<commit_message>
once again, continuing the work of god
</commit_message>
<xml_diff>
--- a/B.Sc. LRT/Grundlagen der Elektrotechnik/images/ETech-Images.pptx
+++ b/B.Sc. LRT/Grundlagen der Elektrotechnik/images/ETech-Images.pptx
@@ -5,11 +5,14 @@
     <p:sldMasterId id="2147483660" r:id="rId1"/>
   </p:sldMasterIdLst>
   <p:notesMasterIdLst>
-    <p:notesMasterId r:id="rId4"/>
+    <p:notesMasterId r:id="rId7"/>
   </p:notesMasterIdLst>
   <p:sldIdLst>
     <p:sldId id="256" r:id="rId2"/>
     <p:sldId id="257" r:id="rId3"/>
+    <p:sldId id="258" r:id="rId4"/>
+    <p:sldId id="259" r:id="rId5"/>
+    <p:sldId id="260" r:id="rId6"/>
   </p:sldIdLst>
   <p:sldSz cx="3600450" cy="3600450"/>
   <p:notesSz cx="6858000" cy="9144000"/>
@@ -198,7 +201,7 @@
           <a:p>
             <a:fld id="{0C596C2D-C72C-406E-B79E-9BAC142DD20E}" type="datetimeFigureOut">
               <a:rPr lang="de-DE" smtClean="0"/>
-              <a:t>28.01.2026</a:t>
+              <a:t>29.01.2026</a:t>
             </a:fld>
             <a:endParaRPr lang="de-DE"/>
           </a:p>
@@ -596,7 +599,7 @@
           <a:p>
             <a:fld id="{6EAE28AA-0912-4DA0-8B30-7F3CA3FE6671}" type="datetimeFigureOut">
               <a:rPr lang="de-DE" smtClean="0"/>
-              <a:t>28.01.2026</a:t>
+              <a:t>29.01.2026</a:t>
             </a:fld>
             <a:endParaRPr lang="de-DE"/>
           </a:p>
@@ -766,7 +769,7 @@
           <a:p>
             <a:fld id="{6EAE28AA-0912-4DA0-8B30-7F3CA3FE6671}" type="datetimeFigureOut">
               <a:rPr lang="de-DE" smtClean="0"/>
-              <a:t>28.01.2026</a:t>
+              <a:t>29.01.2026</a:t>
             </a:fld>
             <a:endParaRPr lang="de-DE"/>
           </a:p>
@@ -946,7 +949,7 @@
           <a:p>
             <a:fld id="{6EAE28AA-0912-4DA0-8B30-7F3CA3FE6671}" type="datetimeFigureOut">
               <a:rPr lang="de-DE" smtClean="0"/>
-              <a:t>28.01.2026</a:t>
+              <a:t>29.01.2026</a:t>
             </a:fld>
             <a:endParaRPr lang="de-DE"/>
           </a:p>
@@ -1116,7 +1119,7 @@
           <a:p>
             <a:fld id="{6EAE28AA-0912-4DA0-8B30-7F3CA3FE6671}" type="datetimeFigureOut">
               <a:rPr lang="de-DE" smtClean="0"/>
-              <a:t>28.01.2026</a:t>
+              <a:t>29.01.2026</a:t>
             </a:fld>
             <a:endParaRPr lang="de-DE"/>
           </a:p>
@@ -1362,7 +1365,7 @@
           <a:p>
             <a:fld id="{6EAE28AA-0912-4DA0-8B30-7F3CA3FE6671}" type="datetimeFigureOut">
               <a:rPr lang="de-DE" smtClean="0"/>
-              <a:t>28.01.2026</a:t>
+              <a:t>29.01.2026</a:t>
             </a:fld>
             <a:endParaRPr lang="de-DE"/>
           </a:p>
@@ -1594,7 +1597,7 @@
           <a:p>
             <a:fld id="{6EAE28AA-0912-4DA0-8B30-7F3CA3FE6671}" type="datetimeFigureOut">
               <a:rPr lang="de-DE" smtClean="0"/>
-              <a:t>28.01.2026</a:t>
+              <a:t>29.01.2026</a:t>
             </a:fld>
             <a:endParaRPr lang="de-DE"/>
           </a:p>
@@ -1961,7 +1964,7 @@
           <a:p>
             <a:fld id="{6EAE28AA-0912-4DA0-8B30-7F3CA3FE6671}" type="datetimeFigureOut">
               <a:rPr lang="de-DE" smtClean="0"/>
-              <a:t>28.01.2026</a:t>
+              <a:t>29.01.2026</a:t>
             </a:fld>
             <a:endParaRPr lang="de-DE"/>
           </a:p>
@@ -2079,7 +2082,7 @@
           <a:p>
             <a:fld id="{6EAE28AA-0912-4DA0-8B30-7F3CA3FE6671}" type="datetimeFigureOut">
               <a:rPr lang="de-DE" smtClean="0"/>
-              <a:t>28.01.2026</a:t>
+              <a:t>29.01.2026</a:t>
             </a:fld>
             <a:endParaRPr lang="de-DE"/>
           </a:p>
@@ -2174,7 +2177,7 @@
           <a:p>
             <a:fld id="{6EAE28AA-0912-4DA0-8B30-7F3CA3FE6671}" type="datetimeFigureOut">
               <a:rPr lang="de-DE" smtClean="0"/>
-              <a:t>28.01.2026</a:t>
+              <a:t>29.01.2026</a:t>
             </a:fld>
             <a:endParaRPr lang="de-DE"/>
           </a:p>
@@ -2451,7 +2454,7 @@
           <a:p>
             <a:fld id="{6EAE28AA-0912-4DA0-8B30-7F3CA3FE6671}" type="datetimeFigureOut">
               <a:rPr lang="de-DE" smtClean="0"/>
-              <a:t>28.01.2026</a:t>
+              <a:t>29.01.2026</a:t>
             </a:fld>
             <a:endParaRPr lang="de-DE"/>
           </a:p>
@@ -2708,7 +2711,7 @@
           <a:p>
             <a:fld id="{6EAE28AA-0912-4DA0-8B30-7F3CA3FE6671}" type="datetimeFigureOut">
               <a:rPr lang="de-DE" smtClean="0"/>
-              <a:t>28.01.2026</a:t>
+              <a:t>29.01.2026</a:t>
             </a:fld>
             <a:endParaRPr lang="de-DE"/>
           </a:p>
@@ -2921,7 +2924,7 @@
           <a:p>
             <a:fld id="{6EAE28AA-0912-4DA0-8B30-7F3CA3FE6671}" type="datetimeFigureOut">
               <a:rPr lang="de-DE" smtClean="0"/>
-              <a:t>28.01.2026</a:t>
+              <a:t>29.01.2026</a:t>
             </a:fld>
             <a:endParaRPr lang="de-DE"/>
           </a:p>
@@ -4832,10 +4835,7 @@
           </a:prstGeom>
           <a:ln cap="rnd">
             <a:solidFill>
-              <a:schemeClr val="tx2">
-                <a:lumMod val="75000"/>
-                <a:lumOff val="25000"/>
-              </a:schemeClr>
+              <a:srgbClr val="086FBD"/>
             </a:solidFill>
             <a:round/>
             <a:tailEnd type="triangle"/>
@@ -4887,10 +4887,7 @@
             <a:r>
               <a:rPr lang="de-DE" sz="1100" i="1" dirty="0">
                 <a:solidFill>
-                  <a:schemeClr val="tx2">
-                    <a:lumMod val="75000"/>
-                    <a:lumOff val="25000"/>
-                  </a:schemeClr>
+                  <a:srgbClr val="086FBD"/>
                 </a:solidFill>
                 <a:latin typeface="CMU Serif" panose="02000603000000000000" pitchFamily="2" charset="0"/>
                 <a:ea typeface="CMU Serif" panose="02000603000000000000" pitchFamily="2" charset="0"/>
@@ -4901,10 +4898,7 @@
             <a:r>
               <a:rPr lang="de-DE" sz="1100" baseline="-25000" dirty="0">
                 <a:solidFill>
-                  <a:schemeClr val="tx2">
-                    <a:lumMod val="75000"/>
-                    <a:lumOff val="25000"/>
-                  </a:schemeClr>
+                  <a:srgbClr val="086FBD"/>
                 </a:solidFill>
                 <a:latin typeface="CMU Serif" panose="02000603000000000000" pitchFamily="2" charset="0"/>
                 <a:ea typeface="CMU Serif" panose="02000603000000000000" pitchFamily="2" charset="0"/>
@@ -4939,10 +4933,7 @@
           </a:prstGeom>
           <a:ln cap="rnd">
             <a:solidFill>
-              <a:schemeClr val="tx2">
-                <a:lumMod val="75000"/>
-                <a:lumOff val="25000"/>
-              </a:schemeClr>
+              <a:srgbClr val="086FBD"/>
             </a:solidFill>
             <a:round/>
             <a:tailEnd type="triangle"/>
@@ -4994,10 +4985,7 @@
             <a:r>
               <a:rPr lang="de-DE" sz="1100" i="1" dirty="0">
                 <a:solidFill>
-                  <a:schemeClr val="tx2">
-                    <a:lumMod val="75000"/>
-                    <a:lumOff val="25000"/>
-                  </a:schemeClr>
+                  <a:srgbClr val="086FBD"/>
                 </a:solidFill>
                 <a:latin typeface="CMU Serif" panose="02000603000000000000" pitchFamily="2" charset="0"/>
                 <a:ea typeface="CMU Serif" panose="02000603000000000000" pitchFamily="2" charset="0"/>
@@ -5008,10 +4996,7 @@
             <a:r>
               <a:rPr lang="de-DE" sz="1100" baseline="-25000" dirty="0">
                 <a:solidFill>
-                  <a:schemeClr val="tx2">
-                    <a:lumMod val="75000"/>
-                    <a:lumOff val="25000"/>
-                  </a:schemeClr>
+                  <a:srgbClr val="086FBD"/>
                 </a:solidFill>
                 <a:latin typeface="CMU Serif" panose="02000603000000000000" pitchFamily="2" charset="0"/>
                 <a:ea typeface="CMU Serif" panose="02000603000000000000" pitchFamily="2" charset="0"/>
@@ -5053,10 +5038,7 @@
             <a:r>
               <a:rPr lang="de-DE" sz="1100" i="1" dirty="0">
                 <a:solidFill>
-                  <a:schemeClr val="tx2">
-                    <a:lumMod val="75000"/>
-                    <a:lumOff val="25000"/>
-                  </a:schemeClr>
+                  <a:srgbClr val="086FBD"/>
                 </a:solidFill>
                 <a:latin typeface="CMU Serif" panose="02000603000000000000" pitchFamily="2" charset="0"/>
                 <a:ea typeface="CMU Serif" panose="02000603000000000000" pitchFamily="2" charset="0"/>
@@ -5067,10 +5049,7 @@
             <a:r>
               <a:rPr lang="de-DE" sz="1100" baseline="-25000" dirty="0">
                 <a:solidFill>
-                  <a:schemeClr val="tx2">
-                    <a:lumMod val="75000"/>
-                    <a:lumOff val="25000"/>
-                  </a:schemeClr>
+                  <a:srgbClr val="086FBD"/>
                 </a:solidFill>
                 <a:latin typeface="CMU Serif" panose="02000603000000000000" pitchFamily="2" charset="0"/>
                 <a:ea typeface="CMU Serif" panose="02000603000000000000" pitchFamily="2" charset="0"/>
@@ -5105,10 +5084,7 @@
           </a:prstGeom>
           <a:ln cap="rnd">
             <a:solidFill>
-              <a:schemeClr val="tx2">
-                <a:lumMod val="75000"/>
-                <a:lumOff val="25000"/>
-              </a:schemeClr>
+              <a:srgbClr val="086FBD"/>
             </a:solidFill>
             <a:round/>
             <a:tailEnd type="triangle"/>
@@ -5153,10 +5129,7 @@
           </a:prstGeom>
           <a:ln cap="rnd">
             <a:solidFill>
-              <a:schemeClr val="tx2">
-                <a:lumMod val="75000"/>
-                <a:lumOff val="25000"/>
-              </a:schemeClr>
+              <a:srgbClr val="086FBD"/>
             </a:solidFill>
             <a:round/>
             <a:tailEnd type="triangle"/>
@@ -5208,10 +5181,7 @@
             <a:r>
               <a:rPr lang="de-DE" sz="1100" i="1" dirty="0">
                 <a:solidFill>
-                  <a:schemeClr val="tx2">
-                    <a:lumMod val="75000"/>
-                    <a:lumOff val="25000"/>
-                  </a:schemeClr>
+                  <a:srgbClr val="086FBD"/>
                 </a:solidFill>
                 <a:latin typeface="CMU Serif" panose="02000603000000000000" pitchFamily="2" charset="0"/>
                 <a:ea typeface="CMU Serif" panose="02000603000000000000" pitchFamily="2" charset="0"/>
@@ -5222,10 +5192,7 @@
             <a:r>
               <a:rPr lang="de-DE" sz="1100" baseline="-25000" dirty="0">
                 <a:solidFill>
-                  <a:schemeClr val="tx2">
-                    <a:lumMod val="75000"/>
-                    <a:lumOff val="25000"/>
-                  </a:schemeClr>
+                  <a:srgbClr val="086FBD"/>
                 </a:solidFill>
                 <a:latin typeface="CMU Serif" panose="02000603000000000000" pitchFamily="2" charset="0"/>
                 <a:ea typeface="CMU Serif" panose="02000603000000000000" pitchFamily="2" charset="0"/>
@@ -5240,6 +5207,3414 @@
     <p:extLst>
       <p:ext uri="{BB962C8B-B14F-4D97-AF65-F5344CB8AC3E}">
         <p14:creationId xmlns:p14="http://schemas.microsoft.com/office/powerpoint/2010/main" val="3333156678"/>
+      </p:ext>
+    </p:extLst>
+  </p:cSld>
+  <p:clrMapOvr>
+    <a:masterClrMapping/>
+  </p:clrMapOvr>
+</p:sld>
+</file>
+
+<file path=ppt/slides/slide3.xml><?xml version="1.0" encoding="utf-8"?>
+<p:sld xmlns:a="http://schemas.openxmlformats.org/drawingml/2006/main" xmlns:r="http://schemas.openxmlformats.org/officeDocument/2006/relationships" xmlns:p="http://schemas.openxmlformats.org/presentationml/2006/main">
+  <p:cSld>
+    <p:spTree>
+      <p:nvGrpSpPr>
+        <p:cNvPr id="1" name=""/>
+        <p:cNvGrpSpPr/>
+        <p:nvPr/>
+      </p:nvGrpSpPr>
+      <p:grpSpPr>
+        <a:xfrm>
+          <a:off x="0" y="0"/>
+          <a:ext cx="0" cy="0"/>
+          <a:chOff x="0" y="0"/>
+          <a:chExt cx="0" cy="0"/>
+        </a:xfrm>
+      </p:grpSpPr>
+      <p:sp>
+        <p:nvSpPr>
+          <p:cNvPr id="4" name="Rechteck 3">
+            <a:extLst>
+              <a:ext uri="{FF2B5EF4-FFF2-40B4-BE49-F238E27FC236}">
+                <a16:creationId xmlns:a16="http://schemas.microsoft.com/office/drawing/2014/main" id="{3E057EA1-E5CF-3541-265D-084B3BC6B0C2}"/>
+              </a:ext>
+            </a:extLst>
+          </p:cNvPr>
+          <p:cNvSpPr/>
+          <p:nvPr/>
+        </p:nvSpPr>
+        <p:spPr>
+          <a:xfrm>
+            <a:off x="980162" y="867427"/>
+            <a:ext cx="895612" cy="1803748"/>
+          </a:xfrm>
+          <a:prstGeom prst="rect">
+            <a:avLst/>
+          </a:prstGeom>
+          <a:noFill/>
+          <a:ln w="15875" cap="rnd">
+            <a:solidFill>
+              <a:schemeClr val="tx1"/>
+            </a:solidFill>
+            <a:round/>
+          </a:ln>
+        </p:spPr>
+        <p:style>
+          <a:lnRef idx="2">
+            <a:schemeClr val="accent1">
+              <a:shade val="15000"/>
+            </a:schemeClr>
+          </a:lnRef>
+          <a:fillRef idx="1">
+            <a:schemeClr val="accent1"/>
+          </a:fillRef>
+          <a:effectRef idx="0">
+            <a:schemeClr val="accent1"/>
+          </a:effectRef>
+          <a:fontRef idx="minor">
+            <a:schemeClr val="lt1"/>
+          </a:fontRef>
+        </p:style>
+        <p:txBody>
+          <a:bodyPr rtlCol="0" anchor="ctr"/>
+          <a:lstStyle/>
+          <a:p>
+            <a:pPr algn="ctr"/>
+            <a:endParaRPr lang="de-DE"/>
+          </a:p>
+        </p:txBody>
+      </p:sp>
+      <p:sp>
+        <p:nvSpPr>
+          <p:cNvPr id="5" name="Rechteck 4">
+            <a:extLst>
+              <a:ext uri="{FF2B5EF4-FFF2-40B4-BE49-F238E27FC236}">
+                <a16:creationId xmlns:a16="http://schemas.microsoft.com/office/drawing/2014/main" id="{178928DA-7BDC-B1B9-54F8-86CB5DFFD5DC}"/>
+              </a:ext>
+            </a:extLst>
+          </p:cNvPr>
+          <p:cNvSpPr/>
+          <p:nvPr/>
+        </p:nvSpPr>
+        <p:spPr>
+          <a:xfrm>
+            <a:off x="1875774" y="1778695"/>
+            <a:ext cx="735903" cy="892479"/>
+          </a:xfrm>
+          <a:prstGeom prst="rect">
+            <a:avLst/>
+          </a:prstGeom>
+          <a:noFill/>
+          <a:ln w="15875" cap="rnd">
+            <a:solidFill>
+              <a:schemeClr val="tx1"/>
+            </a:solidFill>
+            <a:round/>
+          </a:ln>
+        </p:spPr>
+        <p:style>
+          <a:lnRef idx="2">
+            <a:schemeClr val="accent1">
+              <a:shade val="15000"/>
+            </a:schemeClr>
+          </a:lnRef>
+          <a:fillRef idx="1">
+            <a:schemeClr val="accent1"/>
+          </a:fillRef>
+          <a:effectRef idx="0">
+            <a:schemeClr val="accent1"/>
+          </a:effectRef>
+          <a:fontRef idx="minor">
+            <a:schemeClr val="lt1"/>
+          </a:fontRef>
+        </p:style>
+        <p:txBody>
+          <a:bodyPr rtlCol="0" anchor="ctr"/>
+          <a:lstStyle/>
+          <a:p>
+            <a:pPr algn="ctr"/>
+            <a:endParaRPr lang="de-DE"/>
+          </a:p>
+        </p:txBody>
+      </p:sp>
+      <p:sp>
+        <p:nvSpPr>
+          <p:cNvPr id="6" name="Ellipse 5">
+            <a:extLst>
+              <a:ext uri="{FF2B5EF4-FFF2-40B4-BE49-F238E27FC236}">
+                <a16:creationId xmlns:a16="http://schemas.microsoft.com/office/drawing/2014/main" id="{D686A7B4-1A15-6A66-B176-584F0D18DE91}"/>
+              </a:ext>
+            </a:extLst>
+          </p:cNvPr>
+          <p:cNvSpPr/>
+          <p:nvPr/>
+        </p:nvSpPr>
+        <p:spPr>
+          <a:xfrm>
+            <a:off x="1835260" y="1738180"/>
+            <a:ext cx="81028" cy="81028"/>
+          </a:xfrm>
+          <a:prstGeom prst="ellipse">
+            <a:avLst/>
+          </a:prstGeom>
+          <a:solidFill>
+            <a:schemeClr val="tx1"/>
+          </a:solidFill>
+          <a:ln>
+            <a:noFill/>
+          </a:ln>
+        </p:spPr>
+        <p:style>
+          <a:lnRef idx="2">
+            <a:schemeClr val="accent1">
+              <a:shade val="15000"/>
+            </a:schemeClr>
+          </a:lnRef>
+          <a:fillRef idx="1">
+            <a:schemeClr val="accent1"/>
+          </a:fillRef>
+          <a:effectRef idx="0">
+            <a:schemeClr val="accent1"/>
+          </a:effectRef>
+          <a:fontRef idx="minor">
+            <a:schemeClr val="lt1"/>
+          </a:fontRef>
+        </p:style>
+        <p:txBody>
+          <a:bodyPr rtlCol="0" anchor="ctr"/>
+          <a:lstStyle/>
+          <a:p>
+            <a:pPr algn="ctr"/>
+            <a:endParaRPr lang="de-DE">
+              <a:solidFill>
+                <a:sysClr val="windowText" lastClr="000000"/>
+              </a:solidFill>
+            </a:endParaRPr>
+          </a:p>
+        </p:txBody>
+      </p:sp>
+      <p:sp>
+        <p:nvSpPr>
+          <p:cNvPr id="7" name="Ellipse 6">
+            <a:extLst>
+              <a:ext uri="{FF2B5EF4-FFF2-40B4-BE49-F238E27FC236}">
+                <a16:creationId xmlns:a16="http://schemas.microsoft.com/office/drawing/2014/main" id="{81C8E0FC-93A2-0376-96F4-52D43EB98E22}"/>
+              </a:ext>
+            </a:extLst>
+          </p:cNvPr>
+          <p:cNvSpPr/>
+          <p:nvPr/>
+        </p:nvSpPr>
+        <p:spPr>
+          <a:xfrm>
+            <a:off x="1835260" y="2630661"/>
+            <a:ext cx="81028" cy="81028"/>
+          </a:xfrm>
+          <a:prstGeom prst="ellipse">
+            <a:avLst/>
+          </a:prstGeom>
+          <a:solidFill>
+            <a:schemeClr val="tx1"/>
+          </a:solidFill>
+          <a:ln>
+            <a:noFill/>
+          </a:ln>
+        </p:spPr>
+        <p:style>
+          <a:lnRef idx="2">
+            <a:schemeClr val="accent1">
+              <a:shade val="15000"/>
+            </a:schemeClr>
+          </a:lnRef>
+          <a:fillRef idx="1">
+            <a:schemeClr val="accent1"/>
+          </a:fillRef>
+          <a:effectRef idx="0">
+            <a:schemeClr val="accent1"/>
+          </a:effectRef>
+          <a:fontRef idx="minor">
+            <a:schemeClr val="lt1"/>
+          </a:fontRef>
+        </p:style>
+        <p:txBody>
+          <a:bodyPr rtlCol="0" anchor="ctr"/>
+          <a:lstStyle/>
+          <a:p>
+            <a:pPr algn="ctr"/>
+            <a:endParaRPr lang="de-DE">
+              <a:solidFill>
+                <a:sysClr val="windowText" lastClr="000000"/>
+              </a:solidFill>
+            </a:endParaRPr>
+          </a:p>
+        </p:txBody>
+      </p:sp>
+      <p:sp>
+        <p:nvSpPr>
+          <p:cNvPr id="8" name="Ellipse 7">
+            <a:extLst>
+              <a:ext uri="{FF2B5EF4-FFF2-40B4-BE49-F238E27FC236}">
+                <a16:creationId xmlns:a16="http://schemas.microsoft.com/office/drawing/2014/main" id="{0104A22D-F753-DAD2-0AB0-3DE6001403B6}"/>
+              </a:ext>
+            </a:extLst>
+          </p:cNvPr>
+          <p:cNvSpPr/>
+          <p:nvPr/>
+        </p:nvSpPr>
+        <p:spPr>
+          <a:xfrm>
+            <a:off x="2225207" y="1743679"/>
+            <a:ext cx="70030" cy="70030"/>
+          </a:xfrm>
+          <a:prstGeom prst="ellipse">
+            <a:avLst/>
+          </a:prstGeom>
+          <a:solidFill>
+            <a:schemeClr val="bg1"/>
+          </a:solidFill>
+          <a:ln w="12700">
+            <a:solidFill>
+              <a:schemeClr val="tx1"/>
+            </a:solidFill>
+          </a:ln>
+        </p:spPr>
+        <p:style>
+          <a:lnRef idx="2">
+            <a:schemeClr val="accent1">
+              <a:shade val="15000"/>
+            </a:schemeClr>
+          </a:lnRef>
+          <a:fillRef idx="1">
+            <a:schemeClr val="accent1"/>
+          </a:fillRef>
+          <a:effectRef idx="0">
+            <a:schemeClr val="accent1"/>
+          </a:effectRef>
+          <a:fontRef idx="minor">
+            <a:schemeClr val="lt1"/>
+          </a:fontRef>
+        </p:style>
+        <p:txBody>
+          <a:bodyPr rtlCol="0" anchor="ctr"/>
+          <a:lstStyle/>
+          <a:p>
+            <a:pPr algn="ctr"/>
+            <a:endParaRPr lang="de-DE">
+              <a:solidFill>
+                <a:sysClr val="windowText" lastClr="000000"/>
+              </a:solidFill>
+            </a:endParaRPr>
+          </a:p>
+        </p:txBody>
+      </p:sp>
+      <p:sp>
+        <p:nvSpPr>
+          <p:cNvPr id="9" name="Ellipse 8">
+            <a:extLst>
+              <a:ext uri="{FF2B5EF4-FFF2-40B4-BE49-F238E27FC236}">
+                <a16:creationId xmlns:a16="http://schemas.microsoft.com/office/drawing/2014/main" id="{BB6A399D-038D-AE45-0E58-CE504D6EEFE1}"/>
+              </a:ext>
+            </a:extLst>
+          </p:cNvPr>
+          <p:cNvSpPr/>
+          <p:nvPr/>
+        </p:nvSpPr>
+        <p:spPr>
+          <a:xfrm>
+            <a:off x="2225207" y="2636159"/>
+            <a:ext cx="70030" cy="70030"/>
+          </a:xfrm>
+          <a:prstGeom prst="ellipse">
+            <a:avLst/>
+          </a:prstGeom>
+          <a:solidFill>
+            <a:schemeClr val="bg1"/>
+          </a:solidFill>
+          <a:ln w="12700">
+            <a:solidFill>
+              <a:schemeClr val="tx1"/>
+            </a:solidFill>
+          </a:ln>
+        </p:spPr>
+        <p:style>
+          <a:lnRef idx="2">
+            <a:schemeClr val="accent1">
+              <a:shade val="15000"/>
+            </a:schemeClr>
+          </a:lnRef>
+          <a:fillRef idx="1">
+            <a:schemeClr val="accent1"/>
+          </a:fillRef>
+          <a:effectRef idx="0">
+            <a:schemeClr val="accent1"/>
+          </a:effectRef>
+          <a:fontRef idx="minor">
+            <a:schemeClr val="lt1"/>
+          </a:fontRef>
+        </p:style>
+        <p:txBody>
+          <a:bodyPr rtlCol="0" anchor="ctr"/>
+          <a:lstStyle/>
+          <a:p>
+            <a:pPr algn="ctr"/>
+            <a:endParaRPr lang="de-DE">
+              <a:solidFill>
+                <a:sysClr val="windowText" lastClr="000000"/>
+              </a:solidFill>
+            </a:endParaRPr>
+          </a:p>
+        </p:txBody>
+      </p:sp>
+      <p:sp>
+        <p:nvSpPr>
+          <p:cNvPr id="10" name="Rechteck 9">
+            <a:extLst>
+              <a:ext uri="{FF2B5EF4-FFF2-40B4-BE49-F238E27FC236}">
+                <a16:creationId xmlns:a16="http://schemas.microsoft.com/office/drawing/2014/main" id="{EC1F46EB-8CF0-2B19-DC2A-218401FEB93A}"/>
+              </a:ext>
+            </a:extLst>
+          </p:cNvPr>
+          <p:cNvSpPr/>
+          <p:nvPr/>
+        </p:nvSpPr>
+        <p:spPr>
+          <a:xfrm rot="16200000">
+            <a:off x="1708134" y="1243749"/>
+            <a:ext cx="335280" cy="118110"/>
+          </a:xfrm>
+          <a:prstGeom prst="rect">
+            <a:avLst/>
+          </a:prstGeom>
+          <a:solidFill>
+            <a:schemeClr val="bg1"/>
+          </a:solidFill>
+          <a:ln w="15875" cap="rnd">
+            <a:solidFill>
+              <a:schemeClr val="tx1"/>
+            </a:solidFill>
+            <a:round/>
+          </a:ln>
+        </p:spPr>
+        <p:style>
+          <a:lnRef idx="2">
+            <a:schemeClr val="accent1">
+              <a:shade val="15000"/>
+            </a:schemeClr>
+          </a:lnRef>
+          <a:fillRef idx="1">
+            <a:schemeClr val="accent1"/>
+          </a:fillRef>
+          <a:effectRef idx="0">
+            <a:schemeClr val="accent1"/>
+          </a:effectRef>
+          <a:fontRef idx="minor">
+            <a:schemeClr val="lt1"/>
+          </a:fontRef>
+        </p:style>
+        <p:txBody>
+          <a:bodyPr rtlCol="0" anchor="ctr"/>
+          <a:lstStyle/>
+          <a:p>
+            <a:pPr algn="ctr"/>
+            <a:endParaRPr lang="de-DE"/>
+          </a:p>
+        </p:txBody>
+      </p:sp>
+      <p:sp>
+        <p:nvSpPr>
+          <p:cNvPr id="11" name="Rechteck 10">
+            <a:extLst>
+              <a:ext uri="{FF2B5EF4-FFF2-40B4-BE49-F238E27FC236}">
+                <a16:creationId xmlns:a16="http://schemas.microsoft.com/office/drawing/2014/main" id="{62972A03-99EE-88DD-B6C7-E772D9EBF4CD}"/>
+              </a:ext>
+            </a:extLst>
+          </p:cNvPr>
+          <p:cNvSpPr/>
+          <p:nvPr/>
+        </p:nvSpPr>
+        <p:spPr>
+          <a:xfrm rot="16200000">
+            <a:off x="1708134" y="2165879"/>
+            <a:ext cx="335280" cy="118110"/>
+          </a:xfrm>
+          <a:prstGeom prst="rect">
+            <a:avLst/>
+          </a:prstGeom>
+          <a:solidFill>
+            <a:schemeClr val="bg1"/>
+          </a:solidFill>
+          <a:ln w="15875" cap="rnd">
+            <a:solidFill>
+              <a:schemeClr val="tx1"/>
+            </a:solidFill>
+            <a:round/>
+          </a:ln>
+        </p:spPr>
+        <p:style>
+          <a:lnRef idx="2">
+            <a:schemeClr val="accent1">
+              <a:shade val="15000"/>
+            </a:schemeClr>
+          </a:lnRef>
+          <a:fillRef idx="1">
+            <a:schemeClr val="accent1"/>
+          </a:fillRef>
+          <a:effectRef idx="0">
+            <a:schemeClr val="accent1"/>
+          </a:effectRef>
+          <a:fontRef idx="minor">
+            <a:schemeClr val="lt1"/>
+          </a:fontRef>
+        </p:style>
+        <p:txBody>
+          <a:bodyPr rtlCol="0" anchor="ctr"/>
+          <a:lstStyle/>
+          <a:p>
+            <a:pPr algn="ctr"/>
+            <a:endParaRPr lang="de-DE"/>
+          </a:p>
+        </p:txBody>
+      </p:sp>
+      <p:sp>
+        <p:nvSpPr>
+          <p:cNvPr id="12" name="Rechteck 11">
+            <a:extLst>
+              <a:ext uri="{FF2B5EF4-FFF2-40B4-BE49-F238E27FC236}">
+                <a16:creationId xmlns:a16="http://schemas.microsoft.com/office/drawing/2014/main" id="{B7F5359C-0992-EE4F-03EF-45806CC8D5FA}"/>
+              </a:ext>
+            </a:extLst>
+          </p:cNvPr>
+          <p:cNvSpPr/>
+          <p:nvPr/>
+        </p:nvSpPr>
+        <p:spPr>
+          <a:xfrm rot="16200000">
+            <a:off x="2444037" y="2165879"/>
+            <a:ext cx="335280" cy="118110"/>
+          </a:xfrm>
+          <a:prstGeom prst="rect">
+            <a:avLst/>
+          </a:prstGeom>
+          <a:solidFill>
+            <a:schemeClr val="bg1"/>
+          </a:solidFill>
+          <a:ln w="15875" cap="rnd">
+            <a:solidFill>
+              <a:schemeClr val="tx1"/>
+            </a:solidFill>
+            <a:round/>
+          </a:ln>
+        </p:spPr>
+        <p:style>
+          <a:lnRef idx="2">
+            <a:schemeClr val="accent1">
+              <a:shade val="15000"/>
+            </a:schemeClr>
+          </a:lnRef>
+          <a:fillRef idx="1">
+            <a:schemeClr val="accent1"/>
+          </a:fillRef>
+          <a:effectRef idx="0">
+            <a:schemeClr val="accent1"/>
+          </a:effectRef>
+          <a:fontRef idx="minor">
+            <a:schemeClr val="lt1"/>
+          </a:fontRef>
+        </p:style>
+        <p:txBody>
+          <a:bodyPr rtlCol="0" anchor="ctr"/>
+          <a:lstStyle/>
+          <a:p>
+            <a:pPr algn="ctr"/>
+            <a:endParaRPr lang="de-DE"/>
+          </a:p>
+        </p:txBody>
+      </p:sp>
+      <p:sp>
+        <p:nvSpPr>
+          <p:cNvPr id="13" name="Ellipse 12">
+            <a:extLst>
+              <a:ext uri="{FF2B5EF4-FFF2-40B4-BE49-F238E27FC236}">
+                <a16:creationId xmlns:a16="http://schemas.microsoft.com/office/drawing/2014/main" id="{A63F8E24-4192-92D7-F463-FFE9D7573B77}"/>
+              </a:ext>
+            </a:extLst>
+          </p:cNvPr>
+          <p:cNvSpPr/>
+          <p:nvPr/>
+        </p:nvSpPr>
+        <p:spPr>
+          <a:xfrm>
+            <a:off x="865862" y="1664394"/>
+            <a:ext cx="228600" cy="228600"/>
+          </a:xfrm>
+          <a:prstGeom prst="ellipse">
+            <a:avLst/>
+          </a:prstGeom>
+          <a:noFill/>
+          <a:ln w="15875">
+            <a:solidFill>
+              <a:schemeClr val="tx1"/>
+            </a:solidFill>
+          </a:ln>
+        </p:spPr>
+        <p:style>
+          <a:lnRef idx="2">
+            <a:schemeClr val="accent1">
+              <a:shade val="15000"/>
+            </a:schemeClr>
+          </a:lnRef>
+          <a:fillRef idx="1">
+            <a:schemeClr val="accent1"/>
+          </a:fillRef>
+          <a:effectRef idx="0">
+            <a:schemeClr val="accent1"/>
+          </a:effectRef>
+          <a:fontRef idx="minor">
+            <a:schemeClr val="lt1"/>
+          </a:fontRef>
+        </p:style>
+        <p:txBody>
+          <a:bodyPr rtlCol="0" anchor="ctr"/>
+          <a:lstStyle/>
+          <a:p>
+            <a:pPr algn="ctr"/>
+            <a:endParaRPr lang="de-DE"/>
+          </a:p>
+        </p:txBody>
+      </p:sp>
+      <p:cxnSp>
+        <p:nvCxnSpPr>
+          <p:cNvPr id="14" name="Gerade Verbindung mit Pfeil 13">
+            <a:extLst>
+              <a:ext uri="{FF2B5EF4-FFF2-40B4-BE49-F238E27FC236}">
+                <a16:creationId xmlns:a16="http://schemas.microsoft.com/office/drawing/2014/main" id="{7868E458-758E-9B4B-9AE3-914A5A14B5A6}"/>
+              </a:ext>
+            </a:extLst>
+          </p:cNvPr>
+          <p:cNvCxnSpPr>
+            <a:cxnSpLocks/>
+          </p:cNvCxnSpPr>
+          <p:nvPr/>
+        </p:nvCxnSpPr>
+        <p:spPr>
+          <a:xfrm>
+            <a:off x="1153517" y="1517800"/>
+            <a:ext cx="0" cy="565147"/>
+          </a:xfrm>
+          <a:prstGeom prst="straightConnector1">
+            <a:avLst/>
+          </a:prstGeom>
+          <a:ln cap="rnd">
+            <a:solidFill>
+              <a:srgbClr val="086FBD"/>
+            </a:solidFill>
+            <a:round/>
+            <a:tailEnd type="triangle"/>
+          </a:ln>
+        </p:spPr>
+        <p:style>
+          <a:lnRef idx="2">
+            <a:schemeClr val="accent1"/>
+          </a:lnRef>
+          <a:fillRef idx="0">
+            <a:schemeClr val="accent1"/>
+          </a:fillRef>
+          <a:effectRef idx="1">
+            <a:schemeClr val="accent1"/>
+          </a:effectRef>
+          <a:fontRef idx="minor">
+            <a:schemeClr val="tx1"/>
+          </a:fontRef>
+        </p:style>
+      </p:cxnSp>
+      <p:sp>
+        <p:nvSpPr>
+          <p:cNvPr id="15" name="Textfeld 14">
+            <a:extLst>
+              <a:ext uri="{FF2B5EF4-FFF2-40B4-BE49-F238E27FC236}">
+                <a16:creationId xmlns:a16="http://schemas.microsoft.com/office/drawing/2014/main" id="{9FABC065-D538-9CA7-8C79-8A0F19E4A9DB}"/>
+              </a:ext>
+            </a:extLst>
+          </p:cNvPr>
+          <p:cNvSpPr txBox="1"/>
+          <p:nvPr/>
+        </p:nvSpPr>
+        <p:spPr>
+          <a:xfrm>
+            <a:off x="1100490" y="1651059"/>
+            <a:ext cx="341666" cy="261610"/>
+          </a:xfrm>
+          <a:prstGeom prst="rect">
+            <a:avLst/>
+          </a:prstGeom>
+          <a:noFill/>
+        </p:spPr>
+        <p:txBody>
+          <a:bodyPr wrap="square" rtlCol="0">
+            <a:spAutoFit/>
+          </a:bodyPr>
+          <a:lstStyle/>
+          <a:p>
+            <a:r>
+              <a:rPr lang="de-DE" sz="1100" i="1" dirty="0" err="1">
+                <a:solidFill>
+                  <a:srgbClr val="086FBD"/>
+                </a:solidFill>
+                <a:latin typeface="CMU Serif" panose="02000603000000000000" pitchFamily="2" charset="0"/>
+                <a:ea typeface="CMU Serif" panose="02000603000000000000" pitchFamily="2" charset="0"/>
+                <a:cs typeface="CMU Serif" panose="02000603000000000000" pitchFamily="2" charset="0"/>
+              </a:rPr>
+              <a:t>U</a:t>
+            </a:r>
+            <a:r>
+              <a:rPr lang="de-DE" sz="1100" baseline="-25000" dirty="0" err="1">
+                <a:solidFill>
+                  <a:srgbClr val="086FBD"/>
+                </a:solidFill>
+                <a:latin typeface="CMU Serif" panose="02000603000000000000" pitchFamily="2" charset="0"/>
+                <a:ea typeface="CMU Serif" panose="02000603000000000000" pitchFamily="2" charset="0"/>
+                <a:cs typeface="CMU Serif" panose="02000603000000000000" pitchFamily="2" charset="0"/>
+              </a:rPr>
+              <a:t>q</a:t>
+            </a:r>
+            <a:endParaRPr lang="de-DE" sz="1100" baseline="-25000" dirty="0">
+              <a:solidFill>
+                <a:srgbClr val="086FBD"/>
+              </a:solidFill>
+              <a:latin typeface="CMU Serif" panose="02000603000000000000" pitchFamily="2" charset="0"/>
+              <a:ea typeface="CMU Serif" panose="02000603000000000000" pitchFamily="2" charset="0"/>
+              <a:cs typeface="CMU Serif" panose="02000603000000000000" pitchFamily="2" charset="0"/>
+            </a:endParaRPr>
+          </a:p>
+        </p:txBody>
+      </p:sp>
+      <p:cxnSp>
+        <p:nvCxnSpPr>
+          <p:cNvPr id="16" name="Gerade Verbindung mit Pfeil 15">
+            <a:extLst>
+              <a:ext uri="{FF2B5EF4-FFF2-40B4-BE49-F238E27FC236}">
+                <a16:creationId xmlns:a16="http://schemas.microsoft.com/office/drawing/2014/main" id="{8D4FB6DF-2525-4FC9-BC05-B1D3572E27ED}"/>
+              </a:ext>
+            </a:extLst>
+          </p:cNvPr>
+          <p:cNvCxnSpPr/>
+          <p:nvPr/>
+        </p:nvCxnSpPr>
+        <p:spPr>
+          <a:xfrm>
+            <a:off x="1358156" y="867427"/>
+            <a:ext cx="167999" cy="0"/>
+          </a:xfrm>
+          <a:prstGeom prst="straightConnector1">
+            <a:avLst/>
+          </a:prstGeom>
+          <a:ln cap="rnd">
+            <a:solidFill>
+              <a:srgbClr val="FF0000"/>
+            </a:solidFill>
+            <a:round/>
+            <a:tailEnd type="triangle"/>
+          </a:ln>
+        </p:spPr>
+        <p:style>
+          <a:lnRef idx="2">
+            <a:schemeClr val="accent1"/>
+          </a:lnRef>
+          <a:fillRef idx="0">
+            <a:schemeClr val="accent1"/>
+          </a:fillRef>
+          <a:effectRef idx="1">
+            <a:schemeClr val="accent1"/>
+          </a:effectRef>
+          <a:fontRef idx="minor">
+            <a:schemeClr val="tx1"/>
+          </a:fontRef>
+        </p:style>
+      </p:cxnSp>
+      <p:sp>
+        <p:nvSpPr>
+          <p:cNvPr id="17" name="Textfeld 16">
+            <a:extLst>
+              <a:ext uri="{FF2B5EF4-FFF2-40B4-BE49-F238E27FC236}">
+                <a16:creationId xmlns:a16="http://schemas.microsoft.com/office/drawing/2014/main" id="{48A7EB98-7A72-4A16-2EDD-3217024027DA}"/>
+              </a:ext>
+            </a:extLst>
+          </p:cNvPr>
+          <p:cNvSpPr txBox="1"/>
+          <p:nvPr/>
+        </p:nvSpPr>
+        <p:spPr>
+          <a:xfrm>
+            <a:off x="1293951" y="892553"/>
+            <a:ext cx="296407" cy="261610"/>
+          </a:xfrm>
+          <a:prstGeom prst="rect">
+            <a:avLst/>
+          </a:prstGeom>
+          <a:noFill/>
+        </p:spPr>
+        <p:txBody>
+          <a:bodyPr wrap="square" rtlCol="0">
+            <a:spAutoFit/>
+          </a:bodyPr>
+          <a:lstStyle/>
+          <a:p>
+            <a:r>
+              <a:rPr lang="de-DE" sz="1100" i="1" dirty="0">
+                <a:solidFill>
+                  <a:srgbClr val="FF0000"/>
+                </a:solidFill>
+                <a:latin typeface="CMU Serif" panose="02000603000000000000" pitchFamily="2" charset="0"/>
+                <a:ea typeface="CMU Serif" panose="02000603000000000000" pitchFamily="2" charset="0"/>
+                <a:cs typeface="CMU Serif" panose="02000603000000000000" pitchFamily="2" charset="0"/>
+              </a:rPr>
+              <a:t>I</a:t>
+            </a:r>
+            <a:endParaRPr lang="de-DE" sz="1100" baseline="-25000" dirty="0">
+              <a:solidFill>
+                <a:srgbClr val="FF0000"/>
+              </a:solidFill>
+              <a:latin typeface="CMU Serif" panose="02000603000000000000" pitchFamily="2" charset="0"/>
+              <a:ea typeface="CMU Serif" panose="02000603000000000000" pitchFamily="2" charset="0"/>
+              <a:cs typeface="CMU Serif" panose="02000603000000000000" pitchFamily="2" charset="0"/>
+            </a:endParaRPr>
+          </a:p>
+        </p:txBody>
+      </p:sp>
+      <p:sp>
+        <p:nvSpPr>
+          <p:cNvPr id="20" name="Textfeld 19">
+            <a:extLst>
+              <a:ext uri="{FF2B5EF4-FFF2-40B4-BE49-F238E27FC236}">
+                <a16:creationId xmlns:a16="http://schemas.microsoft.com/office/drawing/2014/main" id="{FC0B39A7-A019-20A1-8634-17B91DF2738E}"/>
+              </a:ext>
+            </a:extLst>
+          </p:cNvPr>
+          <p:cNvSpPr txBox="1"/>
+          <p:nvPr/>
+        </p:nvSpPr>
+        <p:spPr>
+          <a:xfrm>
+            <a:off x="1517465" y="1177483"/>
+            <a:ext cx="341666" cy="261610"/>
+          </a:xfrm>
+          <a:prstGeom prst="rect">
+            <a:avLst/>
+          </a:prstGeom>
+          <a:noFill/>
+        </p:spPr>
+        <p:txBody>
+          <a:bodyPr wrap="square" rtlCol="0">
+            <a:spAutoFit/>
+          </a:bodyPr>
+          <a:lstStyle/>
+          <a:p>
+            <a:pPr algn="ctr"/>
+            <a:r>
+              <a:rPr lang="de-DE" sz="1100" i="1" dirty="0">
+                <a:latin typeface="CMU Serif" panose="02000603000000000000" pitchFamily="2" charset="0"/>
+                <a:ea typeface="CMU Serif" panose="02000603000000000000" pitchFamily="2" charset="0"/>
+                <a:cs typeface="CMU Serif" panose="02000603000000000000" pitchFamily="2" charset="0"/>
+              </a:rPr>
+              <a:t>R</a:t>
+            </a:r>
+            <a:r>
+              <a:rPr lang="de-DE" sz="1100" baseline="-25000" dirty="0">
+                <a:latin typeface="CMU Serif" panose="02000603000000000000" pitchFamily="2" charset="0"/>
+                <a:ea typeface="CMU Serif" panose="02000603000000000000" pitchFamily="2" charset="0"/>
+                <a:cs typeface="CMU Serif" panose="02000603000000000000" pitchFamily="2" charset="0"/>
+              </a:rPr>
+              <a:t>i</a:t>
+            </a:r>
+          </a:p>
+        </p:txBody>
+      </p:sp>
+      <p:cxnSp>
+        <p:nvCxnSpPr>
+          <p:cNvPr id="21" name="Gerade Verbindung mit Pfeil 20">
+            <a:extLst>
+              <a:ext uri="{FF2B5EF4-FFF2-40B4-BE49-F238E27FC236}">
+                <a16:creationId xmlns:a16="http://schemas.microsoft.com/office/drawing/2014/main" id="{4C2A2C33-4C59-70DB-B219-56133EE8514E}"/>
+              </a:ext>
+            </a:extLst>
+          </p:cNvPr>
+          <p:cNvCxnSpPr/>
+          <p:nvPr/>
+        </p:nvCxnSpPr>
+        <p:spPr>
+          <a:xfrm>
+            <a:off x="2384623" y="1778695"/>
+            <a:ext cx="167999" cy="0"/>
+          </a:xfrm>
+          <a:prstGeom prst="straightConnector1">
+            <a:avLst/>
+          </a:prstGeom>
+          <a:ln cap="rnd">
+            <a:solidFill>
+              <a:srgbClr val="FF0000"/>
+            </a:solidFill>
+            <a:round/>
+            <a:tailEnd type="triangle"/>
+          </a:ln>
+        </p:spPr>
+        <p:style>
+          <a:lnRef idx="2">
+            <a:schemeClr val="accent1"/>
+          </a:lnRef>
+          <a:fillRef idx="0">
+            <a:schemeClr val="accent1"/>
+          </a:fillRef>
+          <a:effectRef idx="1">
+            <a:schemeClr val="accent1"/>
+          </a:effectRef>
+          <a:fontRef idx="minor">
+            <a:schemeClr val="tx1"/>
+          </a:fontRef>
+        </p:style>
+      </p:cxnSp>
+      <p:sp>
+        <p:nvSpPr>
+          <p:cNvPr id="22" name="Textfeld 21">
+            <a:extLst>
+              <a:ext uri="{FF2B5EF4-FFF2-40B4-BE49-F238E27FC236}">
+                <a16:creationId xmlns:a16="http://schemas.microsoft.com/office/drawing/2014/main" id="{3589E243-4267-B551-6152-74220A838544}"/>
+              </a:ext>
+            </a:extLst>
+          </p:cNvPr>
+          <p:cNvSpPr txBox="1"/>
+          <p:nvPr/>
+        </p:nvSpPr>
+        <p:spPr>
+          <a:xfrm>
+            <a:off x="2315270" y="1479344"/>
+            <a:ext cx="296407" cy="261610"/>
+          </a:xfrm>
+          <a:prstGeom prst="rect">
+            <a:avLst/>
+          </a:prstGeom>
+          <a:noFill/>
+        </p:spPr>
+        <p:txBody>
+          <a:bodyPr wrap="square" rtlCol="0">
+            <a:spAutoFit/>
+          </a:bodyPr>
+          <a:lstStyle/>
+          <a:p>
+            <a:r>
+              <a:rPr lang="de-DE" sz="1100" i="1" dirty="0">
+                <a:solidFill>
+                  <a:srgbClr val="FF0000"/>
+                </a:solidFill>
+                <a:latin typeface="CMU Serif" panose="02000603000000000000" pitchFamily="2" charset="0"/>
+                <a:ea typeface="CMU Serif" panose="02000603000000000000" pitchFamily="2" charset="0"/>
+                <a:cs typeface="CMU Serif" panose="02000603000000000000" pitchFamily="2" charset="0"/>
+              </a:rPr>
+              <a:t>I</a:t>
+            </a:r>
+            <a:r>
+              <a:rPr lang="de-DE" sz="1100" baseline="-25000" dirty="0">
+                <a:solidFill>
+                  <a:srgbClr val="FF0000"/>
+                </a:solidFill>
+                <a:latin typeface="CMU Serif" panose="02000603000000000000" pitchFamily="2" charset="0"/>
+                <a:ea typeface="CMU Serif" panose="02000603000000000000" pitchFamily="2" charset="0"/>
+                <a:cs typeface="CMU Serif" panose="02000603000000000000" pitchFamily="2" charset="0"/>
+              </a:rPr>
+              <a:t>2</a:t>
+            </a:r>
+          </a:p>
+        </p:txBody>
+      </p:sp>
+      <p:cxnSp>
+        <p:nvCxnSpPr>
+          <p:cNvPr id="23" name="Gerade Verbindung mit Pfeil 22">
+            <a:extLst>
+              <a:ext uri="{FF2B5EF4-FFF2-40B4-BE49-F238E27FC236}">
+                <a16:creationId xmlns:a16="http://schemas.microsoft.com/office/drawing/2014/main" id="{A3766466-525F-2C31-259F-30B77BE5EB3C}"/>
+              </a:ext>
+            </a:extLst>
+          </p:cNvPr>
+          <p:cNvCxnSpPr>
+            <a:cxnSpLocks/>
+          </p:cNvCxnSpPr>
+          <p:nvPr/>
+        </p:nvCxnSpPr>
+        <p:spPr>
+          <a:xfrm>
+            <a:off x="1876276" y="1859589"/>
+            <a:ext cx="0" cy="157855"/>
+          </a:xfrm>
+          <a:prstGeom prst="straightConnector1">
+            <a:avLst/>
+          </a:prstGeom>
+          <a:ln cap="rnd">
+            <a:solidFill>
+              <a:srgbClr val="FF0000"/>
+            </a:solidFill>
+            <a:round/>
+            <a:tailEnd type="triangle"/>
+          </a:ln>
+        </p:spPr>
+        <p:style>
+          <a:lnRef idx="2">
+            <a:schemeClr val="accent1"/>
+          </a:lnRef>
+          <a:fillRef idx="0">
+            <a:schemeClr val="accent1"/>
+          </a:fillRef>
+          <a:effectRef idx="1">
+            <a:schemeClr val="accent1"/>
+          </a:effectRef>
+          <a:fontRef idx="minor">
+            <a:schemeClr val="tx1"/>
+          </a:fontRef>
+        </p:style>
+      </p:cxnSp>
+      <p:sp>
+        <p:nvSpPr>
+          <p:cNvPr id="24" name="Textfeld 23">
+            <a:extLst>
+              <a:ext uri="{FF2B5EF4-FFF2-40B4-BE49-F238E27FC236}">
+                <a16:creationId xmlns:a16="http://schemas.microsoft.com/office/drawing/2014/main" id="{90CEF2F2-91E1-90D2-5E73-DFDBFD33CFD7}"/>
+              </a:ext>
+            </a:extLst>
+          </p:cNvPr>
+          <p:cNvSpPr txBox="1"/>
+          <p:nvPr/>
+        </p:nvSpPr>
+        <p:spPr>
+          <a:xfrm>
+            <a:off x="1579116" y="1795683"/>
+            <a:ext cx="296407" cy="261610"/>
+          </a:xfrm>
+          <a:prstGeom prst="rect">
+            <a:avLst/>
+          </a:prstGeom>
+          <a:noFill/>
+        </p:spPr>
+        <p:txBody>
+          <a:bodyPr wrap="square" rtlCol="0">
+            <a:spAutoFit/>
+          </a:bodyPr>
+          <a:lstStyle/>
+          <a:p>
+            <a:r>
+              <a:rPr lang="de-DE" sz="1100" i="1" dirty="0">
+                <a:solidFill>
+                  <a:srgbClr val="FF0000"/>
+                </a:solidFill>
+                <a:latin typeface="CMU Serif" panose="02000603000000000000" pitchFamily="2" charset="0"/>
+                <a:ea typeface="CMU Serif" panose="02000603000000000000" pitchFamily="2" charset="0"/>
+                <a:cs typeface="CMU Serif" panose="02000603000000000000" pitchFamily="2" charset="0"/>
+              </a:rPr>
+              <a:t>I</a:t>
+            </a:r>
+            <a:r>
+              <a:rPr lang="de-DE" sz="1100" baseline="-25000" dirty="0">
+                <a:solidFill>
+                  <a:srgbClr val="FF0000"/>
+                </a:solidFill>
+                <a:latin typeface="CMU Serif" panose="02000603000000000000" pitchFamily="2" charset="0"/>
+                <a:ea typeface="CMU Serif" panose="02000603000000000000" pitchFamily="2" charset="0"/>
+                <a:cs typeface="CMU Serif" panose="02000603000000000000" pitchFamily="2" charset="0"/>
+              </a:rPr>
+              <a:t>1</a:t>
+            </a:r>
+          </a:p>
+        </p:txBody>
+      </p:sp>
+      <p:sp>
+        <p:nvSpPr>
+          <p:cNvPr id="26" name="Textfeld 25">
+            <a:extLst>
+              <a:ext uri="{FF2B5EF4-FFF2-40B4-BE49-F238E27FC236}">
+                <a16:creationId xmlns:a16="http://schemas.microsoft.com/office/drawing/2014/main" id="{26527C2F-70F0-A612-918C-B3D53D89BB9D}"/>
+              </a:ext>
+            </a:extLst>
+          </p:cNvPr>
+          <p:cNvSpPr txBox="1"/>
+          <p:nvPr/>
+        </p:nvSpPr>
+        <p:spPr>
+          <a:xfrm>
+            <a:off x="1517465" y="2094128"/>
+            <a:ext cx="341666" cy="261610"/>
+          </a:xfrm>
+          <a:prstGeom prst="rect">
+            <a:avLst/>
+          </a:prstGeom>
+          <a:noFill/>
+        </p:spPr>
+        <p:txBody>
+          <a:bodyPr wrap="square" rtlCol="0">
+            <a:spAutoFit/>
+          </a:bodyPr>
+          <a:lstStyle/>
+          <a:p>
+            <a:pPr algn="ctr"/>
+            <a:r>
+              <a:rPr lang="de-DE" sz="1100" i="1" dirty="0">
+                <a:latin typeface="CMU Serif" panose="02000603000000000000" pitchFamily="2" charset="0"/>
+                <a:ea typeface="CMU Serif" panose="02000603000000000000" pitchFamily="2" charset="0"/>
+                <a:cs typeface="CMU Serif" panose="02000603000000000000" pitchFamily="2" charset="0"/>
+              </a:rPr>
+              <a:t>R</a:t>
+            </a:r>
+            <a:r>
+              <a:rPr lang="de-DE" sz="1100" baseline="-25000" dirty="0">
+                <a:latin typeface="CMU Serif" panose="02000603000000000000" pitchFamily="2" charset="0"/>
+                <a:ea typeface="CMU Serif" panose="02000603000000000000" pitchFamily="2" charset="0"/>
+                <a:cs typeface="CMU Serif" panose="02000603000000000000" pitchFamily="2" charset="0"/>
+              </a:rPr>
+              <a:t>1</a:t>
+            </a:r>
+          </a:p>
+        </p:txBody>
+      </p:sp>
+      <p:sp>
+        <p:nvSpPr>
+          <p:cNvPr id="27" name="Textfeld 26">
+            <a:extLst>
+              <a:ext uri="{FF2B5EF4-FFF2-40B4-BE49-F238E27FC236}">
+                <a16:creationId xmlns:a16="http://schemas.microsoft.com/office/drawing/2014/main" id="{01FD6ACF-6D45-4261-82A4-C38A2595DF3A}"/>
+              </a:ext>
+            </a:extLst>
+          </p:cNvPr>
+          <p:cNvSpPr txBox="1"/>
+          <p:nvPr/>
+        </p:nvSpPr>
+        <p:spPr>
+          <a:xfrm>
+            <a:off x="2254771" y="2094128"/>
+            <a:ext cx="341666" cy="261610"/>
+          </a:xfrm>
+          <a:prstGeom prst="rect">
+            <a:avLst/>
+          </a:prstGeom>
+          <a:noFill/>
+        </p:spPr>
+        <p:txBody>
+          <a:bodyPr wrap="square" rtlCol="0">
+            <a:spAutoFit/>
+          </a:bodyPr>
+          <a:lstStyle/>
+          <a:p>
+            <a:pPr algn="ctr"/>
+            <a:r>
+              <a:rPr lang="de-DE" sz="1100" i="1" dirty="0">
+                <a:latin typeface="CMU Serif" panose="02000603000000000000" pitchFamily="2" charset="0"/>
+                <a:ea typeface="CMU Serif" panose="02000603000000000000" pitchFamily="2" charset="0"/>
+                <a:cs typeface="CMU Serif" panose="02000603000000000000" pitchFamily="2" charset="0"/>
+              </a:rPr>
+              <a:t>R</a:t>
+            </a:r>
+            <a:endParaRPr lang="de-DE" sz="1100" baseline="-25000" dirty="0">
+              <a:latin typeface="CMU Serif" panose="02000603000000000000" pitchFamily="2" charset="0"/>
+              <a:ea typeface="CMU Serif" panose="02000603000000000000" pitchFamily="2" charset="0"/>
+              <a:cs typeface="CMU Serif" panose="02000603000000000000" pitchFamily="2" charset="0"/>
+            </a:endParaRPr>
+          </a:p>
+        </p:txBody>
+      </p:sp>
+      <p:sp>
+        <p:nvSpPr>
+          <p:cNvPr id="28" name="Textfeld 27">
+            <a:extLst>
+              <a:ext uri="{FF2B5EF4-FFF2-40B4-BE49-F238E27FC236}">
+                <a16:creationId xmlns:a16="http://schemas.microsoft.com/office/drawing/2014/main" id="{E9AE8096-AD6F-F4CC-0A21-D6ECBFAA1D37}"/>
+              </a:ext>
+            </a:extLst>
+          </p:cNvPr>
+          <p:cNvSpPr txBox="1"/>
+          <p:nvPr/>
+        </p:nvSpPr>
+        <p:spPr>
+          <a:xfrm>
+            <a:off x="2089339" y="1533589"/>
+            <a:ext cx="341666" cy="261610"/>
+          </a:xfrm>
+          <a:prstGeom prst="rect">
+            <a:avLst/>
+          </a:prstGeom>
+          <a:noFill/>
+        </p:spPr>
+        <p:txBody>
+          <a:bodyPr wrap="square" rtlCol="0">
+            <a:spAutoFit/>
+          </a:bodyPr>
+          <a:lstStyle/>
+          <a:p>
+            <a:pPr algn="ctr"/>
+            <a:r>
+              <a:rPr lang="de-DE" sz="1100" dirty="0">
+                <a:latin typeface="CMU Serif" panose="02000603000000000000" pitchFamily="2" charset="0"/>
+                <a:ea typeface="CMU Serif" panose="02000603000000000000" pitchFamily="2" charset="0"/>
+                <a:cs typeface="CMU Serif" panose="02000603000000000000" pitchFamily="2" charset="0"/>
+              </a:rPr>
+              <a:t>1</a:t>
+            </a:r>
+            <a:endParaRPr lang="de-DE" sz="1100" baseline="-25000" dirty="0">
+              <a:latin typeface="CMU Serif" panose="02000603000000000000" pitchFamily="2" charset="0"/>
+              <a:ea typeface="CMU Serif" panose="02000603000000000000" pitchFamily="2" charset="0"/>
+              <a:cs typeface="CMU Serif" panose="02000603000000000000" pitchFamily="2" charset="0"/>
+            </a:endParaRPr>
+          </a:p>
+        </p:txBody>
+      </p:sp>
+      <p:sp>
+        <p:nvSpPr>
+          <p:cNvPr id="29" name="Textfeld 28">
+            <a:extLst>
+              <a:ext uri="{FF2B5EF4-FFF2-40B4-BE49-F238E27FC236}">
+                <a16:creationId xmlns:a16="http://schemas.microsoft.com/office/drawing/2014/main" id="{0FF0D137-E45A-B99D-7745-A0D5252075D9}"/>
+              </a:ext>
+            </a:extLst>
+          </p:cNvPr>
+          <p:cNvSpPr txBox="1"/>
+          <p:nvPr/>
+        </p:nvSpPr>
+        <p:spPr>
+          <a:xfrm>
+            <a:off x="2089339" y="2427072"/>
+            <a:ext cx="341666" cy="261610"/>
+          </a:xfrm>
+          <a:prstGeom prst="rect">
+            <a:avLst/>
+          </a:prstGeom>
+          <a:noFill/>
+        </p:spPr>
+        <p:txBody>
+          <a:bodyPr wrap="square" rtlCol="0">
+            <a:spAutoFit/>
+          </a:bodyPr>
+          <a:lstStyle/>
+          <a:p>
+            <a:pPr algn="ctr"/>
+            <a:r>
+              <a:rPr lang="de-DE" sz="1100" dirty="0">
+                <a:latin typeface="CMU Serif" panose="02000603000000000000" pitchFamily="2" charset="0"/>
+                <a:ea typeface="CMU Serif" panose="02000603000000000000" pitchFamily="2" charset="0"/>
+                <a:cs typeface="CMU Serif" panose="02000603000000000000" pitchFamily="2" charset="0"/>
+              </a:rPr>
+              <a:t>2</a:t>
+            </a:r>
+            <a:endParaRPr lang="de-DE" sz="1100" baseline="-25000" dirty="0">
+              <a:latin typeface="CMU Serif" panose="02000603000000000000" pitchFamily="2" charset="0"/>
+              <a:ea typeface="CMU Serif" panose="02000603000000000000" pitchFamily="2" charset="0"/>
+              <a:cs typeface="CMU Serif" panose="02000603000000000000" pitchFamily="2" charset="0"/>
+            </a:endParaRPr>
+          </a:p>
+        </p:txBody>
+      </p:sp>
+    </p:spTree>
+    <p:extLst>
+      <p:ext uri="{BB962C8B-B14F-4D97-AF65-F5344CB8AC3E}">
+        <p14:creationId xmlns:p14="http://schemas.microsoft.com/office/powerpoint/2010/main" val="2210989432"/>
+      </p:ext>
+    </p:extLst>
+  </p:cSld>
+  <p:clrMapOvr>
+    <a:masterClrMapping/>
+  </p:clrMapOvr>
+</p:sld>
+</file>
+
+<file path=ppt/slides/slide4.xml><?xml version="1.0" encoding="utf-8"?>
+<p:sld xmlns:a="http://schemas.openxmlformats.org/drawingml/2006/main" xmlns:r="http://schemas.openxmlformats.org/officeDocument/2006/relationships" xmlns:p="http://schemas.openxmlformats.org/presentationml/2006/main">
+  <p:cSld>
+    <p:spTree>
+      <p:nvGrpSpPr>
+        <p:cNvPr id="1" name="">
+          <a:extLst>
+            <a:ext uri="{FF2B5EF4-FFF2-40B4-BE49-F238E27FC236}">
+              <a16:creationId xmlns:a16="http://schemas.microsoft.com/office/drawing/2014/main" id="{42A93180-0DE8-2D3F-85B0-2B3E5D661E93}"/>
+            </a:ext>
+          </a:extLst>
+        </p:cNvPr>
+        <p:cNvGrpSpPr/>
+        <p:nvPr/>
+      </p:nvGrpSpPr>
+      <p:grpSpPr>
+        <a:xfrm>
+          <a:off x="0" y="0"/>
+          <a:ext cx="0" cy="0"/>
+          <a:chOff x="0" y="0"/>
+          <a:chExt cx="0" cy="0"/>
+        </a:xfrm>
+      </p:grpSpPr>
+      <p:sp>
+        <p:nvSpPr>
+          <p:cNvPr id="4" name="Rechteck 3">
+            <a:extLst>
+              <a:ext uri="{FF2B5EF4-FFF2-40B4-BE49-F238E27FC236}">
+                <a16:creationId xmlns:a16="http://schemas.microsoft.com/office/drawing/2014/main" id="{EC26DCF5-6F09-ACCD-47C5-0B0C2894F5CD}"/>
+              </a:ext>
+            </a:extLst>
+          </p:cNvPr>
+          <p:cNvSpPr/>
+          <p:nvPr/>
+        </p:nvSpPr>
+        <p:spPr>
+          <a:xfrm>
+            <a:off x="1096035" y="867427"/>
+            <a:ext cx="895612" cy="1803748"/>
+          </a:xfrm>
+          <a:prstGeom prst="rect">
+            <a:avLst/>
+          </a:prstGeom>
+          <a:noFill/>
+          <a:ln w="15875" cap="rnd">
+            <a:solidFill>
+              <a:schemeClr val="tx1"/>
+            </a:solidFill>
+            <a:round/>
+          </a:ln>
+        </p:spPr>
+        <p:style>
+          <a:lnRef idx="2">
+            <a:schemeClr val="accent1">
+              <a:shade val="15000"/>
+            </a:schemeClr>
+          </a:lnRef>
+          <a:fillRef idx="1">
+            <a:schemeClr val="accent1"/>
+          </a:fillRef>
+          <a:effectRef idx="0">
+            <a:schemeClr val="accent1"/>
+          </a:effectRef>
+          <a:fontRef idx="minor">
+            <a:schemeClr val="lt1"/>
+          </a:fontRef>
+        </p:style>
+        <p:txBody>
+          <a:bodyPr rtlCol="0" anchor="ctr"/>
+          <a:lstStyle/>
+          <a:p>
+            <a:pPr algn="ctr"/>
+            <a:endParaRPr lang="de-DE"/>
+          </a:p>
+        </p:txBody>
+      </p:sp>
+      <p:sp>
+        <p:nvSpPr>
+          <p:cNvPr id="5" name="Rechteck 4">
+            <a:extLst>
+              <a:ext uri="{FF2B5EF4-FFF2-40B4-BE49-F238E27FC236}">
+                <a16:creationId xmlns:a16="http://schemas.microsoft.com/office/drawing/2014/main" id="{2CCAFFB4-D097-C21D-ABAF-5956BBC8DFF7}"/>
+              </a:ext>
+            </a:extLst>
+          </p:cNvPr>
+          <p:cNvSpPr/>
+          <p:nvPr/>
+        </p:nvSpPr>
+        <p:spPr>
+          <a:xfrm>
+            <a:off x="1991647" y="1778695"/>
+            <a:ext cx="735903" cy="892479"/>
+          </a:xfrm>
+          <a:prstGeom prst="rect">
+            <a:avLst/>
+          </a:prstGeom>
+          <a:noFill/>
+          <a:ln w="15875" cap="rnd">
+            <a:solidFill>
+              <a:schemeClr val="tx1"/>
+            </a:solidFill>
+            <a:round/>
+          </a:ln>
+        </p:spPr>
+        <p:style>
+          <a:lnRef idx="2">
+            <a:schemeClr val="accent1">
+              <a:shade val="15000"/>
+            </a:schemeClr>
+          </a:lnRef>
+          <a:fillRef idx="1">
+            <a:schemeClr val="accent1"/>
+          </a:fillRef>
+          <a:effectRef idx="0">
+            <a:schemeClr val="accent1"/>
+          </a:effectRef>
+          <a:fontRef idx="minor">
+            <a:schemeClr val="lt1"/>
+          </a:fontRef>
+        </p:style>
+        <p:txBody>
+          <a:bodyPr rtlCol="0" anchor="ctr"/>
+          <a:lstStyle/>
+          <a:p>
+            <a:pPr algn="ctr"/>
+            <a:endParaRPr lang="de-DE"/>
+          </a:p>
+        </p:txBody>
+      </p:sp>
+      <p:sp>
+        <p:nvSpPr>
+          <p:cNvPr id="6" name="Ellipse 5">
+            <a:extLst>
+              <a:ext uri="{FF2B5EF4-FFF2-40B4-BE49-F238E27FC236}">
+                <a16:creationId xmlns:a16="http://schemas.microsoft.com/office/drawing/2014/main" id="{215007E6-3C24-9B92-99FF-A3E333D07E24}"/>
+              </a:ext>
+            </a:extLst>
+          </p:cNvPr>
+          <p:cNvSpPr/>
+          <p:nvPr/>
+        </p:nvSpPr>
+        <p:spPr>
+          <a:xfrm>
+            <a:off x="1951133" y="1738180"/>
+            <a:ext cx="81028" cy="81028"/>
+          </a:xfrm>
+          <a:prstGeom prst="ellipse">
+            <a:avLst/>
+          </a:prstGeom>
+          <a:solidFill>
+            <a:schemeClr val="tx1"/>
+          </a:solidFill>
+          <a:ln>
+            <a:noFill/>
+          </a:ln>
+        </p:spPr>
+        <p:style>
+          <a:lnRef idx="2">
+            <a:schemeClr val="accent1">
+              <a:shade val="15000"/>
+            </a:schemeClr>
+          </a:lnRef>
+          <a:fillRef idx="1">
+            <a:schemeClr val="accent1"/>
+          </a:fillRef>
+          <a:effectRef idx="0">
+            <a:schemeClr val="accent1"/>
+          </a:effectRef>
+          <a:fontRef idx="minor">
+            <a:schemeClr val="lt1"/>
+          </a:fontRef>
+        </p:style>
+        <p:txBody>
+          <a:bodyPr rtlCol="0" anchor="ctr"/>
+          <a:lstStyle/>
+          <a:p>
+            <a:pPr algn="ctr"/>
+            <a:endParaRPr lang="de-DE">
+              <a:solidFill>
+                <a:sysClr val="windowText" lastClr="000000"/>
+              </a:solidFill>
+            </a:endParaRPr>
+          </a:p>
+        </p:txBody>
+      </p:sp>
+      <p:sp>
+        <p:nvSpPr>
+          <p:cNvPr id="7" name="Ellipse 6">
+            <a:extLst>
+              <a:ext uri="{FF2B5EF4-FFF2-40B4-BE49-F238E27FC236}">
+                <a16:creationId xmlns:a16="http://schemas.microsoft.com/office/drawing/2014/main" id="{BE9FE3FC-7002-70D2-BBBB-DED824DA0E89}"/>
+              </a:ext>
+            </a:extLst>
+          </p:cNvPr>
+          <p:cNvSpPr/>
+          <p:nvPr/>
+        </p:nvSpPr>
+        <p:spPr>
+          <a:xfrm>
+            <a:off x="1951133" y="2630661"/>
+            <a:ext cx="81028" cy="81028"/>
+          </a:xfrm>
+          <a:prstGeom prst="ellipse">
+            <a:avLst/>
+          </a:prstGeom>
+          <a:solidFill>
+            <a:schemeClr val="tx1"/>
+          </a:solidFill>
+          <a:ln>
+            <a:noFill/>
+          </a:ln>
+        </p:spPr>
+        <p:style>
+          <a:lnRef idx="2">
+            <a:schemeClr val="accent1">
+              <a:shade val="15000"/>
+            </a:schemeClr>
+          </a:lnRef>
+          <a:fillRef idx="1">
+            <a:schemeClr val="accent1"/>
+          </a:fillRef>
+          <a:effectRef idx="0">
+            <a:schemeClr val="accent1"/>
+          </a:effectRef>
+          <a:fontRef idx="minor">
+            <a:schemeClr val="lt1"/>
+          </a:fontRef>
+        </p:style>
+        <p:txBody>
+          <a:bodyPr rtlCol="0" anchor="ctr"/>
+          <a:lstStyle/>
+          <a:p>
+            <a:pPr algn="ctr"/>
+            <a:endParaRPr lang="de-DE">
+              <a:solidFill>
+                <a:sysClr val="windowText" lastClr="000000"/>
+              </a:solidFill>
+            </a:endParaRPr>
+          </a:p>
+        </p:txBody>
+      </p:sp>
+      <p:sp>
+        <p:nvSpPr>
+          <p:cNvPr id="10" name="Rechteck 9">
+            <a:extLst>
+              <a:ext uri="{FF2B5EF4-FFF2-40B4-BE49-F238E27FC236}">
+                <a16:creationId xmlns:a16="http://schemas.microsoft.com/office/drawing/2014/main" id="{28602033-4A6D-A3FA-4390-73F7E19C3E5B}"/>
+              </a:ext>
+            </a:extLst>
+          </p:cNvPr>
+          <p:cNvSpPr/>
+          <p:nvPr/>
+        </p:nvSpPr>
+        <p:spPr>
+          <a:xfrm rot="16200000">
+            <a:off x="1824007" y="1243749"/>
+            <a:ext cx="335280" cy="118110"/>
+          </a:xfrm>
+          <a:prstGeom prst="rect">
+            <a:avLst/>
+          </a:prstGeom>
+          <a:solidFill>
+            <a:schemeClr val="bg1"/>
+          </a:solidFill>
+          <a:ln w="15875" cap="rnd">
+            <a:solidFill>
+              <a:schemeClr val="tx1"/>
+            </a:solidFill>
+            <a:round/>
+          </a:ln>
+        </p:spPr>
+        <p:style>
+          <a:lnRef idx="2">
+            <a:schemeClr val="accent1">
+              <a:shade val="15000"/>
+            </a:schemeClr>
+          </a:lnRef>
+          <a:fillRef idx="1">
+            <a:schemeClr val="accent1"/>
+          </a:fillRef>
+          <a:effectRef idx="0">
+            <a:schemeClr val="accent1"/>
+          </a:effectRef>
+          <a:fontRef idx="minor">
+            <a:schemeClr val="lt1"/>
+          </a:fontRef>
+        </p:style>
+        <p:txBody>
+          <a:bodyPr rtlCol="0" anchor="ctr"/>
+          <a:lstStyle/>
+          <a:p>
+            <a:pPr algn="ctr"/>
+            <a:endParaRPr lang="de-DE"/>
+          </a:p>
+        </p:txBody>
+      </p:sp>
+      <p:sp>
+        <p:nvSpPr>
+          <p:cNvPr id="11" name="Rechteck 10">
+            <a:extLst>
+              <a:ext uri="{FF2B5EF4-FFF2-40B4-BE49-F238E27FC236}">
+                <a16:creationId xmlns:a16="http://schemas.microsoft.com/office/drawing/2014/main" id="{33887E9A-A9B3-E710-8EB2-39D739F725DC}"/>
+              </a:ext>
+            </a:extLst>
+          </p:cNvPr>
+          <p:cNvSpPr/>
+          <p:nvPr/>
+        </p:nvSpPr>
+        <p:spPr>
+          <a:xfrm rot="16200000">
+            <a:off x="1824007" y="2165879"/>
+            <a:ext cx="335280" cy="118110"/>
+          </a:xfrm>
+          <a:prstGeom prst="rect">
+            <a:avLst/>
+          </a:prstGeom>
+          <a:solidFill>
+            <a:schemeClr val="bg1"/>
+          </a:solidFill>
+          <a:ln w="15875" cap="rnd">
+            <a:solidFill>
+              <a:schemeClr val="tx1"/>
+            </a:solidFill>
+            <a:round/>
+          </a:ln>
+        </p:spPr>
+        <p:style>
+          <a:lnRef idx="2">
+            <a:schemeClr val="accent1">
+              <a:shade val="15000"/>
+            </a:schemeClr>
+          </a:lnRef>
+          <a:fillRef idx="1">
+            <a:schemeClr val="accent1"/>
+          </a:fillRef>
+          <a:effectRef idx="0">
+            <a:schemeClr val="accent1"/>
+          </a:effectRef>
+          <a:fontRef idx="minor">
+            <a:schemeClr val="lt1"/>
+          </a:fontRef>
+        </p:style>
+        <p:txBody>
+          <a:bodyPr rtlCol="0" anchor="ctr"/>
+          <a:lstStyle/>
+          <a:p>
+            <a:pPr algn="ctr"/>
+            <a:endParaRPr lang="de-DE"/>
+          </a:p>
+        </p:txBody>
+      </p:sp>
+      <p:sp>
+        <p:nvSpPr>
+          <p:cNvPr id="12" name="Rechteck 11">
+            <a:extLst>
+              <a:ext uri="{FF2B5EF4-FFF2-40B4-BE49-F238E27FC236}">
+                <a16:creationId xmlns:a16="http://schemas.microsoft.com/office/drawing/2014/main" id="{799670D9-3C38-8A83-D639-16F028C0782C}"/>
+              </a:ext>
+            </a:extLst>
+          </p:cNvPr>
+          <p:cNvSpPr/>
+          <p:nvPr/>
+        </p:nvSpPr>
+        <p:spPr>
+          <a:xfrm rot="16200000">
+            <a:off x="2112555" y="2036733"/>
+            <a:ext cx="968008" cy="370899"/>
+          </a:xfrm>
+          <a:prstGeom prst="rect">
+            <a:avLst/>
+          </a:prstGeom>
+          <a:solidFill>
+            <a:schemeClr val="bg1"/>
+          </a:solidFill>
+          <a:ln w="15875" cap="rnd">
+            <a:noFill/>
+            <a:round/>
+          </a:ln>
+        </p:spPr>
+        <p:style>
+          <a:lnRef idx="2">
+            <a:schemeClr val="accent1">
+              <a:shade val="15000"/>
+            </a:schemeClr>
+          </a:lnRef>
+          <a:fillRef idx="1">
+            <a:schemeClr val="accent1"/>
+          </a:fillRef>
+          <a:effectRef idx="0">
+            <a:schemeClr val="accent1"/>
+          </a:effectRef>
+          <a:fontRef idx="minor">
+            <a:schemeClr val="lt1"/>
+          </a:fontRef>
+        </p:style>
+        <p:txBody>
+          <a:bodyPr rtlCol="0" anchor="ctr"/>
+          <a:lstStyle/>
+          <a:p>
+            <a:pPr algn="ctr"/>
+            <a:endParaRPr lang="de-DE"/>
+          </a:p>
+        </p:txBody>
+      </p:sp>
+      <p:sp>
+        <p:nvSpPr>
+          <p:cNvPr id="13" name="Ellipse 12">
+            <a:extLst>
+              <a:ext uri="{FF2B5EF4-FFF2-40B4-BE49-F238E27FC236}">
+                <a16:creationId xmlns:a16="http://schemas.microsoft.com/office/drawing/2014/main" id="{E2D47FA6-0C95-47D8-CDCF-052FB93DACAA}"/>
+              </a:ext>
+            </a:extLst>
+          </p:cNvPr>
+          <p:cNvSpPr/>
+          <p:nvPr/>
+        </p:nvSpPr>
+        <p:spPr>
+          <a:xfrm>
+            <a:off x="981735" y="1664394"/>
+            <a:ext cx="228600" cy="228600"/>
+          </a:xfrm>
+          <a:prstGeom prst="ellipse">
+            <a:avLst/>
+          </a:prstGeom>
+          <a:noFill/>
+          <a:ln w="15875">
+            <a:solidFill>
+              <a:schemeClr val="tx1"/>
+            </a:solidFill>
+          </a:ln>
+        </p:spPr>
+        <p:style>
+          <a:lnRef idx="2">
+            <a:schemeClr val="accent1">
+              <a:shade val="15000"/>
+            </a:schemeClr>
+          </a:lnRef>
+          <a:fillRef idx="1">
+            <a:schemeClr val="accent1"/>
+          </a:fillRef>
+          <a:effectRef idx="0">
+            <a:schemeClr val="accent1"/>
+          </a:effectRef>
+          <a:fontRef idx="minor">
+            <a:schemeClr val="lt1"/>
+          </a:fontRef>
+        </p:style>
+        <p:txBody>
+          <a:bodyPr rtlCol="0" anchor="ctr"/>
+          <a:lstStyle/>
+          <a:p>
+            <a:pPr algn="ctr"/>
+            <a:endParaRPr lang="de-DE"/>
+          </a:p>
+        </p:txBody>
+      </p:sp>
+      <p:cxnSp>
+        <p:nvCxnSpPr>
+          <p:cNvPr id="14" name="Gerade Verbindung mit Pfeil 13">
+            <a:extLst>
+              <a:ext uri="{FF2B5EF4-FFF2-40B4-BE49-F238E27FC236}">
+                <a16:creationId xmlns:a16="http://schemas.microsoft.com/office/drawing/2014/main" id="{5F243993-4FED-2C24-6D02-31E23C2B6DE4}"/>
+              </a:ext>
+            </a:extLst>
+          </p:cNvPr>
+          <p:cNvCxnSpPr>
+            <a:cxnSpLocks/>
+          </p:cNvCxnSpPr>
+          <p:nvPr/>
+        </p:nvCxnSpPr>
+        <p:spPr>
+          <a:xfrm>
+            <a:off x="1269390" y="1517800"/>
+            <a:ext cx="0" cy="565147"/>
+          </a:xfrm>
+          <a:prstGeom prst="straightConnector1">
+            <a:avLst/>
+          </a:prstGeom>
+          <a:ln cap="rnd">
+            <a:solidFill>
+              <a:srgbClr val="086FBD"/>
+            </a:solidFill>
+            <a:round/>
+            <a:tailEnd type="triangle"/>
+          </a:ln>
+        </p:spPr>
+        <p:style>
+          <a:lnRef idx="2">
+            <a:schemeClr val="accent1"/>
+          </a:lnRef>
+          <a:fillRef idx="0">
+            <a:schemeClr val="accent1"/>
+          </a:fillRef>
+          <a:effectRef idx="1">
+            <a:schemeClr val="accent1"/>
+          </a:effectRef>
+          <a:fontRef idx="minor">
+            <a:schemeClr val="tx1"/>
+          </a:fontRef>
+        </p:style>
+      </p:cxnSp>
+      <p:sp>
+        <p:nvSpPr>
+          <p:cNvPr id="15" name="Textfeld 14">
+            <a:extLst>
+              <a:ext uri="{FF2B5EF4-FFF2-40B4-BE49-F238E27FC236}">
+                <a16:creationId xmlns:a16="http://schemas.microsoft.com/office/drawing/2014/main" id="{2F861A83-F8C5-9CCC-75D3-A27446323ABA}"/>
+              </a:ext>
+            </a:extLst>
+          </p:cNvPr>
+          <p:cNvSpPr txBox="1"/>
+          <p:nvPr/>
+        </p:nvSpPr>
+        <p:spPr>
+          <a:xfrm>
+            <a:off x="1216363" y="1651059"/>
+            <a:ext cx="341666" cy="261610"/>
+          </a:xfrm>
+          <a:prstGeom prst="rect">
+            <a:avLst/>
+          </a:prstGeom>
+          <a:noFill/>
+        </p:spPr>
+        <p:txBody>
+          <a:bodyPr wrap="square" rtlCol="0">
+            <a:spAutoFit/>
+          </a:bodyPr>
+          <a:lstStyle/>
+          <a:p>
+            <a:r>
+              <a:rPr lang="de-DE" sz="1100" i="1" dirty="0" err="1">
+                <a:solidFill>
+                  <a:srgbClr val="086FBD"/>
+                </a:solidFill>
+                <a:latin typeface="CMU Serif" panose="02000603000000000000" pitchFamily="2" charset="0"/>
+                <a:ea typeface="CMU Serif" panose="02000603000000000000" pitchFamily="2" charset="0"/>
+                <a:cs typeface="CMU Serif" panose="02000603000000000000" pitchFamily="2" charset="0"/>
+              </a:rPr>
+              <a:t>U</a:t>
+            </a:r>
+            <a:r>
+              <a:rPr lang="de-DE" sz="1100" baseline="-25000" dirty="0" err="1">
+                <a:solidFill>
+                  <a:srgbClr val="086FBD"/>
+                </a:solidFill>
+                <a:latin typeface="CMU Serif" panose="02000603000000000000" pitchFamily="2" charset="0"/>
+                <a:ea typeface="CMU Serif" panose="02000603000000000000" pitchFamily="2" charset="0"/>
+                <a:cs typeface="CMU Serif" panose="02000603000000000000" pitchFamily="2" charset="0"/>
+              </a:rPr>
+              <a:t>q</a:t>
+            </a:r>
+            <a:endParaRPr lang="de-DE" sz="1100" baseline="-25000" dirty="0">
+              <a:solidFill>
+                <a:srgbClr val="086FBD"/>
+              </a:solidFill>
+              <a:latin typeface="CMU Serif" panose="02000603000000000000" pitchFamily="2" charset="0"/>
+              <a:ea typeface="CMU Serif" panose="02000603000000000000" pitchFamily="2" charset="0"/>
+              <a:cs typeface="CMU Serif" panose="02000603000000000000" pitchFamily="2" charset="0"/>
+            </a:endParaRPr>
+          </a:p>
+        </p:txBody>
+      </p:sp>
+      <p:cxnSp>
+        <p:nvCxnSpPr>
+          <p:cNvPr id="16" name="Gerade Verbindung mit Pfeil 15">
+            <a:extLst>
+              <a:ext uri="{FF2B5EF4-FFF2-40B4-BE49-F238E27FC236}">
+                <a16:creationId xmlns:a16="http://schemas.microsoft.com/office/drawing/2014/main" id="{3BE8BC9B-2E5A-88D1-D072-90BCED54D6A0}"/>
+              </a:ext>
+            </a:extLst>
+          </p:cNvPr>
+          <p:cNvCxnSpPr/>
+          <p:nvPr/>
+        </p:nvCxnSpPr>
+        <p:spPr>
+          <a:xfrm>
+            <a:off x="1474029" y="867427"/>
+            <a:ext cx="167999" cy="0"/>
+          </a:xfrm>
+          <a:prstGeom prst="straightConnector1">
+            <a:avLst/>
+          </a:prstGeom>
+          <a:ln cap="rnd">
+            <a:solidFill>
+              <a:srgbClr val="FF0000"/>
+            </a:solidFill>
+            <a:round/>
+            <a:tailEnd type="triangle"/>
+          </a:ln>
+        </p:spPr>
+        <p:style>
+          <a:lnRef idx="2">
+            <a:schemeClr val="accent1"/>
+          </a:lnRef>
+          <a:fillRef idx="0">
+            <a:schemeClr val="accent1"/>
+          </a:fillRef>
+          <a:effectRef idx="1">
+            <a:schemeClr val="accent1"/>
+          </a:effectRef>
+          <a:fontRef idx="minor">
+            <a:schemeClr val="tx1"/>
+          </a:fontRef>
+        </p:style>
+      </p:cxnSp>
+      <p:sp>
+        <p:nvSpPr>
+          <p:cNvPr id="17" name="Textfeld 16">
+            <a:extLst>
+              <a:ext uri="{FF2B5EF4-FFF2-40B4-BE49-F238E27FC236}">
+                <a16:creationId xmlns:a16="http://schemas.microsoft.com/office/drawing/2014/main" id="{10A75A5E-6306-CF12-9D41-ECCBA9C22C9B}"/>
+              </a:ext>
+            </a:extLst>
+          </p:cNvPr>
+          <p:cNvSpPr txBox="1"/>
+          <p:nvPr/>
+        </p:nvSpPr>
+        <p:spPr>
+          <a:xfrm>
+            <a:off x="1409824" y="892553"/>
+            <a:ext cx="296407" cy="261610"/>
+          </a:xfrm>
+          <a:prstGeom prst="rect">
+            <a:avLst/>
+          </a:prstGeom>
+          <a:noFill/>
+        </p:spPr>
+        <p:txBody>
+          <a:bodyPr wrap="square" rtlCol="0">
+            <a:spAutoFit/>
+          </a:bodyPr>
+          <a:lstStyle/>
+          <a:p>
+            <a:r>
+              <a:rPr lang="de-DE" sz="1100" i="1" dirty="0">
+                <a:solidFill>
+                  <a:srgbClr val="FF0000"/>
+                </a:solidFill>
+                <a:latin typeface="CMU Serif" panose="02000603000000000000" pitchFamily="2" charset="0"/>
+                <a:ea typeface="CMU Serif" panose="02000603000000000000" pitchFamily="2" charset="0"/>
+                <a:cs typeface="CMU Serif" panose="02000603000000000000" pitchFamily="2" charset="0"/>
+              </a:rPr>
+              <a:t>I</a:t>
+            </a:r>
+            <a:endParaRPr lang="de-DE" sz="1100" baseline="-25000" dirty="0">
+              <a:solidFill>
+                <a:srgbClr val="FF0000"/>
+              </a:solidFill>
+              <a:latin typeface="CMU Serif" panose="02000603000000000000" pitchFamily="2" charset="0"/>
+              <a:ea typeface="CMU Serif" panose="02000603000000000000" pitchFamily="2" charset="0"/>
+              <a:cs typeface="CMU Serif" panose="02000603000000000000" pitchFamily="2" charset="0"/>
+            </a:endParaRPr>
+          </a:p>
+        </p:txBody>
+      </p:sp>
+      <p:sp>
+        <p:nvSpPr>
+          <p:cNvPr id="20" name="Textfeld 19">
+            <a:extLst>
+              <a:ext uri="{FF2B5EF4-FFF2-40B4-BE49-F238E27FC236}">
+                <a16:creationId xmlns:a16="http://schemas.microsoft.com/office/drawing/2014/main" id="{248A2ACD-F1EA-5E7F-4AED-095EEF08B587}"/>
+              </a:ext>
+            </a:extLst>
+          </p:cNvPr>
+          <p:cNvSpPr txBox="1"/>
+          <p:nvPr/>
+        </p:nvSpPr>
+        <p:spPr>
+          <a:xfrm>
+            <a:off x="1633338" y="1177483"/>
+            <a:ext cx="341666" cy="261610"/>
+          </a:xfrm>
+          <a:prstGeom prst="rect">
+            <a:avLst/>
+          </a:prstGeom>
+          <a:noFill/>
+        </p:spPr>
+        <p:txBody>
+          <a:bodyPr wrap="square" rtlCol="0">
+            <a:spAutoFit/>
+          </a:bodyPr>
+          <a:lstStyle/>
+          <a:p>
+            <a:pPr algn="ctr"/>
+            <a:r>
+              <a:rPr lang="de-DE" sz="1100" i="1" dirty="0">
+                <a:latin typeface="CMU Serif" panose="02000603000000000000" pitchFamily="2" charset="0"/>
+                <a:ea typeface="CMU Serif" panose="02000603000000000000" pitchFamily="2" charset="0"/>
+                <a:cs typeface="CMU Serif" panose="02000603000000000000" pitchFamily="2" charset="0"/>
+              </a:rPr>
+              <a:t>R</a:t>
+            </a:r>
+            <a:r>
+              <a:rPr lang="de-DE" sz="1100" baseline="-25000" dirty="0">
+                <a:latin typeface="CMU Serif" panose="02000603000000000000" pitchFamily="2" charset="0"/>
+                <a:ea typeface="CMU Serif" panose="02000603000000000000" pitchFamily="2" charset="0"/>
+                <a:cs typeface="CMU Serif" panose="02000603000000000000" pitchFamily="2" charset="0"/>
+              </a:rPr>
+              <a:t>i</a:t>
+            </a:r>
+          </a:p>
+        </p:txBody>
+      </p:sp>
+      <p:cxnSp>
+        <p:nvCxnSpPr>
+          <p:cNvPr id="23" name="Gerade Verbindung mit Pfeil 22">
+            <a:extLst>
+              <a:ext uri="{FF2B5EF4-FFF2-40B4-BE49-F238E27FC236}">
+                <a16:creationId xmlns:a16="http://schemas.microsoft.com/office/drawing/2014/main" id="{70F39339-76E0-F373-7E0E-ADD9A72AD9CE}"/>
+              </a:ext>
+            </a:extLst>
+          </p:cNvPr>
+          <p:cNvCxnSpPr>
+            <a:cxnSpLocks/>
+          </p:cNvCxnSpPr>
+          <p:nvPr/>
+        </p:nvCxnSpPr>
+        <p:spPr>
+          <a:xfrm>
+            <a:off x="1992149" y="1859589"/>
+            <a:ext cx="0" cy="157855"/>
+          </a:xfrm>
+          <a:prstGeom prst="straightConnector1">
+            <a:avLst/>
+          </a:prstGeom>
+          <a:ln cap="rnd">
+            <a:solidFill>
+              <a:srgbClr val="FF0000"/>
+            </a:solidFill>
+            <a:round/>
+            <a:tailEnd type="triangle"/>
+          </a:ln>
+        </p:spPr>
+        <p:style>
+          <a:lnRef idx="2">
+            <a:schemeClr val="accent1"/>
+          </a:lnRef>
+          <a:fillRef idx="0">
+            <a:schemeClr val="accent1"/>
+          </a:fillRef>
+          <a:effectRef idx="1">
+            <a:schemeClr val="accent1"/>
+          </a:effectRef>
+          <a:fontRef idx="minor">
+            <a:schemeClr val="tx1"/>
+          </a:fontRef>
+        </p:style>
+      </p:cxnSp>
+      <p:sp>
+        <p:nvSpPr>
+          <p:cNvPr id="24" name="Textfeld 23">
+            <a:extLst>
+              <a:ext uri="{FF2B5EF4-FFF2-40B4-BE49-F238E27FC236}">
+                <a16:creationId xmlns:a16="http://schemas.microsoft.com/office/drawing/2014/main" id="{0F1CE6E0-30F2-2FAC-2885-3803B8C3A3DB}"/>
+              </a:ext>
+            </a:extLst>
+          </p:cNvPr>
+          <p:cNvSpPr txBox="1"/>
+          <p:nvPr/>
+        </p:nvSpPr>
+        <p:spPr>
+          <a:xfrm>
+            <a:off x="1694989" y="1795683"/>
+            <a:ext cx="296407" cy="261610"/>
+          </a:xfrm>
+          <a:prstGeom prst="rect">
+            <a:avLst/>
+          </a:prstGeom>
+          <a:noFill/>
+        </p:spPr>
+        <p:txBody>
+          <a:bodyPr wrap="square" rtlCol="0">
+            <a:spAutoFit/>
+          </a:bodyPr>
+          <a:lstStyle/>
+          <a:p>
+            <a:r>
+              <a:rPr lang="de-DE" sz="1100" i="1" dirty="0">
+                <a:solidFill>
+                  <a:srgbClr val="FF0000"/>
+                </a:solidFill>
+                <a:latin typeface="CMU Serif" panose="02000603000000000000" pitchFamily="2" charset="0"/>
+                <a:ea typeface="CMU Serif" panose="02000603000000000000" pitchFamily="2" charset="0"/>
+                <a:cs typeface="CMU Serif" panose="02000603000000000000" pitchFamily="2" charset="0"/>
+              </a:rPr>
+              <a:t>I</a:t>
+            </a:r>
+            <a:r>
+              <a:rPr lang="de-DE" sz="1100" baseline="-25000" dirty="0">
+                <a:solidFill>
+                  <a:srgbClr val="FF0000"/>
+                </a:solidFill>
+                <a:latin typeface="CMU Serif" panose="02000603000000000000" pitchFamily="2" charset="0"/>
+                <a:ea typeface="CMU Serif" panose="02000603000000000000" pitchFamily="2" charset="0"/>
+                <a:cs typeface="CMU Serif" panose="02000603000000000000" pitchFamily="2" charset="0"/>
+              </a:rPr>
+              <a:t>1</a:t>
+            </a:r>
+          </a:p>
+        </p:txBody>
+      </p:sp>
+      <p:sp>
+        <p:nvSpPr>
+          <p:cNvPr id="26" name="Textfeld 25">
+            <a:extLst>
+              <a:ext uri="{FF2B5EF4-FFF2-40B4-BE49-F238E27FC236}">
+                <a16:creationId xmlns:a16="http://schemas.microsoft.com/office/drawing/2014/main" id="{A2160195-DDB8-6ECF-0B2A-EDC98E802C09}"/>
+              </a:ext>
+            </a:extLst>
+          </p:cNvPr>
+          <p:cNvSpPr txBox="1"/>
+          <p:nvPr/>
+        </p:nvSpPr>
+        <p:spPr>
+          <a:xfrm>
+            <a:off x="1633338" y="2094128"/>
+            <a:ext cx="341666" cy="261610"/>
+          </a:xfrm>
+          <a:prstGeom prst="rect">
+            <a:avLst/>
+          </a:prstGeom>
+          <a:noFill/>
+        </p:spPr>
+        <p:txBody>
+          <a:bodyPr wrap="square" rtlCol="0">
+            <a:spAutoFit/>
+          </a:bodyPr>
+          <a:lstStyle/>
+          <a:p>
+            <a:pPr algn="ctr"/>
+            <a:r>
+              <a:rPr lang="de-DE" sz="1100" i="1" dirty="0">
+                <a:latin typeface="CMU Serif" panose="02000603000000000000" pitchFamily="2" charset="0"/>
+                <a:ea typeface="CMU Serif" panose="02000603000000000000" pitchFamily="2" charset="0"/>
+                <a:cs typeface="CMU Serif" panose="02000603000000000000" pitchFamily="2" charset="0"/>
+              </a:rPr>
+              <a:t>R</a:t>
+            </a:r>
+            <a:r>
+              <a:rPr lang="de-DE" sz="1100" baseline="-25000" dirty="0">
+                <a:latin typeface="CMU Serif" panose="02000603000000000000" pitchFamily="2" charset="0"/>
+                <a:ea typeface="CMU Serif" panose="02000603000000000000" pitchFamily="2" charset="0"/>
+                <a:cs typeface="CMU Serif" panose="02000603000000000000" pitchFamily="2" charset="0"/>
+              </a:rPr>
+              <a:t>1</a:t>
+            </a:r>
+          </a:p>
+        </p:txBody>
+      </p:sp>
+      <p:sp>
+        <p:nvSpPr>
+          <p:cNvPr id="28" name="Textfeld 27">
+            <a:extLst>
+              <a:ext uri="{FF2B5EF4-FFF2-40B4-BE49-F238E27FC236}">
+                <a16:creationId xmlns:a16="http://schemas.microsoft.com/office/drawing/2014/main" id="{3C91E694-EBC2-1B3F-C1EB-08211EE00B50}"/>
+              </a:ext>
+            </a:extLst>
+          </p:cNvPr>
+          <p:cNvSpPr txBox="1"/>
+          <p:nvPr/>
+        </p:nvSpPr>
+        <p:spPr>
+          <a:xfrm>
+            <a:off x="2331554" y="1658229"/>
+            <a:ext cx="341666" cy="261610"/>
+          </a:xfrm>
+          <a:prstGeom prst="rect">
+            <a:avLst/>
+          </a:prstGeom>
+          <a:noFill/>
+        </p:spPr>
+        <p:txBody>
+          <a:bodyPr wrap="square" rtlCol="0">
+            <a:spAutoFit/>
+          </a:bodyPr>
+          <a:lstStyle/>
+          <a:p>
+            <a:pPr algn="ctr"/>
+            <a:r>
+              <a:rPr lang="de-DE" sz="1100" dirty="0">
+                <a:latin typeface="CMU Serif" panose="02000603000000000000" pitchFamily="2" charset="0"/>
+                <a:ea typeface="CMU Serif" panose="02000603000000000000" pitchFamily="2" charset="0"/>
+                <a:cs typeface="CMU Serif" panose="02000603000000000000" pitchFamily="2" charset="0"/>
+              </a:rPr>
+              <a:t>1</a:t>
+            </a:r>
+            <a:endParaRPr lang="de-DE" sz="1100" baseline="-25000" dirty="0">
+              <a:latin typeface="CMU Serif" panose="02000603000000000000" pitchFamily="2" charset="0"/>
+              <a:ea typeface="CMU Serif" panose="02000603000000000000" pitchFamily="2" charset="0"/>
+              <a:cs typeface="CMU Serif" panose="02000603000000000000" pitchFamily="2" charset="0"/>
+            </a:endParaRPr>
+          </a:p>
+        </p:txBody>
+      </p:sp>
+      <p:sp>
+        <p:nvSpPr>
+          <p:cNvPr id="29" name="Textfeld 28">
+            <a:extLst>
+              <a:ext uri="{FF2B5EF4-FFF2-40B4-BE49-F238E27FC236}">
+                <a16:creationId xmlns:a16="http://schemas.microsoft.com/office/drawing/2014/main" id="{1460DA54-2300-4766-5270-1A2CD5D53C55}"/>
+              </a:ext>
+            </a:extLst>
+          </p:cNvPr>
+          <p:cNvSpPr txBox="1"/>
+          <p:nvPr/>
+        </p:nvSpPr>
+        <p:spPr>
+          <a:xfrm>
+            <a:off x="2337269" y="2550985"/>
+            <a:ext cx="341666" cy="261610"/>
+          </a:xfrm>
+          <a:prstGeom prst="rect">
+            <a:avLst/>
+          </a:prstGeom>
+          <a:noFill/>
+        </p:spPr>
+        <p:txBody>
+          <a:bodyPr wrap="square" rtlCol="0">
+            <a:spAutoFit/>
+          </a:bodyPr>
+          <a:lstStyle/>
+          <a:p>
+            <a:pPr algn="ctr"/>
+            <a:r>
+              <a:rPr lang="de-DE" sz="1100" dirty="0">
+                <a:latin typeface="CMU Serif" panose="02000603000000000000" pitchFamily="2" charset="0"/>
+                <a:ea typeface="CMU Serif" panose="02000603000000000000" pitchFamily="2" charset="0"/>
+                <a:cs typeface="CMU Serif" panose="02000603000000000000" pitchFamily="2" charset="0"/>
+              </a:rPr>
+              <a:t>2</a:t>
+            </a:r>
+            <a:endParaRPr lang="de-DE" sz="1100" baseline="-25000" dirty="0">
+              <a:latin typeface="CMU Serif" panose="02000603000000000000" pitchFamily="2" charset="0"/>
+              <a:ea typeface="CMU Serif" panose="02000603000000000000" pitchFamily="2" charset="0"/>
+              <a:cs typeface="CMU Serif" panose="02000603000000000000" pitchFamily="2" charset="0"/>
+            </a:endParaRPr>
+          </a:p>
+        </p:txBody>
+      </p:sp>
+      <p:sp>
+        <p:nvSpPr>
+          <p:cNvPr id="8" name="Ellipse 7">
+            <a:extLst>
+              <a:ext uri="{FF2B5EF4-FFF2-40B4-BE49-F238E27FC236}">
+                <a16:creationId xmlns:a16="http://schemas.microsoft.com/office/drawing/2014/main" id="{56FFA2C0-46D1-E466-D123-EF9B8F92B9A7}"/>
+              </a:ext>
+            </a:extLst>
+          </p:cNvPr>
+          <p:cNvSpPr/>
+          <p:nvPr/>
+        </p:nvSpPr>
+        <p:spPr>
+          <a:xfrm>
+            <a:off x="2341080" y="1743679"/>
+            <a:ext cx="70030" cy="70030"/>
+          </a:xfrm>
+          <a:prstGeom prst="ellipse">
+            <a:avLst/>
+          </a:prstGeom>
+          <a:solidFill>
+            <a:schemeClr val="bg1"/>
+          </a:solidFill>
+          <a:ln w="12700">
+            <a:solidFill>
+              <a:schemeClr val="tx1"/>
+            </a:solidFill>
+          </a:ln>
+        </p:spPr>
+        <p:style>
+          <a:lnRef idx="2">
+            <a:schemeClr val="accent1">
+              <a:shade val="15000"/>
+            </a:schemeClr>
+          </a:lnRef>
+          <a:fillRef idx="1">
+            <a:schemeClr val="accent1"/>
+          </a:fillRef>
+          <a:effectRef idx="0">
+            <a:schemeClr val="accent1"/>
+          </a:effectRef>
+          <a:fontRef idx="minor">
+            <a:schemeClr val="lt1"/>
+          </a:fontRef>
+        </p:style>
+        <p:txBody>
+          <a:bodyPr rtlCol="0" anchor="ctr"/>
+          <a:lstStyle/>
+          <a:p>
+            <a:pPr algn="ctr"/>
+            <a:endParaRPr lang="de-DE">
+              <a:solidFill>
+                <a:sysClr val="windowText" lastClr="000000"/>
+              </a:solidFill>
+            </a:endParaRPr>
+          </a:p>
+        </p:txBody>
+      </p:sp>
+      <p:sp>
+        <p:nvSpPr>
+          <p:cNvPr id="9" name="Ellipse 8">
+            <a:extLst>
+              <a:ext uri="{FF2B5EF4-FFF2-40B4-BE49-F238E27FC236}">
+                <a16:creationId xmlns:a16="http://schemas.microsoft.com/office/drawing/2014/main" id="{AA11FC0B-2738-EF53-D0C0-CAF8D6B82200}"/>
+              </a:ext>
+            </a:extLst>
+          </p:cNvPr>
+          <p:cNvSpPr/>
+          <p:nvPr/>
+        </p:nvSpPr>
+        <p:spPr>
+          <a:xfrm>
+            <a:off x="2341080" y="2636159"/>
+            <a:ext cx="70030" cy="70030"/>
+          </a:xfrm>
+          <a:prstGeom prst="ellipse">
+            <a:avLst/>
+          </a:prstGeom>
+          <a:solidFill>
+            <a:schemeClr val="bg1"/>
+          </a:solidFill>
+          <a:ln w="12700">
+            <a:solidFill>
+              <a:schemeClr val="tx1"/>
+            </a:solidFill>
+          </a:ln>
+        </p:spPr>
+        <p:style>
+          <a:lnRef idx="2">
+            <a:schemeClr val="accent1">
+              <a:shade val="15000"/>
+            </a:schemeClr>
+          </a:lnRef>
+          <a:fillRef idx="1">
+            <a:schemeClr val="accent1"/>
+          </a:fillRef>
+          <a:effectRef idx="0">
+            <a:schemeClr val="accent1"/>
+          </a:effectRef>
+          <a:fontRef idx="minor">
+            <a:schemeClr val="lt1"/>
+          </a:fontRef>
+        </p:style>
+        <p:txBody>
+          <a:bodyPr rtlCol="0" anchor="ctr"/>
+          <a:lstStyle/>
+          <a:p>
+            <a:pPr algn="ctr"/>
+            <a:endParaRPr lang="de-DE">
+              <a:solidFill>
+                <a:sysClr val="windowText" lastClr="000000"/>
+              </a:solidFill>
+            </a:endParaRPr>
+          </a:p>
+        </p:txBody>
+      </p:sp>
+      <p:cxnSp>
+        <p:nvCxnSpPr>
+          <p:cNvPr id="2" name="Gerade Verbindung mit Pfeil 1">
+            <a:extLst>
+              <a:ext uri="{FF2B5EF4-FFF2-40B4-BE49-F238E27FC236}">
+                <a16:creationId xmlns:a16="http://schemas.microsoft.com/office/drawing/2014/main" id="{5A215222-9CAB-DB87-BD22-413E4E657E3D}"/>
+              </a:ext>
+            </a:extLst>
+          </p:cNvPr>
+          <p:cNvCxnSpPr>
+            <a:cxnSpLocks/>
+          </p:cNvCxnSpPr>
+          <p:nvPr/>
+        </p:nvCxnSpPr>
+        <p:spPr>
+          <a:xfrm>
+            <a:off x="2376568" y="1859384"/>
+            <a:ext cx="0" cy="735226"/>
+          </a:xfrm>
+          <a:prstGeom prst="straightConnector1">
+            <a:avLst/>
+          </a:prstGeom>
+          <a:ln cap="rnd">
+            <a:solidFill>
+              <a:srgbClr val="086FBD"/>
+            </a:solidFill>
+            <a:round/>
+            <a:tailEnd type="triangle"/>
+          </a:ln>
+        </p:spPr>
+        <p:style>
+          <a:lnRef idx="2">
+            <a:schemeClr val="accent1"/>
+          </a:lnRef>
+          <a:fillRef idx="0">
+            <a:schemeClr val="accent1"/>
+          </a:fillRef>
+          <a:effectRef idx="1">
+            <a:schemeClr val="accent1"/>
+          </a:effectRef>
+          <a:fontRef idx="minor">
+            <a:schemeClr val="tx1"/>
+          </a:fontRef>
+        </p:style>
+      </p:cxnSp>
+      <p:sp>
+        <p:nvSpPr>
+          <p:cNvPr id="3" name="Textfeld 2">
+            <a:extLst>
+              <a:ext uri="{FF2B5EF4-FFF2-40B4-BE49-F238E27FC236}">
+                <a16:creationId xmlns:a16="http://schemas.microsoft.com/office/drawing/2014/main" id="{02ECAFED-1A1D-6661-7179-952083BDFF28}"/>
+              </a:ext>
+            </a:extLst>
+          </p:cNvPr>
+          <p:cNvSpPr txBox="1"/>
+          <p:nvPr/>
+        </p:nvSpPr>
+        <p:spPr>
+          <a:xfrm>
+            <a:off x="2331554" y="2082947"/>
+            <a:ext cx="441404" cy="261610"/>
+          </a:xfrm>
+          <a:prstGeom prst="rect">
+            <a:avLst/>
+          </a:prstGeom>
+          <a:noFill/>
+        </p:spPr>
+        <p:txBody>
+          <a:bodyPr wrap="square" rtlCol="0">
+            <a:spAutoFit/>
+          </a:bodyPr>
+          <a:lstStyle/>
+          <a:p>
+            <a:r>
+              <a:rPr lang="de-DE" sz="1100" i="1" dirty="0" err="1">
+                <a:solidFill>
+                  <a:srgbClr val="086FBD"/>
+                </a:solidFill>
+                <a:latin typeface="CMU Serif" panose="02000603000000000000" pitchFamily="2" charset="0"/>
+                <a:ea typeface="CMU Serif" panose="02000603000000000000" pitchFamily="2" charset="0"/>
+                <a:cs typeface="CMU Serif" panose="02000603000000000000" pitchFamily="2" charset="0"/>
+              </a:rPr>
+              <a:t>U</a:t>
+            </a:r>
+            <a:r>
+              <a:rPr lang="de-DE" sz="1100" baseline="-25000" dirty="0" err="1">
+                <a:solidFill>
+                  <a:srgbClr val="086FBD"/>
+                </a:solidFill>
+                <a:latin typeface="CMU Serif" panose="02000603000000000000" pitchFamily="2" charset="0"/>
+                <a:ea typeface="CMU Serif" panose="02000603000000000000" pitchFamily="2" charset="0"/>
+                <a:cs typeface="CMU Serif" panose="02000603000000000000" pitchFamily="2" charset="0"/>
+              </a:rPr>
+              <a:t>q</a:t>
+            </a:r>
+            <a:r>
+              <a:rPr lang="de-DE" sz="1100" dirty="0">
+                <a:solidFill>
+                  <a:srgbClr val="086FBD"/>
+                </a:solidFill>
+                <a:latin typeface="CMU Serif" panose="02000603000000000000" pitchFamily="2" charset="0"/>
+                <a:ea typeface="CMU Serif" panose="02000603000000000000" pitchFamily="2" charset="0"/>
+                <a:cs typeface="CMU Serif" panose="02000603000000000000" pitchFamily="2" charset="0"/>
+              </a:rPr>
+              <a:t>′</a:t>
+            </a:r>
+          </a:p>
+        </p:txBody>
+      </p:sp>
+    </p:spTree>
+    <p:extLst>
+      <p:ext uri="{BB962C8B-B14F-4D97-AF65-F5344CB8AC3E}">
+        <p14:creationId xmlns:p14="http://schemas.microsoft.com/office/powerpoint/2010/main" val="866456762"/>
+      </p:ext>
+    </p:extLst>
+  </p:cSld>
+  <p:clrMapOvr>
+    <a:masterClrMapping/>
+  </p:clrMapOvr>
+</p:sld>
+</file>
+
+<file path=ppt/slides/slide5.xml><?xml version="1.0" encoding="utf-8"?>
+<p:sld xmlns:a="http://schemas.openxmlformats.org/drawingml/2006/main" xmlns:r="http://schemas.openxmlformats.org/officeDocument/2006/relationships" xmlns:p="http://schemas.openxmlformats.org/presentationml/2006/main">
+  <p:cSld>
+    <p:spTree>
+      <p:nvGrpSpPr>
+        <p:cNvPr id="1" name="">
+          <a:extLst>
+            <a:ext uri="{FF2B5EF4-FFF2-40B4-BE49-F238E27FC236}">
+              <a16:creationId xmlns:a16="http://schemas.microsoft.com/office/drawing/2014/main" id="{95E5EDE7-E3FE-84E4-319D-31CDE830858A}"/>
+            </a:ext>
+          </a:extLst>
+        </p:cNvPr>
+        <p:cNvGrpSpPr/>
+        <p:nvPr/>
+      </p:nvGrpSpPr>
+      <p:grpSpPr>
+        <a:xfrm>
+          <a:off x="0" y="0"/>
+          <a:ext cx="0" cy="0"/>
+          <a:chOff x="0" y="0"/>
+          <a:chExt cx="0" cy="0"/>
+        </a:xfrm>
+      </p:grpSpPr>
+      <p:sp>
+        <p:nvSpPr>
+          <p:cNvPr id="4" name="Rechteck 3">
+            <a:extLst>
+              <a:ext uri="{FF2B5EF4-FFF2-40B4-BE49-F238E27FC236}">
+                <a16:creationId xmlns:a16="http://schemas.microsoft.com/office/drawing/2014/main" id="{FC8C22B4-8526-CB29-88CD-051EB7508B1B}"/>
+              </a:ext>
+            </a:extLst>
+          </p:cNvPr>
+          <p:cNvSpPr/>
+          <p:nvPr/>
+        </p:nvSpPr>
+        <p:spPr>
+          <a:xfrm>
+            <a:off x="1096035" y="867427"/>
+            <a:ext cx="895612" cy="1803748"/>
+          </a:xfrm>
+          <a:prstGeom prst="rect">
+            <a:avLst/>
+          </a:prstGeom>
+          <a:noFill/>
+          <a:ln w="15875" cap="rnd">
+            <a:solidFill>
+              <a:schemeClr val="tx1"/>
+            </a:solidFill>
+            <a:round/>
+          </a:ln>
+        </p:spPr>
+        <p:style>
+          <a:lnRef idx="2">
+            <a:schemeClr val="accent1">
+              <a:shade val="15000"/>
+            </a:schemeClr>
+          </a:lnRef>
+          <a:fillRef idx="1">
+            <a:schemeClr val="accent1"/>
+          </a:fillRef>
+          <a:effectRef idx="0">
+            <a:schemeClr val="accent1"/>
+          </a:effectRef>
+          <a:fontRef idx="minor">
+            <a:schemeClr val="lt1"/>
+          </a:fontRef>
+        </p:style>
+        <p:txBody>
+          <a:bodyPr rtlCol="0" anchor="ctr"/>
+          <a:lstStyle/>
+          <a:p>
+            <a:pPr algn="ctr"/>
+            <a:endParaRPr lang="de-DE"/>
+          </a:p>
+        </p:txBody>
+      </p:sp>
+      <p:sp>
+        <p:nvSpPr>
+          <p:cNvPr id="5" name="Rechteck 4">
+            <a:extLst>
+              <a:ext uri="{FF2B5EF4-FFF2-40B4-BE49-F238E27FC236}">
+                <a16:creationId xmlns:a16="http://schemas.microsoft.com/office/drawing/2014/main" id="{3FD89CC3-97A7-80CB-0DA3-68278E4FC0E3}"/>
+              </a:ext>
+            </a:extLst>
+          </p:cNvPr>
+          <p:cNvSpPr/>
+          <p:nvPr/>
+        </p:nvSpPr>
+        <p:spPr>
+          <a:xfrm>
+            <a:off x="1991648" y="1778695"/>
+            <a:ext cx="386136" cy="892479"/>
+          </a:xfrm>
+          <a:prstGeom prst="rect">
+            <a:avLst/>
+          </a:prstGeom>
+          <a:noFill/>
+          <a:ln w="15875" cap="rnd">
+            <a:solidFill>
+              <a:schemeClr val="tx1"/>
+            </a:solidFill>
+            <a:round/>
+          </a:ln>
+        </p:spPr>
+        <p:style>
+          <a:lnRef idx="2">
+            <a:schemeClr val="accent1">
+              <a:shade val="15000"/>
+            </a:schemeClr>
+          </a:lnRef>
+          <a:fillRef idx="1">
+            <a:schemeClr val="accent1"/>
+          </a:fillRef>
+          <a:effectRef idx="0">
+            <a:schemeClr val="accent1"/>
+          </a:effectRef>
+          <a:fontRef idx="minor">
+            <a:schemeClr val="lt1"/>
+          </a:fontRef>
+        </p:style>
+        <p:txBody>
+          <a:bodyPr rtlCol="0" anchor="ctr"/>
+          <a:lstStyle/>
+          <a:p>
+            <a:pPr algn="ctr"/>
+            <a:endParaRPr lang="de-DE"/>
+          </a:p>
+        </p:txBody>
+      </p:sp>
+      <p:sp>
+        <p:nvSpPr>
+          <p:cNvPr id="6" name="Ellipse 5">
+            <a:extLst>
+              <a:ext uri="{FF2B5EF4-FFF2-40B4-BE49-F238E27FC236}">
+                <a16:creationId xmlns:a16="http://schemas.microsoft.com/office/drawing/2014/main" id="{378204AC-684F-5034-6679-ABEC4ADFBF2C}"/>
+              </a:ext>
+            </a:extLst>
+          </p:cNvPr>
+          <p:cNvSpPr/>
+          <p:nvPr/>
+        </p:nvSpPr>
+        <p:spPr>
+          <a:xfrm>
+            <a:off x="1951133" y="1738180"/>
+            <a:ext cx="81028" cy="81028"/>
+          </a:xfrm>
+          <a:prstGeom prst="ellipse">
+            <a:avLst/>
+          </a:prstGeom>
+          <a:solidFill>
+            <a:schemeClr val="tx1"/>
+          </a:solidFill>
+          <a:ln>
+            <a:noFill/>
+          </a:ln>
+        </p:spPr>
+        <p:style>
+          <a:lnRef idx="2">
+            <a:schemeClr val="accent1">
+              <a:shade val="15000"/>
+            </a:schemeClr>
+          </a:lnRef>
+          <a:fillRef idx="1">
+            <a:schemeClr val="accent1"/>
+          </a:fillRef>
+          <a:effectRef idx="0">
+            <a:schemeClr val="accent1"/>
+          </a:effectRef>
+          <a:fontRef idx="minor">
+            <a:schemeClr val="lt1"/>
+          </a:fontRef>
+        </p:style>
+        <p:txBody>
+          <a:bodyPr rtlCol="0" anchor="ctr"/>
+          <a:lstStyle/>
+          <a:p>
+            <a:pPr algn="ctr"/>
+            <a:endParaRPr lang="de-DE">
+              <a:solidFill>
+                <a:sysClr val="windowText" lastClr="000000"/>
+              </a:solidFill>
+            </a:endParaRPr>
+          </a:p>
+        </p:txBody>
+      </p:sp>
+      <p:sp>
+        <p:nvSpPr>
+          <p:cNvPr id="7" name="Ellipse 6">
+            <a:extLst>
+              <a:ext uri="{FF2B5EF4-FFF2-40B4-BE49-F238E27FC236}">
+                <a16:creationId xmlns:a16="http://schemas.microsoft.com/office/drawing/2014/main" id="{3EE75F33-A70E-26DB-A5AC-B11C41FEC07A}"/>
+              </a:ext>
+            </a:extLst>
+          </p:cNvPr>
+          <p:cNvSpPr/>
+          <p:nvPr/>
+        </p:nvSpPr>
+        <p:spPr>
+          <a:xfrm>
+            <a:off x="1951133" y="2630661"/>
+            <a:ext cx="81028" cy="81028"/>
+          </a:xfrm>
+          <a:prstGeom prst="ellipse">
+            <a:avLst/>
+          </a:prstGeom>
+          <a:solidFill>
+            <a:schemeClr val="tx1"/>
+          </a:solidFill>
+          <a:ln>
+            <a:noFill/>
+          </a:ln>
+        </p:spPr>
+        <p:style>
+          <a:lnRef idx="2">
+            <a:schemeClr val="accent1">
+              <a:shade val="15000"/>
+            </a:schemeClr>
+          </a:lnRef>
+          <a:fillRef idx="1">
+            <a:schemeClr val="accent1"/>
+          </a:fillRef>
+          <a:effectRef idx="0">
+            <a:schemeClr val="accent1"/>
+          </a:effectRef>
+          <a:fontRef idx="minor">
+            <a:schemeClr val="lt1"/>
+          </a:fontRef>
+        </p:style>
+        <p:txBody>
+          <a:bodyPr rtlCol="0" anchor="ctr"/>
+          <a:lstStyle/>
+          <a:p>
+            <a:pPr algn="ctr"/>
+            <a:endParaRPr lang="de-DE">
+              <a:solidFill>
+                <a:sysClr val="windowText" lastClr="000000"/>
+              </a:solidFill>
+            </a:endParaRPr>
+          </a:p>
+        </p:txBody>
+      </p:sp>
+      <p:sp>
+        <p:nvSpPr>
+          <p:cNvPr id="10" name="Rechteck 9">
+            <a:extLst>
+              <a:ext uri="{FF2B5EF4-FFF2-40B4-BE49-F238E27FC236}">
+                <a16:creationId xmlns:a16="http://schemas.microsoft.com/office/drawing/2014/main" id="{F70FA5A3-5027-B1C0-3679-7F76C7CC9DDF}"/>
+              </a:ext>
+            </a:extLst>
+          </p:cNvPr>
+          <p:cNvSpPr/>
+          <p:nvPr/>
+        </p:nvSpPr>
+        <p:spPr>
+          <a:xfrm rot="16200000">
+            <a:off x="1824007" y="1243749"/>
+            <a:ext cx="335280" cy="118110"/>
+          </a:xfrm>
+          <a:prstGeom prst="rect">
+            <a:avLst/>
+          </a:prstGeom>
+          <a:solidFill>
+            <a:schemeClr val="bg1"/>
+          </a:solidFill>
+          <a:ln w="15875" cap="rnd">
+            <a:solidFill>
+              <a:schemeClr val="tx1"/>
+            </a:solidFill>
+            <a:round/>
+          </a:ln>
+        </p:spPr>
+        <p:style>
+          <a:lnRef idx="2">
+            <a:schemeClr val="accent1">
+              <a:shade val="15000"/>
+            </a:schemeClr>
+          </a:lnRef>
+          <a:fillRef idx="1">
+            <a:schemeClr val="accent1"/>
+          </a:fillRef>
+          <a:effectRef idx="0">
+            <a:schemeClr val="accent1"/>
+          </a:effectRef>
+          <a:fontRef idx="minor">
+            <a:schemeClr val="lt1"/>
+          </a:fontRef>
+        </p:style>
+        <p:txBody>
+          <a:bodyPr rtlCol="0" anchor="ctr"/>
+          <a:lstStyle/>
+          <a:p>
+            <a:pPr algn="ctr"/>
+            <a:endParaRPr lang="de-DE"/>
+          </a:p>
+        </p:txBody>
+      </p:sp>
+      <p:sp>
+        <p:nvSpPr>
+          <p:cNvPr id="11" name="Rechteck 10">
+            <a:extLst>
+              <a:ext uri="{FF2B5EF4-FFF2-40B4-BE49-F238E27FC236}">
+                <a16:creationId xmlns:a16="http://schemas.microsoft.com/office/drawing/2014/main" id="{F2CD5A6B-512D-FD37-3C41-D0E4C54CC797}"/>
+              </a:ext>
+            </a:extLst>
+          </p:cNvPr>
+          <p:cNvSpPr/>
+          <p:nvPr/>
+        </p:nvSpPr>
+        <p:spPr>
+          <a:xfrm rot="16200000">
+            <a:off x="1824007" y="2165879"/>
+            <a:ext cx="335280" cy="118110"/>
+          </a:xfrm>
+          <a:prstGeom prst="rect">
+            <a:avLst/>
+          </a:prstGeom>
+          <a:solidFill>
+            <a:schemeClr val="bg1"/>
+          </a:solidFill>
+          <a:ln w="15875" cap="rnd">
+            <a:solidFill>
+              <a:schemeClr val="tx1"/>
+            </a:solidFill>
+            <a:round/>
+          </a:ln>
+        </p:spPr>
+        <p:style>
+          <a:lnRef idx="2">
+            <a:schemeClr val="accent1">
+              <a:shade val="15000"/>
+            </a:schemeClr>
+          </a:lnRef>
+          <a:fillRef idx="1">
+            <a:schemeClr val="accent1"/>
+          </a:fillRef>
+          <a:effectRef idx="0">
+            <a:schemeClr val="accent1"/>
+          </a:effectRef>
+          <a:fontRef idx="minor">
+            <a:schemeClr val="lt1"/>
+          </a:fontRef>
+        </p:style>
+        <p:txBody>
+          <a:bodyPr rtlCol="0" anchor="ctr"/>
+          <a:lstStyle/>
+          <a:p>
+            <a:pPr algn="ctr"/>
+            <a:endParaRPr lang="de-DE"/>
+          </a:p>
+        </p:txBody>
+      </p:sp>
+      <p:sp>
+        <p:nvSpPr>
+          <p:cNvPr id="13" name="Ellipse 12">
+            <a:extLst>
+              <a:ext uri="{FF2B5EF4-FFF2-40B4-BE49-F238E27FC236}">
+                <a16:creationId xmlns:a16="http://schemas.microsoft.com/office/drawing/2014/main" id="{D7B4E630-7FAE-6F32-E538-DAD790677C58}"/>
+              </a:ext>
+            </a:extLst>
+          </p:cNvPr>
+          <p:cNvSpPr/>
+          <p:nvPr/>
+        </p:nvSpPr>
+        <p:spPr>
+          <a:xfrm>
+            <a:off x="981735" y="1664394"/>
+            <a:ext cx="228600" cy="228600"/>
+          </a:xfrm>
+          <a:prstGeom prst="ellipse">
+            <a:avLst/>
+          </a:prstGeom>
+          <a:noFill/>
+          <a:ln w="15875">
+            <a:solidFill>
+              <a:schemeClr val="tx1"/>
+            </a:solidFill>
+          </a:ln>
+        </p:spPr>
+        <p:style>
+          <a:lnRef idx="2">
+            <a:schemeClr val="accent1">
+              <a:shade val="15000"/>
+            </a:schemeClr>
+          </a:lnRef>
+          <a:fillRef idx="1">
+            <a:schemeClr val="accent1"/>
+          </a:fillRef>
+          <a:effectRef idx="0">
+            <a:schemeClr val="accent1"/>
+          </a:effectRef>
+          <a:fontRef idx="minor">
+            <a:schemeClr val="lt1"/>
+          </a:fontRef>
+        </p:style>
+        <p:txBody>
+          <a:bodyPr rtlCol="0" anchor="ctr"/>
+          <a:lstStyle/>
+          <a:p>
+            <a:pPr algn="ctr"/>
+            <a:endParaRPr lang="de-DE"/>
+          </a:p>
+        </p:txBody>
+      </p:sp>
+      <p:cxnSp>
+        <p:nvCxnSpPr>
+          <p:cNvPr id="14" name="Gerade Verbindung mit Pfeil 13">
+            <a:extLst>
+              <a:ext uri="{FF2B5EF4-FFF2-40B4-BE49-F238E27FC236}">
+                <a16:creationId xmlns:a16="http://schemas.microsoft.com/office/drawing/2014/main" id="{B3E8230A-15E9-5B6D-155E-38439D10BF5F}"/>
+              </a:ext>
+            </a:extLst>
+          </p:cNvPr>
+          <p:cNvCxnSpPr>
+            <a:cxnSpLocks/>
+          </p:cNvCxnSpPr>
+          <p:nvPr/>
+        </p:nvCxnSpPr>
+        <p:spPr>
+          <a:xfrm>
+            <a:off x="1269390" y="1517800"/>
+            <a:ext cx="0" cy="565147"/>
+          </a:xfrm>
+          <a:prstGeom prst="straightConnector1">
+            <a:avLst/>
+          </a:prstGeom>
+          <a:ln cap="rnd">
+            <a:solidFill>
+              <a:srgbClr val="086FBD"/>
+            </a:solidFill>
+            <a:round/>
+            <a:tailEnd type="triangle"/>
+          </a:ln>
+        </p:spPr>
+        <p:style>
+          <a:lnRef idx="2">
+            <a:schemeClr val="accent1"/>
+          </a:lnRef>
+          <a:fillRef idx="0">
+            <a:schemeClr val="accent1"/>
+          </a:fillRef>
+          <a:effectRef idx="1">
+            <a:schemeClr val="accent1"/>
+          </a:effectRef>
+          <a:fontRef idx="minor">
+            <a:schemeClr val="tx1"/>
+          </a:fontRef>
+        </p:style>
+      </p:cxnSp>
+      <p:sp>
+        <p:nvSpPr>
+          <p:cNvPr id="15" name="Textfeld 14">
+            <a:extLst>
+              <a:ext uri="{FF2B5EF4-FFF2-40B4-BE49-F238E27FC236}">
+                <a16:creationId xmlns:a16="http://schemas.microsoft.com/office/drawing/2014/main" id="{3D14D721-9D21-10AB-3B2A-9B05ADA13E4A}"/>
+              </a:ext>
+            </a:extLst>
+          </p:cNvPr>
+          <p:cNvSpPr txBox="1"/>
+          <p:nvPr/>
+        </p:nvSpPr>
+        <p:spPr>
+          <a:xfrm>
+            <a:off x="1216363" y="1651059"/>
+            <a:ext cx="341666" cy="261610"/>
+          </a:xfrm>
+          <a:prstGeom prst="rect">
+            <a:avLst/>
+          </a:prstGeom>
+          <a:noFill/>
+        </p:spPr>
+        <p:txBody>
+          <a:bodyPr wrap="square" rtlCol="0">
+            <a:spAutoFit/>
+          </a:bodyPr>
+          <a:lstStyle/>
+          <a:p>
+            <a:r>
+              <a:rPr lang="de-DE" sz="1100" i="1" dirty="0" err="1">
+                <a:solidFill>
+                  <a:srgbClr val="086FBD"/>
+                </a:solidFill>
+                <a:latin typeface="CMU Serif" panose="02000603000000000000" pitchFamily="2" charset="0"/>
+                <a:ea typeface="CMU Serif" panose="02000603000000000000" pitchFamily="2" charset="0"/>
+                <a:cs typeface="CMU Serif" panose="02000603000000000000" pitchFamily="2" charset="0"/>
+              </a:rPr>
+              <a:t>U</a:t>
+            </a:r>
+            <a:r>
+              <a:rPr lang="de-DE" sz="1100" baseline="-25000" dirty="0" err="1">
+                <a:solidFill>
+                  <a:srgbClr val="086FBD"/>
+                </a:solidFill>
+                <a:latin typeface="CMU Serif" panose="02000603000000000000" pitchFamily="2" charset="0"/>
+                <a:ea typeface="CMU Serif" panose="02000603000000000000" pitchFamily="2" charset="0"/>
+                <a:cs typeface="CMU Serif" panose="02000603000000000000" pitchFamily="2" charset="0"/>
+              </a:rPr>
+              <a:t>q</a:t>
+            </a:r>
+            <a:endParaRPr lang="de-DE" sz="1100" baseline="-25000" dirty="0">
+              <a:solidFill>
+                <a:srgbClr val="086FBD"/>
+              </a:solidFill>
+              <a:latin typeface="CMU Serif" panose="02000603000000000000" pitchFamily="2" charset="0"/>
+              <a:ea typeface="CMU Serif" panose="02000603000000000000" pitchFamily="2" charset="0"/>
+              <a:cs typeface="CMU Serif" panose="02000603000000000000" pitchFamily="2" charset="0"/>
+            </a:endParaRPr>
+          </a:p>
+        </p:txBody>
+      </p:sp>
+      <p:cxnSp>
+        <p:nvCxnSpPr>
+          <p:cNvPr id="16" name="Gerade Verbindung mit Pfeil 15">
+            <a:extLst>
+              <a:ext uri="{FF2B5EF4-FFF2-40B4-BE49-F238E27FC236}">
+                <a16:creationId xmlns:a16="http://schemas.microsoft.com/office/drawing/2014/main" id="{BAAB494C-ABF9-9256-0B17-8BFC9AA6F06D}"/>
+              </a:ext>
+            </a:extLst>
+          </p:cNvPr>
+          <p:cNvCxnSpPr/>
+          <p:nvPr/>
+        </p:nvCxnSpPr>
+        <p:spPr>
+          <a:xfrm>
+            <a:off x="1474029" y="867427"/>
+            <a:ext cx="167999" cy="0"/>
+          </a:xfrm>
+          <a:prstGeom prst="straightConnector1">
+            <a:avLst/>
+          </a:prstGeom>
+          <a:ln cap="rnd">
+            <a:solidFill>
+              <a:srgbClr val="FF0000"/>
+            </a:solidFill>
+            <a:round/>
+            <a:tailEnd type="triangle"/>
+          </a:ln>
+        </p:spPr>
+        <p:style>
+          <a:lnRef idx="2">
+            <a:schemeClr val="accent1"/>
+          </a:lnRef>
+          <a:fillRef idx="0">
+            <a:schemeClr val="accent1"/>
+          </a:fillRef>
+          <a:effectRef idx="1">
+            <a:schemeClr val="accent1"/>
+          </a:effectRef>
+          <a:fontRef idx="minor">
+            <a:schemeClr val="tx1"/>
+          </a:fontRef>
+        </p:style>
+      </p:cxnSp>
+      <p:sp>
+        <p:nvSpPr>
+          <p:cNvPr id="17" name="Textfeld 16">
+            <a:extLst>
+              <a:ext uri="{FF2B5EF4-FFF2-40B4-BE49-F238E27FC236}">
+                <a16:creationId xmlns:a16="http://schemas.microsoft.com/office/drawing/2014/main" id="{59FB38A0-E99A-5F9A-2393-04B62DB3A73A}"/>
+              </a:ext>
+            </a:extLst>
+          </p:cNvPr>
+          <p:cNvSpPr txBox="1"/>
+          <p:nvPr/>
+        </p:nvSpPr>
+        <p:spPr>
+          <a:xfrm>
+            <a:off x="1409824" y="892553"/>
+            <a:ext cx="296407" cy="261610"/>
+          </a:xfrm>
+          <a:prstGeom prst="rect">
+            <a:avLst/>
+          </a:prstGeom>
+          <a:noFill/>
+        </p:spPr>
+        <p:txBody>
+          <a:bodyPr wrap="square" rtlCol="0">
+            <a:spAutoFit/>
+          </a:bodyPr>
+          <a:lstStyle/>
+          <a:p>
+            <a:r>
+              <a:rPr lang="de-DE" sz="1100" i="1" dirty="0">
+                <a:solidFill>
+                  <a:srgbClr val="FF0000"/>
+                </a:solidFill>
+                <a:latin typeface="CMU Serif" panose="02000603000000000000" pitchFamily="2" charset="0"/>
+                <a:ea typeface="CMU Serif" panose="02000603000000000000" pitchFamily="2" charset="0"/>
+                <a:cs typeface="CMU Serif" panose="02000603000000000000" pitchFamily="2" charset="0"/>
+              </a:rPr>
+              <a:t>I</a:t>
+            </a:r>
+            <a:endParaRPr lang="de-DE" sz="1100" baseline="-25000" dirty="0">
+              <a:solidFill>
+                <a:srgbClr val="FF0000"/>
+              </a:solidFill>
+              <a:latin typeface="CMU Serif" panose="02000603000000000000" pitchFamily="2" charset="0"/>
+              <a:ea typeface="CMU Serif" panose="02000603000000000000" pitchFamily="2" charset="0"/>
+              <a:cs typeface="CMU Serif" panose="02000603000000000000" pitchFamily="2" charset="0"/>
+            </a:endParaRPr>
+          </a:p>
+        </p:txBody>
+      </p:sp>
+      <p:sp>
+        <p:nvSpPr>
+          <p:cNvPr id="20" name="Textfeld 19">
+            <a:extLst>
+              <a:ext uri="{FF2B5EF4-FFF2-40B4-BE49-F238E27FC236}">
+                <a16:creationId xmlns:a16="http://schemas.microsoft.com/office/drawing/2014/main" id="{8CC36C0E-20BA-4473-BE56-1D6DBEF968A6}"/>
+              </a:ext>
+            </a:extLst>
+          </p:cNvPr>
+          <p:cNvSpPr txBox="1"/>
+          <p:nvPr/>
+        </p:nvSpPr>
+        <p:spPr>
+          <a:xfrm>
+            <a:off x="1633338" y="1177483"/>
+            <a:ext cx="341666" cy="261610"/>
+          </a:xfrm>
+          <a:prstGeom prst="rect">
+            <a:avLst/>
+          </a:prstGeom>
+          <a:noFill/>
+        </p:spPr>
+        <p:txBody>
+          <a:bodyPr wrap="square" rtlCol="0">
+            <a:spAutoFit/>
+          </a:bodyPr>
+          <a:lstStyle/>
+          <a:p>
+            <a:pPr algn="ctr"/>
+            <a:r>
+              <a:rPr lang="de-DE" sz="1100" i="1" dirty="0">
+                <a:latin typeface="CMU Serif" panose="02000603000000000000" pitchFamily="2" charset="0"/>
+                <a:ea typeface="CMU Serif" panose="02000603000000000000" pitchFamily="2" charset="0"/>
+                <a:cs typeface="CMU Serif" panose="02000603000000000000" pitchFamily="2" charset="0"/>
+              </a:rPr>
+              <a:t>R</a:t>
+            </a:r>
+            <a:r>
+              <a:rPr lang="de-DE" sz="1100" baseline="-25000" dirty="0">
+                <a:latin typeface="CMU Serif" panose="02000603000000000000" pitchFamily="2" charset="0"/>
+                <a:ea typeface="CMU Serif" panose="02000603000000000000" pitchFamily="2" charset="0"/>
+                <a:cs typeface="CMU Serif" panose="02000603000000000000" pitchFamily="2" charset="0"/>
+              </a:rPr>
+              <a:t>i</a:t>
+            </a:r>
+          </a:p>
+        </p:txBody>
+      </p:sp>
+      <p:cxnSp>
+        <p:nvCxnSpPr>
+          <p:cNvPr id="23" name="Gerade Verbindung mit Pfeil 22">
+            <a:extLst>
+              <a:ext uri="{FF2B5EF4-FFF2-40B4-BE49-F238E27FC236}">
+                <a16:creationId xmlns:a16="http://schemas.microsoft.com/office/drawing/2014/main" id="{6BF2893D-2C46-0A6B-D96B-AF79C07FECCC}"/>
+              </a:ext>
+            </a:extLst>
+          </p:cNvPr>
+          <p:cNvCxnSpPr>
+            <a:cxnSpLocks/>
+          </p:cNvCxnSpPr>
+          <p:nvPr/>
+        </p:nvCxnSpPr>
+        <p:spPr>
+          <a:xfrm>
+            <a:off x="2378052" y="2146853"/>
+            <a:ext cx="0" cy="157855"/>
+          </a:xfrm>
+          <a:prstGeom prst="straightConnector1">
+            <a:avLst/>
+          </a:prstGeom>
+          <a:ln cap="rnd">
+            <a:solidFill>
+              <a:srgbClr val="FF0000"/>
+            </a:solidFill>
+            <a:round/>
+            <a:tailEnd type="triangle"/>
+          </a:ln>
+        </p:spPr>
+        <p:style>
+          <a:lnRef idx="2">
+            <a:schemeClr val="accent1"/>
+          </a:lnRef>
+          <a:fillRef idx="0">
+            <a:schemeClr val="accent1"/>
+          </a:fillRef>
+          <a:effectRef idx="1">
+            <a:schemeClr val="accent1"/>
+          </a:effectRef>
+          <a:fontRef idx="minor">
+            <a:schemeClr val="tx1"/>
+          </a:fontRef>
+        </p:style>
+      </p:cxnSp>
+      <p:sp>
+        <p:nvSpPr>
+          <p:cNvPr id="24" name="Textfeld 23">
+            <a:extLst>
+              <a:ext uri="{FF2B5EF4-FFF2-40B4-BE49-F238E27FC236}">
+                <a16:creationId xmlns:a16="http://schemas.microsoft.com/office/drawing/2014/main" id="{FE0C67E2-D3EE-AD12-9B90-3F85FD258E61}"/>
+              </a:ext>
+            </a:extLst>
+          </p:cNvPr>
+          <p:cNvSpPr txBox="1"/>
+          <p:nvPr/>
+        </p:nvSpPr>
+        <p:spPr>
+          <a:xfrm>
+            <a:off x="2358441" y="2087539"/>
+            <a:ext cx="341666" cy="261610"/>
+          </a:xfrm>
+          <a:prstGeom prst="rect">
+            <a:avLst/>
+          </a:prstGeom>
+          <a:noFill/>
+        </p:spPr>
+        <p:txBody>
+          <a:bodyPr wrap="square" rtlCol="0">
+            <a:spAutoFit/>
+          </a:bodyPr>
+          <a:lstStyle/>
+          <a:p>
+            <a:r>
+              <a:rPr lang="de-DE" sz="1100" i="1" dirty="0" err="1">
+                <a:solidFill>
+                  <a:srgbClr val="FF0000"/>
+                </a:solidFill>
+                <a:latin typeface="CMU Serif" panose="02000603000000000000" pitchFamily="2" charset="0"/>
+                <a:ea typeface="CMU Serif" panose="02000603000000000000" pitchFamily="2" charset="0"/>
+                <a:cs typeface="CMU Serif" panose="02000603000000000000" pitchFamily="2" charset="0"/>
+              </a:rPr>
+              <a:t>I</a:t>
+            </a:r>
+            <a:r>
+              <a:rPr lang="de-DE" sz="1100" baseline="-25000" dirty="0" err="1">
+                <a:solidFill>
+                  <a:srgbClr val="FF0000"/>
+                </a:solidFill>
+                <a:latin typeface="CMU Serif" panose="02000603000000000000" pitchFamily="2" charset="0"/>
+                <a:ea typeface="CMU Serif" panose="02000603000000000000" pitchFamily="2" charset="0"/>
+                <a:cs typeface="CMU Serif" panose="02000603000000000000" pitchFamily="2" charset="0"/>
+              </a:rPr>
+              <a:t>k</a:t>
+            </a:r>
+            <a:r>
+              <a:rPr lang="de-DE" sz="1100" dirty="0">
+                <a:solidFill>
+                  <a:srgbClr val="FF0000"/>
+                </a:solidFill>
+                <a:latin typeface="CMU Serif" panose="02000603000000000000" pitchFamily="2" charset="0"/>
+                <a:ea typeface="CMU Serif" panose="02000603000000000000" pitchFamily="2" charset="0"/>
+                <a:cs typeface="CMU Serif" panose="02000603000000000000" pitchFamily="2" charset="0"/>
+              </a:rPr>
+              <a:t>′</a:t>
+            </a:r>
+          </a:p>
+        </p:txBody>
+      </p:sp>
+      <p:sp>
+        <p:nvSpPr>
+          <p:cNvPr id="26" name="Textfeld 25">
+            <a:extLst>
+              <a:ext uri="{FF2B5EF4-FFF2-40B4-BE49-F238E27FC236}">
+                <a16:creationId xmlns:a16="http://schemas.microsoft.com/office/drawing/2014/main" id="{EFEF0AFA-885E-9E2C-74D3-3A7A9DD5FFAB}"/>
+              </a:ext>
+            </a:extLst>
+          </p:cNvPr>
+          <p:cNvSpPr txBox="1"/>
+          <p:nvPr/>
+        </p:nvSpPr>
+        <p:spPr>
+          <a:xfrm>
+            <a:off x="1633338" y="2094128"/>
+            <a:ext cx="341666" cy="261610"/>
+          </a:xfrm>
+          <a:prstGeom prst="rect">
+            <a:avLst/>
+          </a:prstGeom>
+          <a:noFill/>
+        </p:spPr>
+        <p:txBody>
+          <a:bodyPr wrap="square" rtlCol="0">
+            <a:spAutoFit/>
+          </a:bodyPr>
+          <a:lstStyle/>
+          <a:p>
+            <a:pPr algn="ctr"/>
+            <a:r>
+              <a:rPr lang="de-DE" sz="1100" i="1" dirty="0">
+                <a:latin typeface="CMU Serif" panose="02000603000000000000" pitchFamily="2" charset="0"/>
+                <a:ea typeface="CMU Serif" panose="02000603000000000000" pitchFamily="2" charset="0"/>
+                <a:cs typeface="CMU Serif" panose="02000603000000000000" pitchFamily="2" charset="0"/>
+              </a:rPr>
+              <a:t>R</a:t>
+            </a:r>
+            <a:r>
+              <a:rPr lang="de-DE" sz="1100" baseline="-25000" dirty="0">
+                <a:latin typeface="CMU Serif" panose="02000603000000000000" pitchFamily="2" charset="0"/>
+                <a:ea typeface="CMU Serif" panose="02000603000000000000" pitchFamily="2" charset="0"/>
+                <a:cs typeface="CMU Serif" panose="02000603000000000000" pitchFamily="2" charset="0"/>
+              </a:rPr>
+              <a:t>1</a:t>
+            </a:r>
+          </a:p>
+        </p:txBody>
+      </p:sp>
+      <p:sp>
+        <p:nvSpPr>
+          <p:cNvPr id="28" name="Textfeld 27">
+            <a:extLst>
+              <a:ext uri="{FF2B5EF4-FFF2-40B4-BE49-F238E27FC236}">
+                <a16:creationId xmlns:a16="http://schemas.microsoft.com/office/drawing/2014/main" id="{F3FDE67E-B328-51BB-1C5E-354072379244}"/>
+              </a:ext>
+            </a:extLst>
+          </p:cNvPr>
+          <p:cNvSpPr txBox="1"/>
+          <p:nvPr/>
+        </p:nvSpPr>
+        <p:spPr>
+          <a:xfrm>
+            <a:off x="2331554" y="1658229"/>
+            <a:ext cx="341666" cy="261610"/>
+          </a:xfrm>
+          <a:prstGeom prst="rect">
+            <a:avLst/>
+          </a:prstGeom>
+          <a:noFill/>
+        </p:spPr>
+        <p:txBody>
+          <a:bodyPr wrap="square" rtlCol="0">
+            <a:spAutoFit/>
+          </a:bodyPr>
+          <a:lstStyle/>
+          <a:p>
+            <a:pPr algn="ctr"/>
+            <a:r>
+              <a:rPr lang="de-DE" sz="1100" dirty="0">
+                <a:latin typeface="CMU Serif" panose="02000603000000000000" pitchFamily="2" charset="0"/>
+                <a:ea typeface="CMU Serif" panose="02000603000000000000" pitchFamily="2" charset="0"/>
+                <a:cs typeface="CMU Serif" panose="02000603000000000000" pitchFamily="2" charset="0"/>
+              </a:rPr>
+              <a:t>1</a:t>
+            </a:r>
+            <a:endParaRPr lang="de-DE" sz="1100" baseline="-25000" dirty="0">
+              <a:latin typeface="CMU Serif" panose="02000603000000000000" pitchFamily="2" charset="0"/>
+              <a:ea typeface="CMU Serif" panose="02000603000000000000" pitchFamily="2" charset="0"/>
+              <a:cs typeface="CMU Serif" panose="02000603000000000000" pitchFamily="2" charset="0"/>
+            </a:endParaRPr>
+          </a:p>
+        </p:txBody>
+      </p:sp>
+      <p:sp>
+        <p:nvSpPr>
+          <p:cNvPr id="29" name="Textfeld 28">
+            <a:extLst>
+              <a:ext uri="{FF2B5EF4-FFF2-40B4-BE49-F238E27FC236}">
+                <a16:creationId xmlns:a16="http://schemas.microsoft.com/office/drawing/2014/main" id="{985FFBC7-038C-9FC4-7699-E855256F5B4F}"/>
+              </a:ext>
+            </a:extLst>
+          </p:cNvPr>
+          <p:cNvSpPr txBox="1"/>
+          <p:nvPr/>
+        </p:nvSpPr>
+        <p:spPr>
+          <a:xfrm>
+            <a:off x="2337269" y="2550985"/>
+            <a:ext cx="341666" cy="261610"/>
+          </a:xfrm>
+          <a:prstGeom prst="rect">
+            <a:avLst/>
+          </a:prstGeom>
+          <a:noFill/>
+        </p:spPr>
+        <p:txBody>
+          <a:bodyPr wrap="square" rtlCol="0">
+            <a:spAutoFit/>
+          </a:bodyPr>
+          <a:lstStyle/>
+          <a:p>
+            <a:pPr algn="ctr"/>
+            <a:r>
+              <a:rPr lang="de-DE" sz="1100" dirty="0">
+                <a:latin typeface="CMU Serif" panose="02000603000000000000" pitchFamily="2" charset="0"/>
+                <a:ea typeface="CMU Serif" panose="02000603000000000000" pitchFamily="2" charset="0"/>
+                <a:cs typeface="CMU Serif" panose="02000603000000000000" pitchFamily="2" charset="0"/>
+              </a:rPr>
+              <a:t>2</a:t>
+            </a:r>
+            <a:endParaRPr lang="de-DE" sz="1100" baseline="-25000" dirty="0">
+              <a:latin typeface="CMU Serif" panose="02000603000000000000" pitchFamily="2" charset="0"/>
+              <a:ea typeface="CMU Serif" panose="02000603000000000000" pitchFamily="2" charset="0"/>
+              <a:cs typeface="CMU Serif" panose="02000603000000000000" pitchFamily="2" charset="0"/>
+            </a:endParaRPr>
+          </a:p>
+        </p:txBody>
+      </p:sp>
+      <p:sp>
+        <p:nvSpPr>
+          <p:cNvPr id="8" name="Ellipse 7">
+            <a:extLst>
+              <a:ext uri="{FF2B5EF4-FFF2-40B4-BE49-F238E27FC236}">
+                <a16:creationId xmlns:a16="http://schemas.microsoft.com/office/drawing/2014/main" id="{133A2C89-A0CF-4C28-7E55-D04C05E8388D}"/>
+              </a:ext>
+            </a:extLst>
+          </p:cNvPr>
+          <p:cNvSpPr/>
+          <p:nvPr/>
+        </p:nvSpPr>
+        <p:spPr>
+          <a:xfrm>
+            <a:off x="2341080" y="1743679"/>
+            <a:ext cx="70030" cy="70030"/>
+          </a:xfrm>
+          <a:prstGeom prst="ellipse">
+            <a:avLst/>
+          </a:prstGeom>
+          <a:solidFill>
+            <a:schemeClr val="bg1"/>
+          </a:solidFill>
+          <a:ln w="12700">
+            <a:solidFill>
+              <a:schemeClr val="tx1"/>
+            </a:solidFill>
+          </a:ln>
+        </p:spPr>
+        <p:style>
+          <a:lnRef idx="2">
+            <a:schemeClr val="accent1">
+              <a:shade val="15000"/>
+            </a:schemeClr>
+          </a:lnRef>
+          <a:fillRef idx="1">
+            <a:schemeClr val="accent1"/>
+          </a:fillRef>
+          <a:effectRef idx="0">
+            <a:schemeClr val="accent1"/>
+          </a:effectRef>
+          <a:fontRef idx="minor">
+            <a:schemeClr val="lt1"/>
+          </a:fontRef>
+        </p:style>
+        <p:txBody>
+          <a:bodyPr rtlCol="0" anchor="ctr"/>
+          <a:lstStyle/>
+          <a:p>
+            <a:pPr algn="ctr"/>
+            <a:endParaRPr lang="de-DE">
+              <a:solidFill>
+                <a:sysClr val="windowText" lastClr="000000"/>
+              </a:solidFill>
+            </a:endParaRPr>
+          </a:p>
+        </p:txBody>
+      </p:sp>
+      <p:sp>
+        <p:nvSpPr>
+          <p:cNvPr id="9" name="Ellipse 8">
+            <a:extLst>
+              <a:ext uri="{FF2B5EF4-FFF2-40B4-BE49-F238E27FC236}">
+                <a16:creationId xmlns:a16="http://schemas.microsoft.com/office/drawing/2014/main" id="{32EF8E7A-29F9-1B0D-AD5D-F0A2A4950141}"/>
+              </a:ext>
+            </a:extLst>
+          </p:cNvPr>
+          <p:cNvSpPr/>
+          <p:nvPr/>
+        </p:nvSpPr>
+        <p:spPr>
+          <a:xfrm>
+            <a:off x="2341080" y="2636159"/>
+            <a:ext cx="70030" cy="70030"/>
+          </a:xfrm>
+          <a:prstGeom prst="ellipse">
+            <a:avLst/>
+          </a:prstGeom>
+          <a:solidFill>
+            <a:schemeClr val="bg1"/>
+          </a:solidFill>
+          <a:ln w="12700">
+            <a:solidFill>
+              <a:schemeClr val="tx1"/>
+            </a:solidFill>
+          </a:ln>
+        </p:spPr>
+        <p:style>
+          <a:lnRef idx="2">
+            <a:schemeClr val="accent1">
+              <a:shade val="15000"/>
+            </a:schemeClr>
+          </a:lnRef>
+          <a:fillRef idx="1">
+            <a:schemeClr val="accent1"/>
+          </a:fillRef>
+          <a:effectRef idx="0">
+            <a:schemeClr val="accent1"/>
+          </a:effectRef>
+          <a:fontRef idx="minor">
+            <a:schemeClr val="lt1"/>
+          </a:fontRef>
+        </p:style>
+        <p:txBody>
+          <a:bodyPr rtlCol="0" anchor="ctr"/>
+          <a:lstStyle/>
+          <a:p>
+            <a:pPr algn="ctr"/>
+            <a:endParaRPr lang="de-DE">
+              <a:solidFill>
+                <a:sysClr val="windowText" lastClr="000000"/>
+              </a:solidFill>
+            </a:endParaRPr>
+          </a:p>
+        </p:txBody>
+      </p:sp>
+    </p:spTree>
+    <p:extLst>
+      <p:ext uri="{BB962C8B-B14F-4D97-AF65-F5344CB8AC3E}">
+        <p14:creationId xmlns:p14="http://schemas.microsoft.com/office/powerpoint/2010/main" val="3446423345"/>
       </p:ext>
     </p:extLst>
   </p:cSld>

</xml_diff>

<commit_message>
continued work on Grundlagen der Elektrotechnik
</commit_message>
<xml_diff>
--- a/B.Sc. LRT/Grundlagen der Elektrotechnik/images/ETech-Images.pptx
+++ b/B.Sc. LRT/Grundlagen der Elektrotechnik/images/ETech-Images.pptx
@@ -5,7 +5,7 @@
     <p:sldMasterId id="2147483660" r:id="rId1"/>
   </p:sldMasterIdLst>
   <p:notesMasterIdLst>
-    <p:notesMasterId r:id="rId9"/>
+    <p:notesMasterId r:id="rId12"/>
   </p:notesMasterIdLst>
   <p:sldIdLst>
     <p:sldId id="256" r:id="rId2"/>
@@ -15,6 +15,9 @@
     <p:sldId id="260" r:id="rId6"/>
     <p:sldId id="261" r:id="rId7"/>
     <p:sldId id="262" r:id="rId8"/>
+    <p:sldId id="263" r:id="rId9"/>
+    <p:sldId id="265" r:id="rId10"/>
+    <p:sldId id="264" r:id="rId11"/>
   </p:sldIdLst>
   <p:sldSz cx="3600450" cy="3600450"/>
   <p:notesSz cx="6858000" cy="9144000"/>
@@ -203,7 +206,7 @@
           <a:p>
             <a:fld id="{0C596C2D-C72C-406E-B79E-9BAC142DD20E}" type="datetimeFigureOut">
               <a:rPr lang="de-DE" smtClean="0"/>
-              <a:t>31.01.2026</a:t>
+              <a:t>11.02.2026</a:t>
             </a:fld>
             <a:endParaRPr lang="de-DE"/>
           </a:p>
@@ -601,7 +604,7 @@
           <a:p>
             <a:fld id="{6EAE28AA-0912-4DA0-8B30-7F3CA3FE6671}" type="datetimeFigureOut">
               <a:rPr lang="de-DE" smtClean="0"/>
-              <a:t>31.01.2026</a:t>
+              <a:t>11.02.2026</a:t>
             </a:fld>
             <a:endParaRPr lang="de-DE"/>
           </a:p>
@@ -771,7 +774,7 @@
           <a:p>
             <a:fld id="{6EAE28AA-0912-4DA0-8B30-7F3CA3FE6671}" type="datetimeFigureOut">
               <a:rPr lang="de-DE" smtClean="0"/>
-              <a:t>31.01.2026</a:t>
+              <a:t>11.02.2026</a:t>
             </a:fld>
             <a:endParaRPr lang="de-DE"/>
           </a:p>
@@ -951,7 +954,7 @@
           <a:p>
             <a:fld id="{6EAE28AA-0912-4DA0-8B30-7F3CA3FE6671}" type="datetimeFigureOut">
               <a:rPr lang="de-DE" smtClean="0"/>
-              <a:t>31.01.2026</a:t>
+              <a:t>11.02.2026</a:t>
             </a:fld>
             <a:endParaRPr lang="de-DE"/>
           </a:p>
@@ -1121,7 +1124,7 @@
           <a:p>
             <a:fld id="{6EAE28AA-0912-4DA0-8B30-7F3CA3FE6671}" type="datetimeFigureOut">
               <a:rPr lang="de-DE" smtClean="0"/>
-              <a:t>31.01.2026</a:t>
+              <a:t>11.02.2026</a:t>
             </a:fld>
             <a:endParaRPr lang="de-DE"/>
           </a:p>
@@ -1367,7 +1370,7 @@
           <a:p>
             <a:fld id="{6EAE28AA-0912-4DA0-8B30-7F3CA3FE6671}" type="datetimeFigureOut">
               <a:rPr lang="de-DE" smtClean="0"/>
-              <a:t>31.01.2026</a:t>
+              <a:t>11.02.2026</a:t>
             </a:fld>
             <a:endParaRPr lang="de-DE"/>
           </a:p>
@@ -1599,7 +1602,7 @@
           <a:p>
             <a:fld id="{6EAE28AA-0912-4DA0-8B30-7F3CA3FE6671}" type="datetimeFigureOut">
               <a:rPr lang="de-DE" smtClean="0"/>
-              <a:t>31.01.2026</a:t>
+              <a:t>11.02.2026</a:t>
             </a:fld>
             <a:endParaRPr lang="de-DE"/>
           </a:p>
@@ -1966,7 +1969,7 @@
           <a:p>
             <a:fld id="{6EAE28AA-0912-4DA0-8B30-7F3CA3FE6671}" type="datetimeFigureOut">
               <a:rPr lang="de-DE" smtClean="0"/>
-              <a:t>31.01.2026</a:t>
+              <a:t>11.02.2026</a:t>
             </a:fld>
             <a:endParaRPr lang="de-DE"/>
           </a:p>
@@ -2084,7 +2087,7 @@
           <a:p>
             <a:fld id="{6EAE28AA-0912-4DA0-8B30-7F3CA3FE6671}" type="datetimeFigureOut">
               <a:rPr lang="de-DE" smtClean="0"/>
-              <a:t>31.01.2026</a:t>
+              <a:t>11.02.2026</a:t>
             </a:fld>
             <a:endParaRPr lang="de-DE"/>
           </a:p>
@@ -2179,7 +2182,7 @@
           <a:p>
             <a:fld id="{6EAE28AA-0912-4DA0-8B30-7F3CA3FE6671}" type="datetimeFigureOut">
               <a:rPr lang="de-DE" smtClean="0"/>
-              <a:t>31.01.2026</a:t>
+              <a:t>11.02.2026</a:t>
             </a:fld>
             <a:endParaRPr lang="de-DE"/>
           </a:p>
@@ -2456,7 +2459,7 @@
           <a:p>
             <a:fld id="{6EAE28AA-0912-4DA0-8B30-7F3CA3FE6671}" type="datetimeFigureOut">
               <a:rPr lang="de-DE" smtClean="0"/>
-              <a:t>31.01.2026</a:t>
+              <a:t>11.02.2026</a:t>
             </a:fld>
             <a:endParaRPr lang="de-DE"/>
           </a:p>
@@ -2713,7 +2716,7 @@
           <a:p>
             <a:fld id="{6EAE28AA-0912-4DA0-8B30-7F3CA3FE6671}" type="datetimeFigureOut">
               <a:rPr lang="de-DE" smtClean="0"/>
-              <a:t>31.01.2026</a:t>
+              <a:t>11.02.2026</a:t>
             </a:fld>
             <a:endParaRPr lang="de-DE"/>
           </a:p>
@@ -2926,7 +2929,7 @@
           <a:p>
             <a:fld id="{6EAE28AA-0912-4DA0-8B30-7F3CA3FE6671}" type="datetimeFigureOut">
               <a:rPr lang="de-DE" smtClean="0"/>
-              <a:t>31.01.2026</a:t>
+              <a:t>11.02.2026</a:t>
             </a:fld>
             <a:endParaRPr lang="de-DE"/>
           </a:p>
@@ -4154,6 +4157,640 @@
 </p:sld>
 </file>
 
+<file path=ppt/slides/slide10.xml><?xml version="1.0" encoding="utf-8"?>
+<p:sld xmlns:a="http://schemas.openxmlformats.org/drawingml/2006/main" xmlns:r="http://schemas.openxmlformats.org/officeDocument/2006/relationships" xmlns:p="http://schemas.openxmlformats.org/presentationml/2006/main">
+  <p:cSld>
+    <p:spTree>
+      <p:nvGrpSpPr>
+        <p:cNvPr id="1" name="">
+          <a:extLst>
+            <a:ext uri="{FF2B5EF4-FFF2-40B4-BE49-F238E27FC236}">
+              <a16:creationId xmlns:a16="http://schemas.microsoft.com/office/drawing/2014/main" id="{59AF6BB8-6D1D-C6EF-674D-CF2A11B76646}"/>
+            </a:ext>
+          </a:extLst>
+        </p:cNvPr>
+        <p:cNvGrpSpPr/>
+        <p:nvPr/>
+      </p:nvGrpSpPr>
+      <p:grpSpPr>
+        <a:xfrm>
+          <a:off x="0" y="0"/>
+          <a:ext cx="0" cy="0"/>
+          <a:chOff x="0" y="0"/>
+          <a:chExt cx="0" cy="0"/>
+        </a:xfrm>
+      </p:grpSpPr>
+      <p:sp>
+        <p:nvSpPr>
+          <p:cNvPr id="19" name="Bogen 18">
+            <a:extLst>
+              <a:ext uri="{FF2B5EF4-FFF2-40B4-BE49-F238E27FC236}">
+                <a16:creationId xmlns:a16="http://schemas.microsoft.com/office/drawing/2014/main" id="{08B87E38-B585-D9F4-2D28-0DDF968FD2CB}"/>
+              </a:ext>
+            </a:extLst>
+          </p:cNvPr>
+          <p:cNvSpPr/>
+          <p:nvPr/>
+        </p:nvSpPr>
+        <p:spPr>
+          <a:xfrm>
+            <a:off x="886221" y="1509386"/>
+            <a:ext cx="1220493" cy="1220493"/>
+          </a:xfrm>
+          <a:prstGeom prst="arc">
+            <a:avLst>
+              <a:gd name="adj1" fmla="val 19392774"/>
+              <a:gd name="adj2" fmla="val 0"/>
+            </a:avLst>
+          </a:prstGeom>
+          <a:ln cap="rnd">
+            <a:solidFill>
+              <a:schemeClr val="accent5"/>
+            </a:solidFill>
+            <a:round/>
+            <a:headEnd type="triangle"/>
+          </a:ln>
+        </p:spPr>
+        <p:style>
+          <a:lnRef idx="2">
+            <a:schemeClr val="accent1"/>
+          </a:lnRef>
+          <a:fillRef idx="0">
+            <a:schemeClr val="accent1"/>
+          </a:fillRef>
+          <a:effectRef idx="1">
+            <a:schemeClr val="accent1"/>
+          </a:effectRef>
+          <a:fontRef idx="minor">
+            <a:schemeClr val="tx1"/>
+          </a:fontRef>
+        </p:style>
+        <p:txBody>
+          <a:bodyPr rtlCol="0" anchor="ctr"/>
+          <a:lstStyle/>
+          <a:p>
+            <a:pPr algn="ctr"/>
+            <a:endParaRPr lang="de-DE" sz="2400"/>
+          </a:p>
+        </p:txBody>
+      </p:sp>
+      <p:cxnSp>
+        <p:nvCxnSpPr>
+          <p:cNvPr id="8" name="Gerade Verbindung mit Pfeil 7">
+            <a:extLst>
+              <a:ext uri="{FF2B5EF4-FFF2-40B4-BE49-F238E27FC236}">
+                <a16:creationId xmlns:a16="http://schemas.microsoft.com/office/drawing/2014/main" id="{6D4BA143-2EE3-B62E-3811-EC5C2C16CD3F}"/>
+              </a:ext>
+            </a:extLst>
+          </p:cNvPr>
+          <p:cNvCxnSpPr>
+            <a:cxnSpLocks/>
+          </p:cNvCxnSpPr>
+          <p:nvPr/>
+        </p:nvCxnSpPr>
+        <p:spPr>
+          <a:xfrm flipV="1">
+            <a:off x="1496469" y="1512518"/>
+            <a:ext cx="799680" cy="607121"/>
+          </a:xfrm>
+          <a:prstGeom prst="straightConnector1">
+            <a:avLst/>
+          </a:prstGeom>
+          <a:ln cap="rnd">
+            <a:solidFill>
+              <a:srgbClr val="086FBD"/>
+            </a:solidFill>
+            <a:round/>
+            <a:tailEnd type="triangle" w="med" len="med"/>
+          </a:ln>
+        </p:spPr>
+        <p:style>
+          <a:lnRef idx="2">
+            <a:schemeClr val="accent1"/>
+          </a:lnRef>
+          <a:fillRef idx="0">
+            <a:schemeClr val="accent1"/>
+          </a:fillRef>
+          <a:effectRef idx="1">
+            <a:schemeClr val="accent1"/>
+          </a:effectRef>
+          <a:fontRef idx="minor">
+            <a:schemeClr val="tx1"/>
+          </a:fontRef>
+        </p:style>
+      </p:cxnSp>
+      <p:cxnSp>
+        <p:nvCxnSpPr>
+          <p:cNvPr id="10" name="Gerade Verbindung mit Pfeil 9">
+            <a:extLst>
+              <a:ext uri="{FF2B5EF4-FFF2-40B4-BE49-F238E27FC236}">
+                <a16:creationId xmlns:a16="http://schemas.microsoft.com/office/drawing/2014/main" id="{78FA873B-332F-2A4F-5031-351A55B64ECE}"/>
+              </a:ext>
+            </a:extLst>
+          </p:cNvPr>
+          <p:cNvCxnSpPr>
+            <a:cxnSpLocks/>
+          </p:cNvCxnSpPr>
+          <p:nvPr/>
+        </p:nvCxnSpPr>
+        <p:spPr>
+          <a:xfrm flipV="1">
+            <a:off x="1496468" y="1675356"/>
+            <a:ext cx="585195" cy="444283"/>
+          </a:xfrm>
+          <a:prstGeom prst="straightConnector1">
+            <a:avLst/>
+          </a:prstGeom>
+          <a:ln w="19050" cap="rnd">
+            <a:solidFill>
+              <a:srgbClr val="FF0000"/>
+            </a:solidFill>
+            <a:round/>
+            <a:tailEnd type="triangle" w="med" len="med"/>
+          </a:ln>
+        </p:spPr>
+        <p:style>
+          <a:lnRef idx="2">
+            <a:schemeClr val="accent1"/>
+          </a:lnRef>
+          <a:fillRef idx="0">
+            <a:schemeClr val="accent1"/>
+          </a:fillRef>
+          <a:effectRef idx="1">
+            <a:schemeClr val="accent1"/>
+          </a:effectRef>
+          <a:fontRef idx="minor">
+            <a:schemeClr val="tx1"/>
+          </a:fontRef>
+        </p:style>
+      </p:cxnSp>
+      <p:cxnSp>
+        <p:nvCxnSpPr>
+          <p:cNvPr id="5" name="Gerade Verbindung mit Pfeil 4">
+            <a:extLst>
+              <a:ext uri="{FF2B5EF4-FFF2-40B4-BE49-F238E27FC236}">
+                <a16:creationId xmlns:a16="http://schemas.microsoft.com/office/drawing/2014/main" id="{F4CAB231-1972-25BB-D11C-0014B56F43F2}"/>
+              </a:ext>
+            </a:extLst>
+          </p:cNvPr>
+          <p:cNvCxnSpPr>
+            <a:cxnSpLocks/>
+          </p:cNvCxnSpPr>
+          <p:nvPr/>
+        </p:nvCxnSpPr>
+        <p:spPr>
+          <a:xfrm flipV="1">
+            <a:off x="1496469" y="1090939"/>
+            <a:ext cx="0" cy="1373557"/>
+          </a:xfrm>
+          <a:prstGeom prst="straightConnector1">
+            <a:avLst/>
+          </a:prstGeom>
+          <a:ln cap="rnd">
+            <a:solidFill>
+              <a:schemeClr val="tx1"/>
+            </a:solidFill>
+            <a:round/>
+            <a:tailEnd type="triangle" w="med" len="med"/>
+          </a:ln>
+        </p:spPr>
+        <p:style>
+          <a:lnRef idx="2">
+            <a:schemeClr val="accent1"/>
+          </a:lnRef>
+          <a:fillRef idx="0">
+            <a:schemeClr val="accent1"/>
+          </a:fillRef>
+          <a:effectRef idx="1">
+            <a:schemeClr val="accent1"/>
+          </a:effectRef>
+          <a:fontRef idx="minor">
+            <a:schemeClr val="tx1"/>
+          </a:fontRef>
+        </p:style>
+      </p:cxnSp>
+      <p:cxnSp>
+        <p:nvCxnSpPr>
+          <p:cNvPr id="6" name="Gerade Verbindung mit Pfeil 5">
+            <a:extLst>
+              <a:ext uri="{FF2B5EF4-FFF2-40B4-BE49-F238E27FC236}">
+                <a16:creationId xmlns:a16="http://schemas.microsoft.com/office/drawing/2014/main" id="{8C88241A-EB7B-07A8-F278-E5DA0AAFA51F}"/>
+              </a:ext>
+            </a:extLst>
+          </p:cNvPr>
+          <p:cNvCxnSpPr>
+            <a:cxnSpLocks/>
+          </p:cNvCxnSpPr>
+          <p:nvPr/>
+        </p:nvCxnSpPr>
+        <p:spPr>
+          <a:xfrm>
+            <a:off x="1030266" y="2119639"/>
+            <a:ext cx="1500513" cy="0"/>
+          </a:xfrm>
+          <a:prstGeom prst="straightConnector1">
+            <a:avLst/>
+          </a:prstGeom>
+          <a:ln cap="rnd">
+            <a:solidFill>
+              <a:schemeClr val="tx1"/>
+            </a:solidFill>
+            <a:round/>
+            <a:tailEnd type="triangle" w="med" len="med"/>
+          </a:ln>
+        </p:spPr>
+        <p:style>
+          <a:lnRef idx="2">
+            <a:schemeClr val="accent1"/>
+          </a:lnRef>
+          <a:fillRef idx="0">
+            <a:schemeClr val="accent1"/>
+          </a:fillRef>
+          <a:effectRef idx="1">
+            <a:schemeClr val="accent1"/>
+          </a:effectRef>
+          <a:fontRef idx="minor">
+            <a:schemeClr val="tx1"/>
+          </a:fontRef>
+        </p:style>
+      </p:cxnSp>
+      <p:sp>
+        <p:nvSpPr>
+          <p:cNvPr id="13" name="Textfeld 12">
+            <a:extLst>
+              <a:ext uri="{FF2B5EF4-FFF2-40B4-BE49-F238E27FC236}">
+                <a16:creationId xmlns:a16="http://schemas.microsoft.com/office/drawing/2014/main" id="{00444581-34A9-6C9F-1461-BEA3B7AA5AB4}"/>
+              </a:ext>
+            </a:extLst>
+          </p:cNvPr>
+          <p:cNvSpPr txBox="1"/>
+          <p:nvPr/>
+        </p:nvSpPr>
+        <p:spPr>
+          <a:xfrm>
+            <a:off x="1962673" y="1128418"/>
+            <a:ext cx="567731" cy="307777"/>
+          </a:xfrm>
+          <a:prstGeom prst="rect">
+            <a:avLst/>
+          </a:prstGeom>
+          <a:noFill/>
+        </p:spPr>
+        <p:txBody>
+          <a:bodyPr wrap="square" rtlCol="0">
+            <a:spAutoFit/>
+          </a:bodyPr>
+          <a:lstStyle/>
+          <a:p>
+            <a:pPr algn="ctr"/>
+            <a:r>
+              <a:rPr lang="de-DE" sz="1400" i="1" dirty="0" err="1">
+                <a:solidFill>
+                  <a:srgbClr val="086FBD"/>
+                </a:solidFill>
+                <a:latin typeface="CMU Serif" panose="02000603000000000000" pitchFamily="2" charset="0"/>
+                <a:ea typeface="CMU Serif" panose="02000603000000000000" pitchFamily="2" charset="0"/>
+                <a:cs typeface="CMU Serif" panose="02000603000000000000" pitchFamily="2" charset="0"/>
+              </a:rPr>
+              <a:t>u</a:t>
+            </a:r>
+            <a:r>
+              <a:rPr lang="de-DE" sz="1400" i="1" baseline="-25000" dirty="0" err="1">
+                <a:solidFill>
+                  <a:srgbClr val="086FBD"/>
+                </a:solidFill>
+                <a:latin typeface="CMU Serif" panose="02000603000000000000" pitchFamily="2" charset="0"/>
+                <a:ea typeface="CMU Serif" panose="02000603000000000000" pitchFamily="2" charset="0"/>
+                <a:cs typeface="CMU Serif" panose="02000603000000000000" pitchFamily="2" charset="0"/>
+              </a:rPr>
+              <a:t>R</a:t>
+            </a:r>
+            <a:r>
+              <a:rPr lang="de-DE" sz="1400" dirty="0">
+                <a:solidFill>
+                  <a:srgbClr val="086FBD"/>
+                </a:solidFill>
+                <a:latin typeface="CMU Serif" panose="02000603000000000000" pitchFamily="2" charset="0"/>
+                <a:ea typeface="CMU Serif" panose="02000603000000000000" pitchFamily="2" charset="0"/>
+                <a:cs typeface="CMU Serif" panose="02000603000000000000" pitchFamily="2" charset="0"/>
+              </a:rPr>
+              <a:t>(</a:t>
+            </a:r>
+            <a:r>
+              <a:rPr lang="de-DE" sz="1400" i="1" dirty="0">
+                <a:solidFill>
+                  <a:srgbClr val="086FBD"/>
+                </a:solidFill>
+                <a:latin typeface="CMU Serif" panose="02000603000000000000" pitchFamily="2" charset="0"/>
+                <a:ea typeface="CMU Serif" panose="02000603000000000000" pitchFamily="2" charset="0"/>
+                <a:cs typeface="CMU Serif" panose="02000603000000000000" pitchFamily="2" charset="0"/>
+              </a:rPr>
+              <a:t>t</a:t>
+            </a:r>
+            <a:r>
+              <a:rPr lang="de-DE" sz="1400" dirty="0">
+                <a:solidFill>
+                  <a:srgbClr val="086FBD"/>
+                </a:solidFill>
+                <a:latin typeface="CMU Serif" panose="02000603000000000000" pitchFamily="2" charset="0"/>
+                <a:ea typeface="CMU Serif" panose="02000603000000000000" pitchFamily="2" charset="0"/>
+                <a:cs typeface="CMU Serif" panose="02000603000000000000" pitchFamily="2" charset="0"/>
+              </a:rPr>
+              <a:t>)</a:t>
+            </a:r>
+            <a:endParaRPr lang="de-DE" sz="1400" baseline="-25000" dirty="0">
+              <a:solidFill>
+                <a:srgbClr val="086FBD"/>
+              </a:solidFill>
+              <a:latin typeface="CMU Serif" panose="02000603000000000000" pitchFamily="2" charset="0"/>
+              <a:ea typeface="CMU Serif" panose="02000603000000000000" pitchFamily="2" charset="0"/>
+              <a:cs typeface="CMU Serif" panose="02000603000000000000" pitchFamily="2" charset="0"/>
+            </a:endParaRPr>
+          </a:p>
+        </p:txBody>
+      </p:sp>
+      <p:sp>
+        <p:nvSpPr>
+          <p:cNvPr id="14" name="Textfeld 13">
+            <a:extLst>
+              <a:ext uri="{FF2B5EF4-FFF2-40B4-BE49-F238E27FC236}">
+                <a16:creationId xmlns:a16="http://schemas.microsoft.com/office/drawing/2014/main" id="{5567ECA1-FAB2-D0BD-2641-FE47C133A964}"/>
+              </a:ext>
+            </a:extLst>
+          </p:cNvPr>
+          <p:cNvSpPr txBox="1"/>
+          <p:nvPr/>
+        </p:nvSpPr>
+        <p:spPr>
+          <a:xfrm>
+            <a:off x="1529673" y="1365291"/>
+            <a:ext cx="518786" cy="307777"/>
+          </a:xfrm>
+          <a:prstGeom prst="rect">
+            <a:avLst/>
+          </a:prstGeom>
+          <a:noFill/>
+        </p:spPr>
+        <p:txBody>
+          <a:bodyPr wrap="square" rtlCol="0">
+            <a:spAutoFit/>
+          </a:bodyPr>
+          <a:lstStyle/>
+          <a:p>
+            <a:pPr algn="ctr"/>
+            <a:r>
+              <a:rPr lang="de-DE" sz="1400" i="1" dirty="0" err="1">
+                <a:solidFill>
+                  <a:srgbClr val="FF0000"/>
+                </a:solidFill>
+                <a:latin typeface="CMU Serif" panose="02000603000000000000" pitchFamily="2" charset="0"/>
+                <a:ea typeface="CMU Serif" panose="02000603000000000000" pitchFamily="2" charset="0"/>
+                <a:cs typeface="CMU Serif" panose="02000603000000000000" pitchFamily="2" charset="0"/>
+              </a:rPr>
+              <a:t>i</a:t>
+            </a:r>
+            <a:r>
+              <a:rPr lang="de-DE" sz="1400" i="1" baseline="-25000" dirty="0" err="1">
+                <a:solidFill>
+                  <a:srgbClr val="FF0000"/>
+                </a:solidFill>
+                <a:latin typeface="CMU Serif" panose="02000603000000000000" pitchFamily="2" charset="0"/>
+                <a:ea typeface="CMU Serif" panose="02000603000000000000" pitchFamily="2" charset="0"/>
+                <a:cs typeface="CMU Serif" panose="02000603000000000000" pitchFamily="2" charset="0"/>
+              </a:rPr>
+              <a:t>R</a:t>
+            </a:r>
+            <a:r>
+              <a:rPr lang="de-DE" sz="1400" dirty="0">
+                <a:solidFill>
+                  <a:srgbClr val="FF0000"/>
+                </a:solidFill>
+                <a:latin typeface="CMU Serif" panose="02000603000000000000" pitchFamily="2" charset="0"/>
+                <a:ea typeface="CMU Serif" panose="02000603000000000000" pitchFamily="2" charset="0"/>
+                <a:cs typeface="CMU Serif" panose="02000603000000000000" pitchFamily="2" charset="0"/>
+              </a:rPr>
+              <a:t>(</a:t>
+            </a:r>
+            <a:r>
+              <a:rPr lang="de-DE" sz="1400" i="1" dirty="0">
+                <a:solidFill>
+                  <a:srgbClr val="FF0000"/>
+                </a:solidFill>
+                <a:latin typeface="CMU Serif" panose="02000603000000000000" pitchFamily="2" charset="0"/>
+                <a:ea typeface="CMU Serif" panose="02000603000000000000" pitchFamily="2" charset="0"/>
+                <a:cs typeface="CMU Serif" panose="02000603000000000000" pitchFamily="2" charset="0"/>
+              </a:rPr>
+              <a:t>t</a:t>
+            </a:r>
+            <a:r>
+              <a:rPr lang="de-DE" sz="1400" dirty="0">
+                <a:solidFill>
+                  <a:srgbClr val="FF0000"/>
+                </a:solidFill>
+                <a:latin typeface="CMU Serif" panose="02000603000000000000" pitchFamily="2" charset="0"/>
+                <a:ea typeface="CMU Serif" panose="02000603000000000000" pitchFamily="2" charset="0"/>
+                <a:cs typeface="CMU Serif" panose="02000603000000000000" pitchFamily="2" charset="0"/>
+              </a:rPr>
+              <a:t>)</a:t>
+            </a:r>
+            <a:endParaRPr lang="de-DE" sz="1400" baseline="-25000" dirty="0">
+              <a:solidFill>
+                <a:srgbClr val="FF0000"/>
+              </a:solidFill>
+              <a:latin typeface="CMU Serif" panose="02000603000000000000" pitchFamily="2" charset="0"/>
+              <a:ea typeface="CMU Serif" panose="02000603000000000000" pitchFamily="2" charset="0"/>
+              <a:cs typeface="CMU Serif" panose="02000603000000000000" pitchFamily="2" charset="0"/>
+            </a:endParaRPr>
+          </a:p>
+        </p:txBody>
+      </p:sp>
+      <p:sp>
+        <p:nvSpPr>
+          <p:cNvPr id="20" name="Textfeld 19">
+            <a:extLst>
+              <a:ext uri="{FF2B5EF4-FFF2-40B4-BE49-F238E27FC236}">
+                <a16:creationId xmlns:a16="http://schemas.microsoft.com/office/drawing/2014/main" id="{BBBA25C8-E09A-BD18-E42B-2B5C98856BD4}"/>
+              </a:ext>
+            </a:extLst>
+          </p:cNvPr>
+          <p:cNvSpPr txBox="1"/>
+          <p:nvPr/>
+        </p:nvSpPr>
+        <p:spPr>
+          <a:xfrm>
+            <a:off x="2070746" y="1767541"/>
+            <a:ext cx="518786" cy="307777"/>
+          </a:xfrm>
+          <a:prstGeom prst="rect">
+            <a:avLst/>
+          </a:prstGeom>
+          <a:noFill/>
+        </p:spPr>
+        <p:txBody>
+          <a:bodyPr wrap="square" rtlCol="0">
+            <a:spAutoFit/>
+          </a:bodyPr>
+          <a:lstStyle/>
+          <a:p>
+            <a:pPr algn="ctr"/>
+            <a:r>
+              <a:rPr lang="de-DE" sz="1400" i="1" dirty="0">
+                <a:solidFill>
+                  <a:schemeClr val="accent5"/>
+                </a:solidFill>
+                <a:latin typeface="Latin Modern Math" panose="02000503000000000000" pitchFamily="50" charset="0"/>
+                <a:ea typeface="Latin Modern Math" panose="02000503000000000000" pitchFamily="50" charset="0"/>
+                <a:cs typeface="CMU Serif" panose="02000603000000000000" pitchFamily="2" charset="0"/>
+              </a:rPr>
+              <a:t>ω </a:t>
+            </a:r>
+            <a:r>
+              <a:rPr lang="de-DE" sz="600" dirty="0">
+                <a:solidFill>
+                  <a:schemeClr val="accent5"/>
+                </a:solidFill>
+                <a:latin typeface="Latin Modern Math" panose="02000503000000000000" pitchFamily="50" charset="0"/>
+                <a:ea typeface="Latin Modern Math" panose="02000503000000000000" pitchFamily="50" charset="0"/>
+                <a:cs typeface="CMU Serif" panose="02000603000000000000" pitchFamily="2" charset="0"/>
+              </a:rPr>
+              <a:t>∙</a:t>
+            </a:r>
+            <a:r>
+              <a:rPr lang="de-DE" sz="1400" i="1" dirty="0">
+                <a:solidFill>
+                  <a:schemeClr val="accent5"/>
+                </a:solidFill>
+                <a:latin typeface="Latin Modern Math" panose="02000503000000000000" pitchFamily="50" charset="0"/>
+                <a:ea typeface="Latin Modern Math" panose="02000503000000000000" pitchFamily="50" charset="0"/>
+                <a:cs typeface="CMU Serif" panose="02000603000000000000" pitchFamily="2" charset="0"/>
+              </a:rPr>
+              <a:t> </a:t>
+            </a:r>
+            <a:r>
+              <a:rPr lang="de-DE" sz="1400" i="1" dirty="0">
+                <a:solidFill>
+                  <a:schemeClr val="accent5"/>
+                </a:solidFill>
+                <a:latin typeface="CMU Serif" panose="02000603000000000000" pitchFamily="2" charset="0"/>
+                <a:ea typeface="CMU Serif" panose="02000603000000000000" pitchFamily="2" charset="0"/>
+                <a:cs typeface="CMU Serif" panose="02000603000000000000" pitchFamily="2" charset="0"/>
+              </a:rPr>
+              <a:t>t</a:t>
+            </a:r>
+            <a:endParaRPr lang="de-DE" sz="1400" baseline="-25000" dirty="0">
+              <a:solidFill>
+                <a:schemeClr val="accent5"/>
+              </a:solidFill>
+              <a:latin typeface="CMU Serif" panose="02000603000000000000" pitchFamily="2" charset="0"/>
+              <a:ea typeface="CMU Serif" panose="02000603000000000000" pitchFamily="2" charset="0"/>
+              <a:cs typeface="CMU Serif" panose="02000603000000000000" pitchFamily="2" charset="0"/>
+            </a:endParaRPr>
+          </a:p>
+        </p:txBody>
+      </p:sp>
+      <p:sp>
+        <p:nvSpPr>
+          <p:cNvPr id="23" name="Textfeld 22">
+            <a:extLst>
+              <a:ext uri="{FF2B5EF4-FFF2-40B4-BE49-F238E27FC236}">
+                <a16:creationId xmlns:a16="http://schemas.microsoft.com/office/drawing/2014/main" id="{9C5DCC1C-22C1-3F97-9C39-05A26C30324A}"/>
+              </a:ext>
+            </a:extLst>
+          </p:cNvPr>
+          <p:cNvSpPr txBox="1"/>
+          <p:nvPr/>
+        </p:nvSpPr>
+        <p:spPr>
+          <a:xfrm>
+            <a:off x="2198035" y="2176651"/>
+            <a:ext cx="518786" cy="253916"/>
+          </a:xfrm>
+          <a:prstGeom prst="rect">
+            <a:avLst/>
+          </a:prstGeom>
+          <a:noFill/>
+        </p:spPr>
+        <p:txBody>
+          <a:bodyPr wrap="square" rtlCol="0">
+            <a:spAutoFit/>
+          </a:bodyPr>
+          <a:lstStyle/>
+          <a:p>
+            <a:pPr algn="ctr"/>
+            <a:r>
+              <a:rPr lang="de-DE" sz="1050" dirty="0">
+                <a:latin typeface="CMU Serif" panose="02000603000000000000" pitchFamily="2" charset="0"/>
+                <a:ea typeface="CMU Serif" panose="02000603000000000000" pitchFamily="2" charset="0"/>
+                <a:cs typeface="CMU Serif" panose="02000603000000000000" pitchFamily="2" charset="0"/>
+              </a:rPr>
+              <a:t>Re</a:t>
+            </a:r>
+            <a:endParaRPr lang="de-DE" sz="1050" baseline="-25000" dirty="0">
+              <a:latin typeface="CMU Serif" panose="02000603000000000000" pitchFamily="2" charset="0"/>
+              <a:ea typeface="CMU Serif" panose="02000603000000000000" pitchFamily="2" charset="0"/>
+              <a:cs typeface="CMU Serif" panose="02000603000000000000" pitchFamily="2" charset="0"/>
+            </a:endParaRPr>
+          </a:p>
+        </p:txBody>
+      </p:sp>
+      <p:sp>
+        <p:nvSpPr>
+          <p:cNvPr id="24" name="Textfeld 23">
+            <a:extLst>
+              <a:ext uri="{FF2B5EF4-FFF2-40B4-BE49-F238E27FC236}">
+                <a16:creationId xmlns:a16="http://schemas.microsoft.com/office/drawing/2014/main" id="{489D902E-FAF1-FB79-0651-3A5F65789A6B}"/>
+              </a:ext>
+            </a:extLst>
+          </p:cNvPr>
+          <p:cNvSpPr txBox="1"/>
+          <p:nvPr/>
+        </p:nvSpPr>
+        <p:spPr>
+          <a:xfrm>
+            <a:off x="1071759" y="1053040"/>
+            <a:ext cx="518786" cy="253916"/>
+          </a:xfrm>
+          <a:prstGeom prst="rect">
+            <a:avLst/>
+          </a:prstGeom>
+          <a:noFill/>
+        </p:spPr>
+        <p:txBody>
+          <a:bodyPr wrap="square" rtlCol="0">
+            <a:spAutoFit/>
+          </a:bodyPr>
+          <a:lstStyle/>
+          <a:p>
+            <a:pPr algn="ctr"/>
+            <a:r>
+              <a:rPr lang="de-DE" sz="1050" dirty="0">
+                <a:latin typeface="CMU Serif" panose="02000603000000000000" pitchFamily="2" charset="0"/>
+                <a:ea typeface="CMU Serif" panose="02000603000000000000" pitchFamily="2" charset="0"/>
+                <a:cs typeface="CMU Serif" panose="02000603000000000000" pitchFamily="2" charset="0"/>
+              </a:rPr>
+              <a:t>Im</a:t>
+            </a:r>
+            <a:endParaRPr lang="de-DE" sz="1050" baseline="-25000" dirty="0">
+              <a:latin typeface="CMU Serif" panose="02000603000000000000" pitchFamily="2" charset="0"/>
+              <a:ea typeface="CMU Serif" panose="02000603000000000000" pitchFamily="2" charset="0"/>
+              <a:cs typeface="CMU Serif" panose="02000603000000000000" pitchFamily="2" charset="0"/>
+            </a:endParaRPr>
+          </a:p>
+        </p:txBody>
+      </p:sp>
+    </p:spTree>
+    <p:extLst>
+      <p:ext uri="{BB962C8B-B14F-4D97-AF65-F5344CB8AC3E}">
+        <p14:creationId xmlns:p14="http://schemas.microsoft.com/office/powerpoint/2010/main" val="3996414772"/>
+      </p:ext>
+    </p:extLst>
+  </p:cSld>
+  <p:clrMapOvr>
+    <a:masterClrMapping/>
+  </p:clrMapOvr>
+</p:sld>
+</file>
+
 <file path=ppt/slides/slide2.xml><?xml version="1.0" encoding="utf-8"?>
 <p:sld xmlns:a="http://schemas.openxmlformats.org/drawingml/2006/main" xmlns:r="http://schemas.openxmlformats.org/officeDocument/2006/relationships" xmlns:p="http://schemas.openxmlformats.org/presentationml/2006/main">
   <p:cSld>
@@ -10465,6 +11102,1814 @@
     <p:extLst>
       <p:ext uri="{BB962C8B-B14F-4D97-AF65-F5344CB8AC3E}">
         <p14:creationId xmlns:p14="http://schemas.microsoft.com/office/powerpoint/2010/main" val="2468398840"/>
+      </p:ext>
+    </p:extLst>
+  </p:cSld>
+  <p:clrMapOvr>
+    <a:masterClrMapping/>
+  </p:clrMapOvr>
+</p:sld>
+</file>
+
+<file path=ppt/slides/slide8.xml><?xml version="1.0" encoding="utf-8"?>
+<p:sld xmlns:a="http://schemas.openxmlformats.org/drawingml/2006/main" xmlns:r="http://schemas.openxmlformats.org/officeDocument/2006/relationships" xmlns:p="http://schemas.openxmlformats.org/presentationml/2006/main">
+  <p:cSld>
+    <p:spTree>
+      <p:nvGrpSpPr>
+        <p:cNvPr id="1" name=""/>
+        <p:cNvGrpSpPr/>
+        <p:nvPr/>
+      </p:nvGrpSpPr>
+      <p:grpSpPr>
+        <a:xfrm>
+          <a:off x="0" y="0"/>
+          <a:ext cx="0" cy="0"/>
+          <a:chOff x="0" y="0"/>
+          <a:chExt cx="0" cy="0"/>
+        </a:xfrm>
+      </p:grpSpPr>
+      <p:sp>
+        <p:nvSpPr>
+          <p:cNvPr id="19" name="Bogen 18">
+            <a:extLst>
+              <a:ext uri="{FF2B5EF4-FFF2-40B4-BE49-F238E27FC236}">
+                <a16:creationId xmlns:a16="http://schemas.microsoft.com/office/drawing/2014/main" id="{32D897D1-A58C-9EA1-8E24-A0499319FD91}"/>
+              </a:ext>
+            </a:extLst>
+          </p:cNvPr>
+          <p:cNvSpPr/>
+          <p:nvPr/>
+        </p:nvSpPr>
+        <p:spPr>
+          <a:xfrm>
+            <a:off x="886221" y="1509386"/>
+            <a:ext cx="1220493" cy="1220493"/>
+          </a:xfrm>
+          <a:prstGeom prst="arc">
+            <a:avLst>
+              <a:gd name="adj1" fmla="val 19392774"/>
+              <a:gd name="adj2" fmla="val 0"/>
+            </a:avLst>
+          </a:prstGeom>
+          <a:ln cap="rnd">
+            <a:solidFill>
+              <a:schemeClr val="accent5"/>
+            </a:solidFill>
+            <a:round/>
+            <a:headEnd type="triangle"/>
+          </a:ln>
+        </p:spPr>
+        <p:style>
+          <a:lnRef idx="2">
+            <a:schemeClr val="accent1"/>
+          </a:lnRef>
+          <a:fillRef idx="0">
+            <a:schemeClr val="accent1"/>
+          </a:fillRef>
+          <a:effectRef idx="1">
+            <a:schemeClr val="accent1"/>
+          </a:effectRef>
+          <a:fontRef idx="minor">
+            <a:schemeClr val="tx1"/>
+          </a:fontRef>
+        </p:style>
+        <p:txBody>
+          <a:bodyPr rtlCol="0" anchor="ctr"/>
+          <a:lstStyle/>
+          <a:p>
+            <a:pPr algn="ctr"/>
+            <a:endParaRPr lang="de-DE" sz="2400"/>
+          </a:p>
+        </p:txBody>
+      </p:sp>
+      <p:cxnSp>
+        <p:nvCxnSpPr>
+          <p:cNvPr id="8" name="Gerade Verbindung mit Pfeil 7">
+            <a:extLst>
+              <a:ext uri="{FF2B5EF4-FFF2-40B4-BE49-F238E27FC236}">
+                <a16:creationId xmlns:a16="http://schemas.microsoft.com/office/drawing/2014/main" id="{6D54BD36-1AE9-A686-89F3-921009DE2088}"/>
+              </a:ext>
+            </a:extLst>
+          </p:cNvPr>
+          <p:cNvCxnSpPr>
+            <a:cxnSpLocks/>
+          </p:cNvCxnSpPr>
+          <p:nvPr/>
+        </p:nvCxnSpPr>
+        <p:spPr>
+          <a:xfrm flipV="1">
+            <a:off x="1496469" y="1512518"/>
+            <a:ext cx="799680" cy="607121"/>
+          </a:xfrm>
+          <a:prstGeom prst="straightConnector1">
+            <a:avLst/>
+          </a:prstGeom>
+          <a:ln cap="rnd">
+            <a:solidFill>
+              <a:srgbClr val="086FBD"/>
+            </a:solidFill>
+            <a:round/>
+            <a:tailEnd type="triangle" w="med" len="med"/>
+          </a:ln>
+        </p:spPr>
+        <p:style>
+          <a:lnRef idx="2">
+            <a:schemeClr val="accent1"/>
+          </a:lnRef>
+          <a:fillRef idx="0">
+            <a:schemeClr val="accent1"/>
+          </a:fillRef>
+          <a:effectRef idx="1">
+            <a:schemeClr val="accent1"/>
+          </a:effectRef>
+          <a:fontRef idx="minor">
+            <a:schemeClr val="tx1"/>
+          </a:fontRef>
+        </p:style>
+      </p:cxnSp>
+      <p:cxnSp>
+        <p:nvCxnSpPr>
+          <p:cNvPr id="10" name="Gerade Verbindung mit Pfeil 9">
+            <a:extLst>
+              <a:ext uri="{FF2B5EF4-FFF2-40B4-BE49-F238E27FC236}">
+                <a16:creationId xmlns:a16="http://schemas.microsoft.com/office/drawing/2014/main" id="{446A8EAF-64B5-B741-9CB0-99EB813D60FD}"/>
+              </a:ext>
+            </a:extLst>
+          </p:cNvPr>
+          <p:cNvCxnSpPr>
+            <a:cxnSpLocks/>
+          </p:cNvCxnSpPr>
+          <p:nvPr/>
+        </p:nvCxnSpPr>
+        <p:spPr>
+          <a:xfrm flipV="1">
+            <a:off x="1496468" y="1675356"/>
+            <a:ext cx="585195" cy="444283"/>
+          </a:xfrm>
+          <a:prstGeom prst="straightConnector1">
+            <a:avLst/>
+          </a:prstGeom>
+          <a:ln w="19050" cap="rnd">
+            <a:solidFill>
+              <a:srgbClr val="FF0000"/>
+            </a:solidFill>
+            <a:round/>
+            <a:tailEnd type="triangle" w="med" len="med"/>
+          </a:ln>
+        </p:spPr>
+        <p:style>
+          <a:lnRef idx="2">
+            <a:schemeClr val="accent1"/>
+          </a:lnRef>
+          <a:fillRef idx="0">
+            <a:schemeClr val="accent1"/>
+          </a:fillRef>
+          <a:effectRef idx="1">
+            <a:schemeClr val="accent1"/>
+          </a:effectRef>
+          <a:fontRef idx="minor">
+            <a:schemeClr val="tx1"/>
+          </a:fontRef>
+        </p:style>
+      </p:cxnSp>
+      <p:cxnSp>
+        <p:nvCxnSpPr>
+          <p:cNvPr id="5" name="Gerade Verbindung mit Pfeil 4">
+            <a:extLst>
+              <a:ext uri="{FF2B5EF4-FFF2-40B4-BE49-F238E27FC236}">
+                <a16:creationId xmlns:a16="http://schemas.microsoft.com/office/drawing/2014/main" id="{98E931C8-5F1B-74D5-918C-5E1A1E4AEC60}"/>
+              </a:ext>
+            </a:extLst>
+          </p:cNvPr>
+          <p:cNvCxnSpPr>
+            <a:cxnSpLocks/>
+          </p:cNvCxnSpPr>
+          <p:nvPr/>
+        </p:nvCxnSpPr>
+        <p:spPr>
+          <a:xfrm flipV="1">
+            <a:off x="1496469" y="1090939"/>
+            <a:ext cx="0" cy="1373557"/>
+          </a:xfrm>
+          <a:prstGeom prst="straightConnector1">
+            <a:avLst/>
+          </a:prstGeom>
+          <a:ln cap="rnd">
+            <a:solidFill>
+              <a:schemeClr val="tx1"/>
+            </a:solidFill>
+            <a:round/>
+            <a:tailEnd type="triangle" w="med" len="med"/>
+          </a:ln>
+        </p:spPr>
+        <p:style>
+          <a:lnRef idx="2">
+            <a:schemeClr val="accent1"/>
+          </a:lnRef>
+          <a:fillRef idx="0">
+            <a:schemeClr val="accent1"/>
+          </a:fillRef>
+          <a:effectRef idx="1">
+            <a:schemeClr val="accent1"/>
+          </a:effectRef>
+          <a:fontRef idx="minor">
+            <a:schemeClr val="tx1"/>
+          </a:fontRef>
+        </p:style>
+      </p:cxnSp>
+      <p:cxnSp>
+        <p:nvCxnSpPr>
+          <p:cNvPr id="6" name="Gerade Verbindung mit Pfeil 5">
+            <a:extLst>
+              <a:ext uri="{FF2B5EF4-FFF2-40B4-BE49-F238E27FC236}">
+                <a16:creationId xmlns:a16="http://schemas.microsoft.com/office/drawing/2014/main" id="{39186656-9B14-D2F3-0DB3-5EDAC43EDE6A}"/>
+              </a:ext>
+            </a:extLst>
+          </p:cNvPr>
+          <p:cNvCxnSpPr>
+            <a:cxnSpLocks/>
+          </p:cNvCxnSpPr>
+          <p:nvPr/>
+        </p:nvCxnSpPr>
+        <p:spPr>
+          <a:xfrm>
+            <a:off x="1030266" y="2119639"/>
+            <a:ext cx="1500513" cy="0"/>
+          </a:xfrm>
+          <a:prstGeom prst="straightConnector1">
+            <a:avLst/>
+          </a:prstGeom>
+          <a:ln cap="rnd">
+            <a:solidFill>
+              <a:schemeClr val="tx1"/>
+            </a:solidFill>
+            <a:round/>
+            <a:tailEnd type="triangle" w="med" len="med"/>
+          </a:ln>
+        </p:spPr>
+        <p:style>
+          <a:lnRef idx="2">
+            <a:schemeClr val="accent1"/>
+          </a:lnRef>
+          <a:fillRef idx="0">
+            <a:schemeClr val="accent1"/>
+          </a:fillRef>
+          <a:effectRef idx="1">
+            <a:schemeClr val="accent1"/>
+          </a:effectRef>
+          <a:fontRef idx="minor">
+            <a:schemeClr val="tx1"/>
+          </a:fontRef>
+        </p:style>
+      </p:cxnSp>
+      <p:sp>
+        <p:nvSpPr>
+          <p:cNvPr id="13" name="Textfeld 12">
+            <a:extLst>
+              <a:ext uri="{FF2B5EF4-FFF2-40B4-BE49-F238E27FC236}">
+                <a16:creationId xmlns:a16="http://schemas.microsoft.com/office/drawing/2014/main" id="{5BE36C7D-7650-11A7-ABA8-37BEB6591F8D}"/>
+              </a:ext>
+            </a:extLst>
+          </p:cNvPr>
+          <p:cNvSpPr txBox="1"/>
+          <p:nvPr/>
+        </p:nvSpPr>
+        <p:spPr>
+          <a:xfrm>
+            <a:off x="1962673" y="1128418"/>
+            <a:ext cx="567731" cy="307777"/>
+          </a:xfrm>
+          <a:prstGeom prst="rect">
+            <a:avLst/>
+          </a:prstGeom>
+          <a:noFill/>
+        </p:spPr>
+        <p:txBody>
+          <a:bodyPr wrap="square" rtlCol="0">
+            <a:spAutoFit/>
+          </a:bodyPr>
+          <a:lstStyle/>
+          <a:p>
+            <a:pPr algn="ctr"/>
+            <a:r>
+              <a:rPr lang="de-DE" sz="1400" i="1" dirty="0" err="1">
+                <a:solidFill>
+                  <a:srgbClr val="086FBD"/>
+                </a:solidFill>
+                <a:latin typeface="CMU Serif" panose="02000603000000000000" pitchFamily="2" charset="0"/>
+                <a:ea typeface="CMU Serif" panose="02000603000000000000" pitchFamily="2" charset="0"/>
+                <a:cs typeface="CMU Serif" panose="02000603000000000000" pitchFamily="2" charset="0"/>
+              </a:rPr>
+              <a:t>u</a:t>
+            </a:r>
+            <a:r>
+              <a:rPr lang="de-DE" sz="1400" i="1" baseline="-25000" dirty="0" err="1">
+                <a:solidFill>
+                  <a:srgbClr val="086FBD"/>
+                </a:solidFill>
+                <a:latin typeface="CMU Serif" panose="02000603000000000000" pitchFamily="2" charset="0"/>
+                <a:ea typeface="CMU Serif" panose="02000603000000000000" pitchFamily="2" charset="0"/>
+                <a:cs typeface="CMU Serif" panose="02000603000000000000" pitchFamily="2" charset="0"/>
+              </a:rPr>
+              <a:t>R</a:t>
+            </a:r>
+            <a:r>
+              <a:rPr lang="de-DE" sz="1400" dirty="0">
+                <a:solidFill>
+                  <a:srgbClr val="086FBD"/>
+                </a:solidFill>
+                <a:latin typeface="CMU Serif" panose="02000603000000000000" pitchFamily="2" charset="0"/>
+                <a:ea typeface="CMU Serif" panose="02000603000000000000" pitchFamily="2" charset="0"/>
+                <a:cs typeface="CMU Serif" panose="02000603000000000000" pitchFamily="2" charset="0"/>
+              </a:rPr>
+              <a:t>(</a:t>
+            </a:r>
+            <a:r>
+              <a:rPr lang="de-DE" sz="1400" i="1" dirty="0">
+                <a:solidFill>
+                  <a:srgbClr val="086FBD"/>
+                </a:solidFill>
+                <a:latin typeface="CMU Serif" panose="02000603000000000000" pitchFamily="2" charset="0"/>
+                <a:ea typeface="CMU Serif" panose="02000603000000000000" pitchFamily="2" charset="0"/>
+                <a:cs typeface="CMU Serif" panose="02000603000000000000" pitchFamily="2" charset="0"/>
+              </a:rPr>
+              <a:t>t</a:t>
+            </a:r>
+            <a:r>
+              <a:rPr lang="de-DE" sz="1400" dirty="0">
+                <a:solidFill>
+                  <a:srgbClr val="086FBD"/>
+                </a:solidFill>
+                <a:latin typeface="CMU Serif" panose="02000603000000000000" pitchFamily="2" charset="0"/>
+                <a:ea typeface="CMU Serif" panose="02000603000000000000" pitchFamily="2" charset="0"/>
+                <a:cs typeface="CMU Serif" panose="02000603000000000000" pitchFamily="2" charset="0"/>
+              </a:rPr>
+              <a:t>)</a:t>
+            </a:r>
+            <a:endParaRPr lang="de-DE" sz="1400" baseline="-25000" dirty="0">
+              <a:solidFill>
+                <a:srgbClr val="086FBD"/>
+              </a:solidFill>
+              <a:latin typeface="CMU Serif" panose="02000603000000000000" pitchFamily="2" charset="0"/>
+              <a:ea typeface="CMU Serif" panose="02000603000000000000" pitchFamily="2" charset="0"/>
+              <a:cs typeface="CMU Serif" panose="02000603000000000000" pitchFamily="2" charset="0"/>
+            </a:endParaRPr>
+          </a:p>
+        </p:txBody>
+      </p:sp>
+      <p:sp>
+        <p:nvSpPr>
+          <p:cNvPr id="14" name="Textfeld 13">
+            <a:extLst>
+              <a:ext uri="{FF2B5EF4-FFF2-40B4-BE49-F238E27FC236}">
+                <a16:creationId xmlns:a16="http://schemas.microsoft.com/office/drawing/2014/main" id="{FE8F30B2-0BF5-9F8A-7F88-CC7A067FB614}"/>
+              </a:ext>
+            </a:extLst>
+          </p:cNvPr>
+          <p:cNvSpPr txBox="1"/>
+          <p:nvPr/>
+        </p:nvSpPr>
+        <p:spPr>
+          <a:xfrm>
+            <a:off x="1529673" y="1365291"/>
+            <a:ext cx="518786" cy="307777"/>
+          </a:xfrm>
+          <a:prstGeom prst="rect">
+            <a:avLst/>
+          </a:prstGeom>
+          <a:noFill/>
+        </p:spPr>
+        <p:txBody>
+          <a:bodyPr wrap="square" rtlCol="0">
+            <a:spAutoFit/>
+          </a:bodyPr>
+          <a:lstStyle/>
+          <a:p>
+            <a:pPr algn="ctr"/>
+            <a:r>
+              <a:rPr lang="de-DE" sz="1400" i="1" dirty="0" err="1">
+                <a:solidFill>
+                  <a:srgbClr val="FF0000"/>
+                </a:solidFill>
+                <a:latin typeface="CMU Serif" panose="02000603000000000000" pitchFamily="2" charset="0"/>
+                <a:ea typeface="CMU Serif" panose="02000603000000000000" pitchFamily="2" charset="0"/>
+                <a:cs typeface="CMU Serif" panose="02000603000000000000" pitchFamily="2" charset="0"/>
+              </a:rPr>
+              <a:t>i</a:t>
+            </a:r>
+            <a:r>
+              <a:rPr lang="de-DE" sz="1400" i="1" baseline="-25000" dirty="0" err="1">
+                <a:solidFill>
+                  <a:srgbClr val="FF0000"/>
+                </a:solidFill>
+                <a:latin typeface="CMU Serif" panose="02000603000000000000" pitchFamily="2" charset="0"/>
+                <a:ea typeface="CMU Serif" panose="02000603000000000000" pitchFamily="2" charset="0"/>
+                <a:cs typeface="CMU Serif" panose="02000603000000000000" pitchFamily="2" charset="0"/>
+              </a:rPr>
+              <a:t>R</a:t>
+            </a:r>
+            <a:r>
+              <a:rPr lang="de-DE" sz="1400" dirty="0">
+                <a:solidFill>
+                  <a:srgbClr val="FF0000"/>
+                </a:solidFill>
+                <a:latin typeface="CMU Serif" panose="02000603000000000000" pitchFamily="2" charset="0"/>
+                <a:ea typeface="CMU Serif" panose="02000603000000000000" pitchFamily="2" charset="0"/>
+                <a:cs typeface="CMU Serif" panose="02000603000000000000" pitchFamily="2" charset="0"/>
+              </a:rPr>
+              <a:t>(</a:t>
+            </a:r>
+            <a:r>
+              <a:rPr lang="de-DE" sz="1400" i="1" dirty="0">
+                <a:solidFill>
+                  <a:srgbClr val="FF0000"/>
+                </a:solidFill>
+                <a:latin typeface="CMU Serif" panose="02000603000000000000" pitchFamily="2" charset="0"/>
+                <a:ea typeface="CMU Serif" panose="02000603000000000000" pitchFamily="2" charset="0"/>
+                <a:cs typeface="CMU Serif" panose="02000603000000000000" pitchFamily="2" charset="0"/>
+              </a:rPr>
+              <a:t>t</a:t>
+            </a:r>
+            <a:r>
+              <a:rPr lang="de-DE" sz="1400" dirty="0">
+                <a:solidFill>
+                  <a:srgbClr val="FF0000"/>
+                </a:solidFill>
+                <a:latin typeface="CMU Serif" panose="02000603000000000000" pitchFamily="2" charset="0"/>
+                <a:ea typeface="CMU Serif" panose="02000603000000000000" pitchFamily="2" charset="0"/>
+                <a:cs typeface="CMU Serif" panose="02000603000000000000" pitchFamily="2" charset="0"/>
+              </a:rPr>
+              <a:t>)</a:t>
+            </a:r>
+            <a:endParaRPr lang="de-DE" sz="1400" baseline="-25000" dirty="0">
+              <a:solidFill>
+                <a:srgbClr val="FF0000"/>
+              </a:solidFill>
+              <a:latin typeface="CMU Serif" panose="02000603000000000000" pitchFamily="2" charset="0"/>
+              <a:ea typeface="CMU Serif" panose="02000603000000000000" pitchFamily="2" charset="0"/>
+              <a:cs typeface="CMU Serif" panose="02000603000000000000" pitchFamily="2" charset="0"/>
+            </a:endParaRPr>
+          </a:p>
+        </p:txBody>
+      </p:sp>
+      <p:sp>
+        <p:nvSpPr>
+          <p:cNvPr id="20" name="Textfeld 19">
+            <a:extLst>
+              <a:ext uri="{FF2B5EF4-FFF2-40B4-BE49-F238E27FC236}">
+                <a16:creationId xmlns:a16="http://schemas.microsoft.com/office/drawing/2014/main" id="{3FA8239C-2EDA-C327-70FE-9A4493D6D5A4}"/>
+              </a:ext>
+            </a:extLst>
+          </p:cNvPr>
+          <p:cNvSpPr txBox="1"/>
+          <p:nvPr/>
+        </p:nvSpPr>
+        <p:spPr>
+          <a:xfrm>
+            <a:off x="2070746" y="1767541"/>
+            <a:ext cx="518786" cy="307777"/>
+          </a:xfrm>
+          <a:prstGeom prst="rect">
+            <a:avLst/>
+          </a:prstGeom>
+          <a:noFill/>
+        </p:spPr>
+        <p:txBody>
+          <a:bodyPr wrap="square" rtlCol="0">
+            <a:spAutoFit/>
+          </a:bodyPr>
+          <a:lstStyle/>
+          <a:p>
+            <a:pPr algn="ctr"/>
+            <a:r>
+              <a:rPr lang="de-DE" sz="1400" i="1" dirty="0">
+                <a:solidFill>
+                  <a:schemeClr val="accent5"/>
+                </a:solidFill>
+                <a:latin typeface="Latin Modern Math" panose="02000503000000000000" pitchFamily="50" charset="0"/>
+                <a:ea typeface="Latin Modern Math" panose="02000503000000000000" pitchFamily="50" charset="0"/>
+                <a:cs typeface="CMU Serif" panose="02000603000000000000" pitchFamily="2" charset="0"/>
+              </a:rPr>
+              <a:t>ω </a:t>
+            </a:r>
+            <a:r>
+              <a:rPr lang="de-DE" sz="600" dirty="0">
+                <a:solidFill>
+                  <a:schemeClr val="accent5"/>
+                </a:solidFill>
+                <a:latin typeface="Latin Modern Math" panose="02000503000000000000" pitchFamily="50" charset="0"/>
+                <a:ea typeface="Latin Modern Math" panose="02000503000000000000" pitchFamily="50" charset="0"/>
+                <a:cs typeface="CMU Serif" panose="02000603000000000000" pitchFamily="2" charset="0"/>
+              </a:rPr>
+              <a:t>∙</a:t>
+            </a:r>
+            <a:r>
+              <a:rPr lang="de-DE" sz="1400" i="1" dirty="0">
+                <a:solidFill>
+                  <a:schemeClr val="accent5"/>
+                </a:solidFill>
+                <a:latin typeface="Latin Modern Math" panose="02000503000000000000" pitchFamily="50" charset="0"/>
+                <a:ea typeface="Latin Modern Math" panose="02000503000000000000" pitchFamily="50" charset="0"/>
+                <a:cs typeface="CMU Serif" panose="02000603000000000000" pitchFamily="2" charset="0"/>
+              </a:rPr>
+              <a:t> </a:t>
+            </a:r>
+            <a:r>
+              <a:rPr lang="de-DE" sz="1400" i="1" dirty="0">
+                <a:solidFill>
+                  <a:schemeClr val="accent5"/>
+                </a:solidFill>
+                <a:latin typeface="CMU Serif" panose="02000603000000000000" pitchFamily="2" charset="0"/>
+                <a:ea typeface="CMU Serif" panose="02000603000000000000" pitchFamily="2" charset="0"/>
+                <a:cs typeface="CMU Serif" panose="02000603000000000000" pitchFamily="2" charset="0"/>
+              </a:rPr>
+              <a:t>t</a:t>
+            </a:r>
+            <a:endParaRPr lang="de-DE" sz="1400" baseline="-25000" dirty="0">
+              <a:solidFill>
+                <a:schemeClr val="accent5"/>
+              </a:solidFill>
+              <a:latin typeface="CMU Serif" panose="02000603000000000000" pitchFamily="2" charset="0"/>
+              <a:ea typeface="CMU Serif" panose="02000603000000000000" pitchFamily="2" charset="0"/>
+              <a:cs typeface="CMU Serif" panose="02000603000000000000" pitchFamily="2" charset="0"/>
+            </a:endParaRPr>
+          </a:p>
+        </p:txBody>
+      </p:sp>
+      <p:sp>
+        <p:nvSpPr>
+          <p:cNvPr id="23" name="Textfeld 22">
+            <a:extLst>
+              <a:ext uri="{FF2B5EF4-FFF2-40B4-BE49-F238E27FC236}">
+                <a16:creationId xmlns:a16="http://schemas.microsoft.com/office/drawing/2014/main" id="{CAD6B84E-3C06-C029-03BB-A0067CECE2D1}"/>
+              </a:ext>
+            </a:extLst>
+          </p:cNvPr>
+          <p:cNvSpPr txBox="1"/>
+          <p:nvPr/>
+        </p:nvSpPr>
+        <p:spPr>
+          <a:xfrm>
+            <a:off x="2198035" y="2176651"/>
+            <a:ext cx="518786" cy="253916"/>
+          </a:xfrm>
+          <a:prstGeom prst="rect">
+            <a:avLst/>
+          </a:prstGeom>
+          <a:noFill/>
+        </p:spPr>
+        <p:txBody>
+          <a:bodyPr wrap="square" rtlCol="0">
+            <a:spAutoFit/>
+          </a:bodyPr>
+          <a:lstStyle/>
+          <a:p>
+            <a:pPr algn="ctr"/>
+            <a:r>
+              <a:rPr lang="de-DE" sz="1050" dirty="0">
+                <a:latin typeface="CMU Serif" panose="02000603000000000000" pitchFamily="2" charset="0"/>
+                <a:ea typeface="CMU Serif" panose="02000603000000000000" pitchFamily="2" charset="0"/>
+                <a:cs typeface="CMU Serif" panose="02000603000000000000" pitchFamily="2" charset="0"/>
+              </a:rPr>
+              <a:t>Re</a:t>
+            </a:r>
+            <a:endParaRPr lang="de-DE" sz="1050" baseline="-25000" dirty="0">
+              <a:latin typeface="CMU Serif" panose="02000603000000000000" pitchFamily="2" charset="0"/>
+              <a:ea typeface="CMU Serif" panose="02000603000000000000" pitchFamily="2" charset="0"/>
+              <a:cs typeface="CMU Serif" panose="02000603000000000000" pitchFamily="2" charset="0"/>
+            </a:endParaRPr>
+          </a:p>
+        </p:txBody>
+      </p:sp>
+      <p:sp>
+        <p:nvSpPr>
+          <p:cNvPr id="24" name="Textfeld 23">
+            <a:extLst>
+              <a:ext uri="{FF2B5EF4-FFF2-40B4-BE49-F238E27FC236}">
+                <a16:creationId xmlns:a16="http://schemas.microsoft.com/office/drawing/2014/main" id="{896B4ABA-CC7B-ECCC-7F67-E522D6E3D0FD}"/>
+              </a:ext>
+            </a:extLst>
+          </p:cNvPr>
+          <p:cNvSpPr txBox="1"/>
+          <p:nvPr/>
+        </p:nvSpPr>
+        <p:spPr>
+          <a:xfrm>
+            <a:off x="1071759" y="1053040"/>
+            <a:ext cx="518786" cy="253916"/>
+          </a:xfrm>
+          <a:prstGeom prst="rect">
+            <a:avLst/>
+          </a:prstGeom>
+          <a:noFill/>
+        </p:spPr>
+        <p:txBody>
+          <a:bodyPr wrap="square" rtlCol="0">
+            <a:spAutoFit/>
+          </a:bodyPr>
+          <a:lstStyle/>
+          <a:p>
+            <a:pPr algn="ctr"/>
+            <a:r>
+              <a:rPr lang="de-DE" sz="1050" dirty="0">
+                <a:latin typeface="CMU Serif" panose="02000603000000000000" pitchFamily="2" charset="0"/>
+                <a:ea typeface="CMU Serif" panose="02000603000000000000" pitchFamily="2" charset="0"/>
+                <a:cs typeface="CMU Serif" panose="02000603000000000000" pitchFamily="2" charset="0"/>
+              </a:rPr>
+              <a:t>Im</a:t>
+            </a:r>
+            <a:endParaRPr lang="de-DE" sz="1050" baseline="-25000" dirty="0">
+              <a:latin typeface="CMU Serif" panose="02000603000000000000" pitchFamily="2" charset="0"/>
+              <a:ea typeface="CMU Serif" panose="02000603000000000000" pitchFamily="2" charset="0"/>
+              <a:cs typeface="CMU Serif" panose="02000603000000000000" pitchFamily="2" charset="0"/>
+            </a:endParaRPr>
+          </a:p>
+        </p:txBody>
+      </p:sp>
+    </p:spTree>
+    <p:extLst>
+      <p:ext uri="{BB962C8B-B14F-4D97-AF65-F5344CB8AC3E}">
+        <p14:creationId xmlns:p14="http://schemas.microsoft.com/office/powerpoint/2010/main" val="517033152"/>
+      </p:ext>
+    </p:extLst>
+  </p:cSld>
+  <p:clrMapOvr>
+    <a:masterClrMapping/>
+  </p:clrMapOvr>
+</p:sld>
+</file>
+
+<file path=ppt/slides/slide9.xml><?xml version="1.0" encoding="utf-8"?>
+<p:sld xmlns:a="http://schemas.openxmlformats.org/drawingml/2006/main" xmlns:r="http://schemas.openxmlformats.org/officeDocument/2006/relationships" xmlns:p="http://schemas.openxmlformats.org/presentationml/2006/main">
+  <p:cSld>
+    <p:spTree>
+      <p:nvGrpSpPr>
+        <p:cNvPr id="1" name=""/>
+        <p:cNvGrpSpPr/>
+        <p:nvPr/>
+      </p:nvGrpSpPr>
+      <p:grpSpPr>
+        <a:xfrm>
+          <a:off x="0" y="0"/>
+          <a:ext cx="0" cy="0"/>
+          <a:chOff x="0" y="0"/>
+          <a:chExt cx="0" cy="0"/>
+        </a:xfrm>
+      </p:grpSpPr>
+      <p:sp>
+        <p:nvSpPr>
+          <p:cNvPr id="4" name="Rechteck 3">
+            <a:extLst>
+              <a:ext uri="{FF2B5EF4-FFF2-40B4-BE49-F238E27FC236}">
+                <a16:creationId xmlns:a16="http://schemas.microsoft.com/office/drawing/2014/main" id="{151416CF-1FBE-948E-361C-CBFB4791216C}"/>
+              </a:ext>
+            </a:extLst>
+          </p:cNvPr>
+          <p:cNvSpPr/>
+          <p:nvPr/>
+        </p:nvSpPr>
+        <p:spPr>
+          <a:xfrm>
+            <a:off x="607080" y="1759516"/>
+            <a:ext cx="2386290" cy="961764"/>
+          </a:xfrm>
+          <a:prstGeom prst="rect">
+            <a:avLst/>
+          </a:prstGeom>
+          <a:noFill/>
+          <a:ln cap="rnd">
+            <a:solidFill>
+              <a:schemeClr val="tx1"/>
+            </a:solidFill>
+            <a:round/>
+          </a:ln>
+        </p:spPr>
+        <p:style>
+          <a:lnRef idx="2">
+            <a:schemeClr val="accent1">
+              <a:shade val="15000"/>
+            </a:schemeClr>
+          </a:lnRef>
+          <a:fillRef idx="1">
+            <a:schemeClr val="accent1"/>
+          </a:fillRef>
+          <a:effectRef idx="0">
+            <a:schemeClr val="accent1"/>
+          </a:effectRef>
+          <a:fontRef idx="minor">
+            <a:schemeClr val="lt1"/>
+          </a:fontRef>
+        </p:style>
+        <p:txBody>
+          <a:bodyPr rtlCol="0" anchor="ctr"/>
+          <a:lstStyle/>
+          <a:p>
+            <a:pPr algn="ctr"/>
+            <a:endParaRPr lang="de-DE"/>
+          </a:p>
+        </p:txBody>
+      </p:sp>
+      <p:sp>
+        <p:nvSpPr>
+          <p:cNvPr id="5" name="Rechteck 4">
+            <a:extLst>
+              <a:ext uri="{FF2B5EF4-FFF2-40B4-BE49-F238E27FC236}">
+                <a16:creationId xmlns:a16="http://schemas.microsoft.com/office/drawing/2014/main" id="{825C4AEB-8AEA-37C7-B806-4532C83E32AF}"/>
+              </a:ext>
+            </a:extLst>
+          </p:cNvPr>
+          <p:cNvSpPr/>
+          <p:nvPr/>
+        </p:nvSpPr>
+        <p:spPr>
+          <a:xfrm>
+            <a:off x="1800224" y="1283164"/>
+            <a:ext cx="1193146" cy="476352"/>
+          </a:xfrm>
+          <a:prstGeom prst="rect">
+            <a:avLst/>
+          </a:prstGeom>
+          <a:noFill/>
+          <a:ln cap="rnd">
+            <a:solidFill>
+              <a:schemeClr val="tx1"/>
+            </a:solidFill>
+            <a:round/>
+          </a:ln>
+        </p:spPr>
+        <p:style>
+          <a:lnRef idx="2">
+            <a:schemeClr val="accent1">
+              <a:shade val="15000"/>
+            </a:schemeClr>
+          </a:lnRef>
+          <a:fillRef idx="1">
+            <a:schemeClr val="accent1"/>
+          </a:fillRef>
+          <a:effectRef idx="0">
+            <a:schemeClr val="accent1"/>
+          </a:effectRef>
+          <a:fontRef idx="minor">
+            <a:schemeClr val="lt1"/>
+          </a:fontRef>
+        </p:style>
+        <p:txBody>
+          <a:bodyPr rtlCol="0" anchor="ctr"/>
+          <a:lstStyle/>
+          <a:p>
+            <a:pPr algn="ctr"/>
+            <a:endParaRPr lang="de-DE"/>
+          </a:p>
+        </p:txBody>
+      </p:sp>
+      <p:sp>
+        <p:nvSpPr>
+          <p:cNvPr id="6" name="Ellipse 5">
+            <a:extLst>
+              <a:ext uri="{FF2B5EF4-FFF2-40B4-BE49-F238E27FC236}">
+                <a16:creationId xmlns:a16="http://schemas.microsoft.com/office/drawing/2014/main" id="{D1EDCD6F-8B83-AAE8-702F-C154756A9B12}"/>
+              </a:ext>
+            </a:extLst>
+          </p:cNvPr>
+          <p:cNvSpPr/>
+          <p:nvPr/>
+        </p:nvSpPr>
+        <p:spPr>
+          <a:xfrm>
+            <a:off x="2251182" y="1137549"/>
+            <a:ext cx="291230" cy="291230"/>
+          </a:xfrm>
+          <a:prstGeom prst="ellipse">
+            <a:avLst/>
+          </a:prstGeom>
+          <a:solidFill>
+            <a:schemeClr val="bg1"/>
+          </a:solidFill>
+          <a:ln>
+            <a:solidFill>
+              <a:schemeClr val="tx1"/>
+            </a:solidFill>
+          </a:ln>
+        </p:spPr>
+        <p:style>
+          <a:lnRef idx="2">
+            <a:schemeClr val="accent1">
+              <a:shade val="15000"/>
+            </a:schemeClr>
+          </a:lnRef>
+          <a:fillRef idx="1">
+            <a:schemeClr val="accent1"/>
+          </a:fillRef>
+          <a:effectRef idx="0">
+            <a:schemeClr val="accent1"/>
+          </a:effectRef>
+          <a:fontRef idx="minor">
+            <a:schemeClr val="lt1"/>
+          </a:fontRef>
+        </p:style>
+        <p:txBody>
+          <a:bodyPr rtlCol="0" anchor="ctr"/>
+          <a:lstStyle/>
+          <a:p>
+            <a:pPr algn="ctr"/>
+            <a:endParaRPr lang="de-DE"/>
+          </a:p>
+        </p:txBody>
+      </p:sp>
+      <p:sp>
+        <p:nvSpPr>
+          <p:cNvPr id="7" name="Ellipse 6">
+            <a:extLst>
+              <a:ext uri="{FF2B5EF4-FFF2-40B4-BE49-F238E27FC236}">
+                <a16:creationId xmlns:a16="http://schemas.microsoft.com/office/drawing/2014/main" id="{28AFD021-0B35-2FA1-F772-E72FAEBFC55B}"/>
+              </a:ext>
+            </a:extLst>
+          </p:cNvPr>
+          <p:cNvSpPr/>
+          <p:nvPr/>
+        </p:nvSpPr>
+        <p:spPr>
+          <a:xfrm>
+            <a:off x="1058037" y="1613901"/>
+            <a:ext cx="291230" cy="291230"/>
+          </a:xfrm>
+          <a:prstGeom prst="ellipse">
+            <a:avLst/>
+          </a:prstGeom>
+          <a:solidFill>
+            <a:schemeClr val="bg1"/>
+          </a:solidFill>
+          <a:ln>
+            <a:solidFill>
+              <a:schemeClr val="tx1"/>
+            </a:solidFill>
+          </a:ln>
+        </p:spPr>
+        <p:style>
+          <a:lnRef idx="2">
+            <a:schemeClr val="accent1">
+              <a:shade val="15000"/>
+            </a:schemeClr>
+          </a:lnRef>
+          <a:fillRef idx="1">
+            <a:schemeClr val="accent1"/>
+          </a:fillRef>
+          <a:effectRef idx="0">
+            <a:schemeClr val="accent1"/>
+          </a:effectRef>
+          <a:fontRef idx="minor">
+            <a:schemeClr val="lt1"/>
+          </a:fontRef>
+        </p:style>
+        <p:txBody>
+          <a:bodyPr rtlCol="0" anchor="ctr"/>
+          <a:lstStyle/>
+          <a:p>
+            <a:pPr algn="ctr"/>
+            <a:endParaRPr lang="de-DE"/>
+          </a:p>
+        </p:txBody>
+      </p:sp>
+      <p:sp>
+        <p:nvSpPr>
+          <p:cNvPr id="8" name="Rechteck 7">
+            <a:extLst>
+              <a:ext uri="{FF2B5EF4-FFF2-40B4-BE49-F238E27FC236}">
+                <a16:creationId xmlns:a16="http://schemas.microsoft.com/office/drawing/2014/main" id="{E00BC18B-C13C-3FDC-48EF-EE01146FB196}"/>
+              </a:ext>
+            </a:extLst>
+          </p:cNvPr>
+          <p:cNvSpPr/>
+          <p:nvPr/>
+        </p:nvSpPr>
+        <p:spPr>
+          <a:xfrm>
+            <a:off x="1699052" y="2594454"/>
+            <a:ext cx="202344" cy="253652"/>
+          </a:xfrm>
+          <a:prstGeom prst="rect">
+            <a:avLst/>
+          </a:prstGeom>
+          <a:solidFill>
+            <a:schemeClr val="bg1"/>
+          </a:solidFill>
+          <a:ln>
+            <a:noFill/>
+          </a:ln>
+        </p:spPr>
+        <p:style>
+          <a:lnRef idx="2">
+            <a:schemeClr val="accent1">
+              <a:shade val="15000"/>
+            </a:schemeClr>
+          </a:lnRef>
+          <a:fillRef idx="1">
+            <a:schemeClr val="accent1"/>
+          </a:fillRef>
+          <a:effectRef idx="0">
+            <a:schemeClr val="accent1"/>
+          </a:effectRef>
+          <a:fontRef idx="minor">
+            <a:schemeClr val="lt1"/>
+          </a:fontRef>
+        </p:style>
+        <p:txBody>
+          <a:bodyPr rtlCol="0" anchor="ctr"/>
+          <a:lstStyle/>
+          <a:p>
+            <a:pPr algn="ctr"/>
+            <a:endParaRPr lang="de-DE"/>
+          </a:p>
+        </p:txBody>
+      </p:sp>
+      <p:sp>
+        <p:nvSpPr>
+          <p:cNvPr id="9" name="Ellipse 8">
+            <a:extLst>
+              <a:ext uri="{FF2B5EF4-FFF2-40B4-BE49-F238E27FC236}">
+                <a16:creationId xmlns:a16="http://schemas.microsoft.com/office/drawing/2014/main" id="{4E105BC4-0FF5-4C73-25D0-33685C38776F}"/>
+              </a:ext>
+            </a:extLst>
+          </p:cNvPr>
+          <p:cNvSpPr/>
+          <p:nvPr/>
+        </p:nvSpPr>
+        <p:spPr>
+          <a:xfrm>
+            <a:off x="1628703" y="2686105"/>
+            <a:ext cx="70349" cy="70349"/>
+          </a:xfrm>
+          <a:prstGeom prst="ellipse">
+            <a:avLst/>
+          </a:prstGeom>
+          <a:solidFill>
+            <a:schemeClr val="bg1"/>
+          </a:solidFill>
+          <a:ln>
+            <a:solidFill>
+              <a:schemeClr val="tx1"/>
+            </a:solidFill>
+          </a:ln>
+        </p:spPr>
+        <p:style>
+          <a:lnRef idx="2">
+            <a:schemeClr val="accent1">
+              <a:shade val="15000"/>
+            </a:schemeClr>
+          </a:lnRef>
+          <a:fillRef idx="1">
+            <a:schemeClr val="accent1"/>
+          </a:fillRef>
+          <a:effectRef idx="0">
+            <a:schemeClr val="accent1"/>
+          </a:effectRef>
+          <a:fontRef idx="minor">
+            <a:schemeClr val="lt1"/>
+          </a:fontRef>
+        </p:style>
+        <p:txBody>
+          <a:bodyPr rtlCol="0" anchor="ctr"/>
+          <a:lstStyle/>
+          <a:p>
+            <a:pPr algn="ctr"/>
+            <a:endParaRPr lang="de-DE"/>
+          </a:p>
+        </p:txBody>
+      </p:sp>
+      <p:sp>
+        <p:nvSpPr>
+          <p:cNvPr id="10" name="Ellipse 9">
+            <a:extLst>
+              <a:ext uri="{FF2B5EF4-FFF2-40B4-BE49-F238E27FC236}">
+                <a16:creationId xmlns:a16="http://schemas.microsoft.com/office/drawing/2014/main" id="{45FE19A6-6812-11D6-EB98-1DD3CE82FC07}"/>
+              </a:ext>
+            </a:extLst>
+          </p:cNvPr>
+          <p:cNvSpPr/>
+          <p:nvPr/>
+        </p:nvSpPr>
+        <p:spPr>
+          <a:xfrm>
+            <a:off x="1901396" y="2686105"/>
+            <a:ext cx="70349" cy="70349"/>
+          </a:xfrm>
+          <a:prstGeom prst="ellipse">
+            <a:avLst/>
+          </a:prstGeom>
+          <a:solidFill>
+            <a:schemeClr val="bg1"/>
+          </a:solidFill>
+          <a:ln>
+            <a:solidFill>
+              <a:schemeClr val="tx1"/>
+            </a:solidFill>
+          </a:ln>
+        </p:spPr>
+        <p:style>
+          <a:lnRef idx="2">
+            <a:schemeClr val="accent1">
+              <a:shade val="15000"/>
+            </a:schemeClr>
+          </a:lnRef>
+          <a:fillRef idx="1">
+            <a:schemeClr val="accent1"/>
+          </a:fillRef>
+          <a:effectRef idx="0">
+            <a:schemeClr val="accent1"/>
+          </a:effectRef>
+          <a:fontRef idx="minor">
+            <a:schemeClr val="lt1"/>
+          </a:fontRef>
+        </p:style>
+        <p:txBody>
+          <a:bodyPr rtlCol="0" anchor="ctr"/>
+          <a:lstStyle/>
+          <a:p>
+            <a:pPr algn="ctr"/>
+            <a:endParaRPr lang="de-DE"/>
+          </a:p>
+        </p:txBody>
+      </p:sp>
+      <p:sp>
+        <p:nvSpPr>
+          <p:cNvPr id="11" name="Textfeld 10">
+            <a:extLst>
+              <a:ext uri="{FF2B5EF4-FFF2-40B4-BE49-F238E27FC236}">
+                <a16:creationId xmlns:a16="http://schemas.microsoft.com/office/drawing/2014/main" id="{D170C4F5-D9B6-4777-54DF-FB57D1C55546}"/>
+              </a:ext>
+            </a:extLst>
+          </p:cNvPr>
+          <p:cNvSpPr txBox="1"/>
+          <p:nvPr/>
+        </p:nvSpPr>
+        <p:spPr>
+          <a:xfrm>
+            <a:off x="1032819" y="1613901"/>
+            <a:ext cx="341666" cy="307777"/>
+          </a:xfrm>
+          <a:prstGeom prst="rect">
+            <a:avLst/>
+          </a:prstGeom>
+          <a:noFill/>
+        </p:spPr>
+        <p:txBody>
+          <a:bodyPr wrap="square" rtlCol="0">
+            <a:spAutoFit/>
+          </a:bodyPr>
+          <a:lstStyle/>
+          <a:p>
+            <a:pPr algn="ctr"/>
+            <a:r>
+              <a:rPr lang="de-DE" sz="1400" dirty="0">
+                <a:latin typeface="CMU Serif" panose="02000603000000000000" pitchFamily="2" charset="0"/>
+                <a:ea typeface="CMU Serif" panose="02000603000000000000" pitchFamily="2" charset="0"/>
+                <a:cs typeface="CMU Serif" panose="02000603000000000000" pitchFamily="2" charset="0"/>
+              </a:rPr>
+              <a:t>A</a:t>
+            </a:r>
+            <a:endParaRPr lang="de-DE" sz="1400" baseline="-25000" dirty="0">
+              <a:latin typeface="CMU Serif" panose="02000603000000000000" pitchFamily="2" charset="0"/>
+              <a:ea typeface="CMU Serif" panose="02000603000000000000" pitchFamily="2" charset="0"/>
+              <a:cs typeface="CMU Serif" panose="02000603000000000000" pitchFamily="2" charset="0"/>
+            </a:endParaRPr>
+          </a:p>
+        </p:txBody>
+      </p:sp>
+      <p:sp>
+        <p:nvSpPr>
+          <p:cNvPr id="12" name="Textfeld 11">
+            <a:extLst>
+              <a:ext uri="{FF2B5EF4-FFF2-40B4-BE49-F238E27FC236}">
+                <a16:creationId xmlns:a16="http://schemas.microsoft.com/office/drawing/2014/main" id="{DD582DF5-2E06-843C-015B-A83418C9741D}"/>
+              </a:ext>
+            </a:extLst>
+          </p:cNvPr>
+          <p:cNvSpPr txBox="1"/>
+          <p:nvPr/>
+        </p:nvSpPr>
+        <p:spPr>
+          <a:xfrm>
+            <a:off x="2225964" y="1159241"/>
+            <a:ext cx="341666" cy="307777"/>
+          </a:xfrm>
+          <a:prstGeom prst="rect">
+            <a:avLst/>
+          </a:prstGeom>
+          <a:noFill/>
+        </p:spPr>
+        <p:txBody>
+          <a:bodyPr wrap="square" rtlCol="0">
+            <a:spAutoFit/>
+          </a:bodyPr>
+          <a:lstStyle/>
+          <a:p>
+            <a:pPr algn="ctr"/>
+            <a:r>
+              <a:rPr lang="de-DE" sz="1400" dirty="0">
+                <a:latin typeface="CMU Serif" panose="02000603000000000000" pitchFamily="2" charset="0"/>
+                <a:ea typeface="CMU Serif" panose="02000603000000000000" pitchFamily="2" charset="0"/>
+                <a:cs typeface="CMU Serif" panose="02000603000000000000" pitchFamily="2" charset="0"/>
+              </a:rPr>
+              <a:t>V</a:t>
+            </a:r>
+            <a:endParaRPr lang="de-DE" sz="1400" baseline="-25000" dirty="0">
+              <a:latin typeface="CMU Serif" panose="02000603000000000000" pitchFamily="2" charset="0"/>
+              <a:ea typeface="CMU Serif" panose="02000603000000000000" pitchFamily="2" charset="0"/>
+              <a:cs typeface="CMU Serif" panose="02000603000000000000" pitchFamily="2" charset="0"/>
+            </a:endParaRPr>
+          </a:p>
+        </p:txBody>
+      </p:sp>
+      <p:sp>
+        <p:nvSpPr>
+          <p:cNvPr id="13" name="Textfeld 12">
+            <a:extLst>
+              <a:ext uri="{FF2B5EF4-FFF2-40B4-BE49-F238E27FC236}">
+                <a16:creationId xmlns:a16="http://schemas.microsoft.com/office/drawing/2014/main" id="{D4DBAC26-BE8A-E26E-380A-B2DC7110AD73}"/>
+              </a:ext>
+            </a:extLst>
+          </p:cNvPr>
+          <p:cNvSpPr txBox="1"/>
+          <p:nvPr/>
+        </p:nvSpPr>
+        <p:spPr>
+          <a:xfrm>
+            <a:off x="1630079" y="2629628"/>
+            <a:ext cx="341666" cy="307777"/>
+          </a:xfrm>
+          <a:prstGeom prst="rect">
+            <a:avLst/>
+          </a:prstGeom>
+          <a:noFill/>
+        </p:spPr>
+        <p:txBody>
+          <a:bodyPr wrap="square" rtlCol="0">
+            <a:spAutoFit/>
+          </a:bodyPr>
+          <a:lstStyle/>
+          <a:p>
+            <a:pPr algn="ctr"/>
+            <a:r>
+              <a:rPr lang="de-DE" sz="1400" dirty="0">
+                <a:latin typeface="CMU Serif" panose="02000603000000000000" pitchFamily="2" charset="0"/>
+                <a:ea typeface="CMU Serif" panose="02000603000000000000" pitchFamily="2" charset="0"/>
+                <a:cs typeface="CMU Serif" panose="02000603000000000000" pitchFamily="2" charset="0"/>
+              </a:rPr>
+              <a:t>~</a:t>
+            </a:r>
+            <a:endParaRPr lang="de-DE" sz="1400" baseline="-25000" dirty="0">
+              <a:latin typeface="CMU Serif" panose="02000603000000000000" pitchFamily="2" charset="0"/>
+              <a:ea typeface="CMU Serif" panose="02000603000000000000" pitchFamily="2" charset="0"/>
+              <a:cs typeface="CMU Serif" panose="02000603000000000000" pitchFamily="2" charset="0"/>
+            </a:endParaRPr>
+          </a:p>
+        </p:txBody>
+      </p:sp>
+      <p:sp>
+        <p:nvSpPr>
+          <p:cNvPr id="14" name="Ellipse 13">
+            <a:extLst>
+              <a:ext uri="{FF2B5EF4-FFF2-40B4-BE49-F238E27FC236}">
+                <a16:creationId xmlns:a16="http://schemas.microsoft.com/office/drawing/2014/main" id="{17879248-9E5E-9540-3305-D7DB7E621D50}"/>
+              </a:ext>
+            </a:extLst>
+          </p:cNvPr>
+          <p:cNvSpPr/>
+          <p:nvPr/>
+        </p:nvSpPr>
+        <p:spPr>
+          <a:xfrm>
+            <a:off x="1765049" y="1724341"/>
+            <a:ext cx="70349" cy="70349"/>
+          </a:xfrm>
+          <a:prstGeom prst="ellipse">
+            <a:avLst/>
+          </a:prstGeom>
+          <a:solidFill>
+            <a:schemeClr val="tx1"/>
+          </a:solidFill>
+          <a:ln>
+            <a:noFill/>
+          </a:ln>
+        </p:spPr>
+        <p:style>
+          <a:lnRef idx="2">
+            <a:schemeClr val="accent1">
+              <a:shade val="15000"/>
+            </a:schemeClr>
+          </a:lnRef>
+          <a:fillRef idx="1">
+            <a:schemeClr val="accent1"/>
+          </a:fillRef>
+          <a:effectRef idx="0">
+            <a:schemeClr val="accent1"/>
+          </a:effectRef>
+          <a:fontRef idx="minor">
+            <a:schemeClr val="lt1"/>
+          </a:fontRef>
+        </p:style>
+        <p:txBody>
+          <a:bodyPr rtlCol="0" anchor="ctr"/>
+          <a:lstStyle/>
+          <a:p>
+            <a:pPr algn="ctr"/>
+            <a:endParaRPr lang="de-DE"/>
+          </a:p>
+        </p:txBody>
+      </p:sp>
+      <p:sp>
+        <p:nvSpPr>
+          <p:cNvPr id="15" name="Ellipse 14">
+            <a:extLst>
+              <a:ext uri="{FF2B5EF4-FFF2-40B4-BE49-F238E27FC236}">
+                <a16:creationId xmlns:a16="http://schemas.microsoft.com/office/drawing/2014/main" id="{FDB46DEF-7601-2053-4A91-22C90B95523C}"/>
+              </a:ext>
+            </a:extLst>
+          </p:cNvPr>
+          <p:cNvSpPr/>
+          <p:nvPr/>
+        </p:nvSpPr>
+        <p:spPr>
+          <a:xfrm>
+            <a:off x="2958195" y="1724341"/>
+            <a:ext cx="70349" cy="70349"/>
+          </a:xfrm>
+          <a:prstGeom prst="ellipse">
+            <a:avLst/>
+          </a:prstGeom>
+          <a:solidFill>
+            <a:schemeClr val="tx1"/>
+          </a:solidFill>
+          <a:ln>
+            <a:noFill/>
+          </a:ln>
+        </p:spPr>
+        <p:style>
+          <a:lnRef idx="2">
+            <a:schemeClr val="accent1">
+              <a:shade val="15000"/>
+            </a:schemeClr>
+          </a:lnRef>
+          <a:fillRef idx="1">
+            <a:schemeClr val="accent1"/>
+          </a:fillRef>
+          <a:effectRef idx="0">
+            <a:schemeClr val="accent1"/>
+          </a:effectRef>
+          <a:fontRef idx="minor">
+            <a:schemeClr val="lt1"/>
+          </a:fontRef>
+        </p:style>
+        <p:txBody>
+          <a:bodyPr rtlCol="0" anchor="ctr"/>
+          <a:lstStyle/>
+          <a:p>
+            <a:pPr algn="ctr"/>
+            <a:endParaRPr lang="de-DE"/>
+          </a:p>
+        </p:txBody>
+      </p:sp>
+      <p:sp>
+        <p:nvSpPr>
+          <p:cNvPr id="16" name="Rechteck 15">
+            <a:extLst>
+              <a:ext uri="{FF2B5EF4-FFF2-40B4-BE49-F238E27FC236}">
+                <a16:creationId xmlns:a16="http://schemas.microsoft.com/office/drawing/2014/main" id="{33A958FD-91E2-80A0-E979-96AE6A1E74CA}"/>
+              </a:ext>
+            </a:extLst>
+          </p:cNvPr>
+          <p:cNvSpPr/>
+          <p:nvPr/>
+        </p:nvSpPr>
+        <p:spPr>
+          <a:xfrm>
+            <a:off x="2095500" y="1632690"/>
+            <a:ext cx="602594" cy="253652"/>
+          </a:xfrm>
+          <a:prstGeom prst="rect">
+            <a:avLst/>
+          </a:prstGeom>
+          <a:solidFill>
+            <a:schemeClr val="bg1"/>
+          </a:solidFill>
+          <a:ln>
+            <a:noFill/>
+          </a:ln>
+        </p:spPr>
+        <p:style>
+          <a:lnRef idx="2">
+            <a:schemeClr val="accent1">
+              <a:shade val="15000"/>
+            </a:schemeClr>
+          </a:lnRef>
+          <a:fillRef idx="1">
+            <a:schemeClr val="accent1"/>
+          </a:fillRef>
+          <a:effectRef idx="0">
+            <a:schemeClr val="accent1"/>
+          </a:effectRef>
+          <a:fontRef idx="minor">
+            <a:schemeClr val="lt1"/>
+          </a:fontRef>
+        </p:style>
+        <p:txBody>
+          <a:bodyPr rtlCol="0" anchor="ctr"/>
+          <a:lstStyle/>
+          <a:p>
+            <a:pPr algn="ctr"/>
+            <a:endParaRPr lang="de-DE"/>
+          </a:p>
+        </p:txBody>
+      </p:sp>
+      <p:sp>
+        <p:nvSpPr>
+          <p:cNvPr id="17" name="Textfeld 16">
+            <a:extLst>
+              <a:ext uri="{FF2B5EF4-FFF2-40B4-BE49-F238E27FC236}">
+                <a16:creationId xmlns:a16="http://schemas.microsoft.com/office/drawing/2014/main" id="{88EFE8CB-704E-5102-E7E6-5B07A079F72E}"/>
+              </a:ext>
+            </a:extLst>
+          </p:cNvPr>
+          <p:cNvSpPr txBox="1"/>
+          <p:nvPr/>
+        </p:nvSpPr>
+        <p:spPr>
+          <a:xfrm>
+            <a:off x="2037238" y="1621774"/>
+            <a:ext cx="719118" cy="307777"/>
+          </a:xfrm>
+          <a:prstGeom prst="rect">
+            <a:avLst/>
+          </a:prstGeom>
+          <a:noFill/>
+        </p:spPr>
+        <p:txBody>
+          <a:bodyPr wrap="square" rtlCol="0">
+            <a:spAutoFit/>
+          </a:bodyPr>
+          <a:lstStyle/>
+          <a:p>
+            <a:pPr algn="ctr"/>
+            <a:r>
+              <a:rPr lang="de-DE" sz="1400" dirty="0">
+                <a:latin typeface="CMU Serif" panose="02000603000000000000" pitchFamily="2" charset="0"/>
+                <a:ea typeface="CMU Serif" panose="02000603000000000000" pitchFamily="2" charset="0"/>
+                <a:cs typeface="CMU Serif" panose="02000603000000000000" pitchFamily="2" charset="0"/>
+              </a:rPr>
+              <a:t>L / C</a:t>
+            </a:r>
+            <a:endParaRPr lang="de-DE" sz="1400" baseline="-25000" dirty="0">
+              <a:latin typeface="CMU Serif" panose="02000603000000000000" pitchFamily="2" charset="0"/>
+              <a:ea typeface="CMU Serif" panose="02000603000000000000" pitchFamily="2" charset="0"/>
+              <a:cs typeface="CMU Serif" panose="02000603000000000000" pitchFamily="2" charset="0"/>
+            </a:endParaRPr>
+          </a:p>
+        </p:txBody>
+      </p:sp>
+      <p:cxnSp>
+        <p:nvCxnSpPr>
+          <p:cNvPr id="18" name="Gerade Verbindung mit Pfeil 17">
+            <a:extLst>
+              <a:ext uri="{FF2B5EF4-FFF2-40B4-BE49-F238E27FC236}">
+                <a16:creationId xmlns:a16="http://schemas.microsoft.com/office/drawing/2014/main" id="{0567DFA3-6013-E383-1619-6CB95683A2AB}"/>
+              </a:ext>
+            </a:extLst>
+          </p:cNvPr>
+          <p:cNvCxnSpPr>
+            <a:cxnSpLocks/>
+          </p:cNvCxnSpPr>
+          <p:nvPr/>
+        </p:nvCxnSpPr>
+        <p:spPr>
+          <a:xfrm flipH="1">
+            <a:off x="2037238" y="1055483"/>
+            <a:ext cx="682772" cy="0"/>
+          </a:xfrm>
+          <a:prstGeom prst="straightConnector1">
+            <a:avLst/>
+          </a:prstGeom>
+          <a:ln cap="rnd">
+            <a:solidFill>
+              <a:srgbClr val="086FBD"/>
+            </a:solidFill>
+            <a:round/>
+            <a:tailEnd type="triangle"/>
+          </a:ln>
+        </p:spPr>
+        <p:style>
+          <a:lnRef idx="2">
+            <a:schemeClr val="accent1"/>
+          </a:lnRef>
+          <a:fillRef idx="0">
+            <a:schemeClr val="accent1"/>
+          </a:fillRef>
+          <a:effectRef idx="1">
+            <a:schemeClr val="accent1"/>
+          </a:effectRef>
+          <a:fontRef idx="minor">
+            <a:schemeClr val="tx1"/>
+          </a:fontRef>
+        </p:style>
+      </p:cxnSp>
+      <p:sp>
+        <p:nvSpPr>
+          <p:cNvPr id="19" name="Textfeld 18">
+            <a:extLst>
+              <a:ext uri="{FF2B5EF4-FFF2-40B4-BE49-F238E27FC236}">
+                <a16:creationId xmlns:a16="http://schemas.microsoft.com/office/drawing/2014/main" id="{F837B461-6CA9-6D96-A62F-178FFB54B4A5}"/>
+              </a:ext>
+            </a:extLst>
+          </p:cNvPr>
+          <p:cNvSpPr txBox="1"/>
+          <p:nvPr/>
+        </p:nvSpPr>
+        <p:spPr>
+          <a:xfrm>
+            <a:off x="1113865" y="922105"/>
+            <a:ext cx="953695" cy="261610"/>
+          </a:xfrm>
+          <a:prstGeom prst="rect">
+            <a:avLst/>
+          </a:prstGeom>
+          <a:noFill/>
+        </p:spPr>
+        <p:txBody>
+          <a:bodyPr wrap="square" rtlCol="0">
+            <a:spAutoFit/>
+          </a:bodyPr>
+          <a:lstStyle/>
+          <a:p>
+            <a:pPr algn="ctr"/>
+            <a:r>
+              <a:rPr lang="de-DE" sz="1100" i="1" dirty="0" err="1">
+                <a:solidFill>
+                  <a:srgbClr val="086FBD"/>
+                </a:solidFill>
+                <a:latin typeface="CMU Serif" panose="02000603000000000000" pitchFamily="2" charset="0"/>
+                <a:ea typeface="CMU Serif" panose="02000603000000000000" pitchFamily="2" charset="0"/>
+                <a:cs typeface="CMU Serif" panose="02000603000000000000" pitchFamily="2" charset="0"/>
+              </a:rPr>
+              <a:t>u</a:t>
+            </a:r>
+            <a:r>
+              <a:rPr lang="de-DE" sz="1100" baseline="-25000" dirty="0" err="1">
+                <a:solidFill>
+                  <a:srgbClr val="086FBD"/>
+                </a:solidFill>
+                <a:latin typeface="CMU Serif" panose="02000603000000000000" pitchFamily="2" charset="0"/>
+                <a:ea typeface="CMU Serif" panose="02000603000000000000" pitchFamily="2" charset="0"/>
+                <a:cs typeface="CMU Serif" panose="02000603000000000000" pitchFamily="2" charset="0"/>
+              </a:rPr>
+              <a:t>L</a:t>
+            </a:r>
+            <a:r>
+              <a:rPr lang="de-DE" sz="1100" dirty="0">
+                <a:solidFill>
+                  <a:srgbClr val="086FBD"/>
+                </a:solidFill>
+                <a:latin typeface="CMU Serif" panose="02000603000000000000" pitchFamily="2" charset="0"/>
+                <a:ea typeface="CMU Serif" panose="02000603000000000000" pitchFamily="2" charset="0"/>
+                <a:cs typeface="CMU Serif" panose="02000603000000000000" pitchFamily="2" charset="0"/>
+              </a:rPr>
+              <a:t>(</a:t>
+            </a:r>
+            <a:r>
+              <a:rPr lang="de-DE" sz="1100" i="1" dirty="0">
+                <a:solidFill>
+                  <a:srgbClr val="086FBD"/>
+                </a:solidFill>
+                <a:latin typeface="CMU Serif" panose="02000603000000000000" pitchFamily="2" charset="0"/>
+                <a:ea typeface="CMU Serif" panose="02000603000000000000" pitchFamily="2" charset="0"/>
+                <a:cs typeface="CMU Serif" panose="02000603000000000000" pitchFamily="2" charset="0"/>
+              </a:rPr>
+              <a:t>t</a:t>
+            </a:r>
+            <a:r>
+              <a:rPr lang="de-DE" sz="1100" dirty="0">
+                <a:solidFill>
+                  <a:srgbClr val="086FBD"/>
+                </a:solidFill>
+                <a:latin typeface="CMU Serif" panose="02000603000000000000" pitchFamily="2" charset="0"/>
+                <a:ea typeface="CMU Serif" panose="02000603000000000000" pitchFamily="2" charset="0"/>
+                <a:cs typeface="CMU Serif" panose="02000603000000000000" pitchFamily="2" charset="0"/>
+              </a:rPr>
+              <a:t>)</a:t>
+            </a:r>
+            <a:r>
+              <a:rPr lang="de-DE" sz="1100" i="1" dirty="0">
+                <a:solidFill>
+                  <a:srgbClr val="086FBD"/>
+                </a:solidFill>
+                <a:latin typeface="CMU Serif" panose="02000603000000000000" pitchFamily="2" charset="0"/>
+                <a:ea typeface="CMU Serif" panose="02000603000000000000" pitchFamily="2" charset="0"/>
+                <a:cs typeface="CMU Serif" panose="02000603000000000000" pitchFamily="2" charset="0"/>
+              </a:rPr>
+              <a:t> </a:t>
+            </a:r>
+            <a:r>
+              <a:rPr lang="de-DE" sz="1100" dirty="0">
+                <a:solidFill>
+                  <a:srgbClr val="086FBD"/>
+                </a:solidFill>
+                <a:latin typeface="CMU Serif" panose="02000603000000000000" pitchFamily="2" charset="0"/>
+                <a:ea typeface="CMU Serif" panose="02000603000000000000" pitchFamily="2" charset="0"/>
+                <a:cs typeface="CMU Serif" panose="02000603000000000000" pitchFamily="2" charset="0"/>
+              </a:rPr>
+              <a:t>/</a:t>
+            </a:r>
+            <a:r>
+              <a:rPr lang="de-DE" sz="1100" i="1" dirty="0">
+                <a:solidFill>
+                  <a:srgbClr val="086FBD"/>
+                </a:solidFill>
+                <a:latin typeface="CMU Serif" panose="02000603000000000000" pitchFamily="2" charset="0"/>
+                <a:ea typeface="CMU Serif" panose="02000603000000000000" pitchFamily="2" charset="0"/>
+                <a:cs typeface="CMU Serif" panose="02000603000000000000" pitchFamily="2" charset="0"/>
+              </a:rPr>
+              <a:t> </a:t>
+            </a:r>
+            <a:r>
+              <a:rPr lang="de-DE" sz="1100" i="1" dirty="0" err="1">
+                <a:solidFill>
+                  <a:srgbClr val="086FBD"/>
+                </a:solidFill>
+                <a:latin typeface="CMU Serif" panose="02000603000000000000" pitchFamily="2" charset="0"/>
+                <a:ea typeface="CMU Serif" panose="02000603000000000000" pitchFamily="2" charset="0"/>
+                <a:cs typeface="CMU Serif" panose="02000603000000000000" pitchFamily="2" charset="0"/>
+              </a:rPr>
+              <a:t>u</a:t>
+            </a:r>
+            <a:r>
+              <a:rPr lang="de-DE" sz="1100" baseline="-25000" dirty="0" err="1">
+                <a:solidFill>
+                  <a:srgbClr val="086FBD"/>
+                </a:solidFill>
+                <a:latin typeface="CMU Serif" panose="02000603000000000000" pitchFamily="2" charset="0"/>
+                <a:ea typeface="CMU Serif" panose="02000603000000000000" pitchFamily="2" charset="0"/>
+                <a:cs typeface="CMU Serif" panose="02000603000000000000" pitchFamily="2" charset="0"/>
+              </a:rPr>
+              <a:t>C</a:t>
+            </a:r>
+            <a:r>
+              <a:rPr lang="de-DE" sz="1100" dirty="0">
+                <a:solidFill>
+                  <a:srgbClr val="086FBD"/>
+                </a:solidFill>
+                <a:latin typeface="CMU Serif" panose="02000603000000000000" pitchFamily="2" charset="0"/>
+                <a:ea typeface="CMU Serif" panose="02000603000000000000" pitchFamily="2" charset="0"/>
+                <a:cs typeface="CMU Serif" panose="02000603000000000000" pitchFamily="2" charset="0"/>
+              </a:rPr>
+              <a:t>(</a:t>
+            </a:r>
+            <a:r>
+              <a:rPr lang="de-DE" sz="1100" i="1" dirty="0">
+                <a:solidFill>
+                  <a:srgbClr val="086FBD"/>
+                </a:solidFill>
+                <a:latin typeface="CMU Serif" panose="02000603000000000000" pitchFamily="2" charset="0"/>
+                <a:ea typeface="CMU Serif" panose="02000603000000000000" pitchFamily="2" charset="0"/>
+                <a:cs typeface="CMU Serif" panose="02000603000000000000" pitchFamily="2" charset="0"/>
+              </a:rPr>
+              <a:t>t</a:t>
+            </a:r>
+            <a:r>
+              <a:rPr lang="de-DE" sz="1100" dirty="0">
+                <a:solidFill>
+                  <a:srgbClr val="086FBD"/>
+                </a:solidFill>
+                <a:latin typeface="CMU Serif" panose="02000603000000000000" pitchFamily="2" charset="0"/>
+                <a:ea typeface="CMU Serif" panose="02000603000000000000" pitchFamily="2" charset="0"/>
+                <a:cs typeface="CMU Serif" panose="02000603000000000000" pitchFamily="2" charset="0"/>
+              </a:rPr>
+              <a:t>)</a:t>
+            </a:r>
+          </a:p>
+        </p:txBody>
+      </p:sp>
+      <p:cxnSp>
+        <p:nvCxnSpPr>
+          <p:cNvPr id="23" name="Gerade Verbindung mit Pfeil 22">
+            <a:extLst>
+              <a:ext uri="{FF2B5EF4-FFF2-40B4-BE49-F238E27FC236}">
+                <a16:creationId xmlns:a16="http://schemas.microsoft.com/office/drawing/2014/main" id="{1A7D2943-C89B-CC0F-E1FD-D83D9D74D6A3}"/>
+              </a:ext>
+            </a:extLst>
+          </p:cNvPr>
+          <p:cNvCxnSpPr>
+            <a:cxnSpLocks/>
+          </p:cNvCxnSpPr>
+          <p:nvPr/>
+        </p:nvCxnSpPr>
+        <p:spPr>
+          <a:xfrm flipH="1">
+            <a:off x="1470660" y="1759515"/>
+            <a:ext cx="193217" cy="0"/>
+          </a:xfrm>
+          <a:prstGeom prst="straightConnector1">
+            <a:avLst/>
+          </a:prstGeom>
+          <a:ln w="19050" cap="rnd">
+            <a:solidFill>
+              <a:srgbClr val="FF0000"/>
+            </a:solidFill>
+            <a:round/>
+            <a:tailEnd type="triangle"/>
+          </a:ln>
+        </p:spPr>
+        <p:style>
+          <a:lnRef idx="2">
+            <a:schemeClr val="accent1"/>
+          </a:lnRef>
+          <a:fillRef idx="0">
+            <a:schemeClr val="accent1"/>
+          </a:fillRef>
+          <a:effectRef idx="1">
+            <a:schemeClr val="accent1"/>
+          </a:effectRef>
+          <a:fontRef idx="minor">
+            <a:schemeClr val="tx1"/>
+          </a:fontRef>
+        </p:style>
+      </p:cxnSp>
+      <p:sp>
+        <p:nvSpPr>
+          <p:cNvPr id="25" name="Textfeld 24">
+            <a:extLst>
+              <a:ext uri="{FF2B5EF4-FFF2-40B4-BE49-F238E27FC236}">
+                <a16:creationId xmlns:a16="http://schemas.microsoft.com/office/drawing/2014/main" id="{324443C5-2C64-4659-D26A-DAFD0631BDD3}"/>
+              </a:ext>
+            </a:extLst>
+          </p:cNvPr>
+          <p:cNvSpPr txBox="1"/>
+          <p:nvPr/>
+        </p:nvSpPr>
+        <p:spPr>
+          <a:xfrm>
+            <a:off x="1132069" y="1914272"/>
+            <a:ext cx="905169" cy="261610"/>
+          </a:xfrm>
+          <a:prstGeom prst="rect">
+            <a:avLst/>
+          </a:prstGeom>
+          <a:noFill/>
+        </p:spPr>
+        <p:txBody>
+          <a:bodyPr wrap="square" rtlCol="0">
+            <a:spAutoFit/>
+          </a:bodyPr>
+          <a:lstStyle/>
+          <a:p>
+            <a:pPr algn="ctr"/>
+            <a:r>
+              <a:rPr lang="de-DE" sz="1100" i="1" dirty="0" err="1">
+                <a:solidFill>
+                  <a:srgbClr val="FF0000"/>
+                </a:solidFill>
+                <a:latin typeface="CMU Serif" panose="02000603000000000000" pitchFamily="2" charset="0"/>
+                <a:ea typeface="CMU Serif" panose="02000603000000000000" pitchFamily="2" charset="0"/>
+                <a:cs typeface="CMU Serif" panose="02000603000000000000" pitchFamily="2" charset="0"/>
+              </a:rPr>
+              <a:t>i</a:t>
+            </a:r>
+            <a:r>
+              <a:rPr lang="de-DE" sz="1100" baseline="-25000" dirty="0" err="1">
+                <a:solidFill>
+                  <a:srgbClr val="FF0000"/>
+                </a:solidFill>
+                <a:latin typeface="CMU Serif" panose="02000603000000000000" pitchFamily="2" charset="0"/>
+                <a:ea typeface="CMU Serif" panose="02000603000000000000" pitchFamily="2" charset="0"/>
+                <a:cs typeface="CMU Serif" panose="02000603000000000000" pitchFamily="2" charset="0"/>
+              </a:rPr>
+              <a:t>L</a:t>
+            </a:r>
+            <a:r>
+              <a:rPr lang="de-DE" sz="1100" dirty="0">
+                <a:solidFill>
+                  <a:srgbClr val="FF0000"/>
+                </a:solidFill>
+                <a:latin typeface="CMU Serif" panose="02000603000000000000" pitchFamily="2" charset="0"/>
+                <a:ea typeface="CMU Serif" panose="02000603000000000000" pitchFamily="2" charset="0"/>
+                <a:cs typeface="CMU Serif" panose="02000603000000000000" pitchFamily="2" charset="0"/>
+              </a:rPr>
+              <a:t>(</a:t>
+            </a:r>
+            <a:r>
+              <a:rPr lang="de-DE" sz="1100" i="1" dirty="0">
+                <a:solidFill>
+                  <a:srgbClr val="FF0000"/>
+                </a:solidFill>
+                <a:latin typeface="CMU Serif" panose="02000603000000000000" pitchFamily="2" charset="0"/>
+                <a:ea typeface="CMU Serif" panose="02000603000000000000" pitchFamily="2" charset="0"/>
+                <a:cs typeface="CMU Serif" panose="02000603000000000000" pitchFamily="2" charset="0"/>
+              </a:rPr>
+              <a:t>t</a:t>
+            </a:r>
+            <a:r>
+              <a:rPr lang="de-DE" sz="1100" dirty="0">
+                <a:solidFill>
+                  <a:srgbClr val="FF0000"/>
+                </a:solidFill>
+                <a:latin typeface="CMU Serif" panose="02000603000000000000" pitchFamily="2" charset="0"/>
+                <a:ea typeface="CMU Serif" panose="02000603000000000000" pitchFamily="2" charset="0"/>
+                <a:cs typeface="CMU Serif" panose="02000603000000000000" pitchFamily="2" charset="0"/>
+              </a:rPr>
+              <a:t>)</a:t>
+            </a:r>
+            <a:r>
+              <a:rPr lang="de-DE" sz="1100" i="1" dirty="0">
+                <a:solidFill>
+                  <a:srgbClr val="FF0000"/>
+                </a:solidFill>
+                <a:latin typeface="CMU Serif" panose="02000603000000000000" pitchFamily="2" charset="0"/>
+                <a:ea typeface="CMU Serif" panose="02000603000000000000" pitchFamily="2" charset="0"/>
+                <a:cs typeface="CMU Serif" panose="02000603000000000000" pitchFamily="2" charset="0"/>
+              </a:rPr>
+              <a:t> </a:t>
+            </a:r>
+            <a:r>
+              <a:rPr lang="de-DE" sz="1100" dirty="0">
+                <a:solidFill>
+                  <a:srgbClr val="FF0000"/>
+                </a:solidFill>
+                <a:latin typeface="CMU Serif" panose="02000603000000000000" pitchFamily="2" charset="0"/>
+                <a:ea typeface="CMU Serif" panose="02000603000000000000" pitchFamily="2" charset="0"/>
+                <a:cs typeface="CMU Serif" panose="02000603000000000000" pitchFamily="2" charset="0"/>
+              </a:rPr>
+              <a:t>/</a:t>
+            </a:r>
+            <a:r>
+              <a:rPr lang="de-DE" sz="1100" i="1" dirty="0">
+                <a:solidFill>
+                  <a:srgbClr val="FF0000"/>
+                </a:solidFill>
+                <a:latin typeface="CMU Serif" panose="02000603000000000000" pitchFamily="2" charset="0"/>
+                <a:ea typeface="CMU Serif" panose="02000603000000000000" pitchFamily="2" charset="0"/>
+                <a:cs typeface="CMU Serif" panose="02000603000000000000" pitchFamily="2" charset="0"/>
+              </a:rPr>
+              <a:t> </a:t>
+            </a:r>
+            <a:r>
+              <a:rPr lang="de-DE" sz="1100" i="1" dirty="0" err="1">
+                <a:solidFill>
+                  <a:srgbClr val="FF0000"/>
+                </a:solidFill>
+                <a:latin typeface="CMU Serif" panose="02000603000000000000" pitchFamily="2" charset="0"/>
+                <a:ea typeface="CMU Serif" panose="02000603000000000000" pitchFamily="2" charset="0"/>
+                <a:cs typeface="CMU Serif" panose="02000603000000000000" pitchFamily="2" charset="0"/>
+              </a:rPr>
+              <a:t>i</a:t>
+            </a:r>
+            <a:r>
+              <a:rPr lang="de-DE" sz="1100" baseline="-25000" dirty="0" err="1">
+                <a:solidFill>
+                  <a:srgbClr val="FF0000"/>
+                </a:solidFill>
+                <a:latin typeface="CMU Serif" panose="02000603000000000000" pitchFamily="2" charset="0"/>
+                <a:ea typeface="CMU Serif" panose="02000603000000000000" pitchFamily="2" charset="0"/>
+                <a:cs typeface="CMU Serif" panose="02000603000000000000" pitchFamily="2" charset="0"/>
+              </a:rPr>
+              <a:t>C</a:t>
+            </a:r>
+            <a:r>
+              <a:rPr lang="de-DE" sz="1100" dirty="0">
+                <a:solidFill>
+                  <a:srgbClr val="FF0000"/>
+                </a:solidFill>
+                <a:latin typeface="CMU Serif" panose="02000603000000000000" pitchFamily="2" charset="0"/>
+                <a:ea typeface="CMU Serif" panose="02000603000000000000" pitchFamily="2" charset="0"/>
+                <a:cs typeface="CMU Serif" panose="02000603000000000000" pitchFamily="2" charset="0"/>
+              </a:rPr>
+              <a:t>(</a:t>
+            </a:r>
+            <a:r>
+              <a:rPr lang="de-DE" sz="1100" i="1" dirty="0">
+                <a:solidFill>
+                  <a:srgbClr val="FF0000"/>
+                </a:solidFill>
+                <a:latin typeface="CMU Serif" panose="02000603000000000000" pitchFamily="2" charset="0"/>
+                <a:ea typeface="CMU Serif" panose="02000603000000000000" pitchFamily="2" charset="0"/>
+                <a:cs typeface="CMU Serif" panose="02000603000000000000" pitchFamily="2" charset="0"/>
+              </a:rPr>
+              <a:t>t</a:t>
+            </a:r>
+            <a:r>
+              <a:rPr lang="de-DE" sz="1100" dirty="0">
+                <a:solidFill>
+                  <a:srgbClr val="FF0000"/>
+                </a:solidFill>
+                <a:latin typeface="CMU Serif" panose="02000603000000000000" pitchFamily="2" charset="0"/>
+                <a:ea typeface="CMU Serif" panose="02000603000000000000" pitchFamily="2" charset="0"/>
+                <a:cs typeface="CMU Serif" panose="02000603000000000000" pitchFamily="2" charset="0"/>
+              </a:rPr>
+              <a:t>)</a:t>
+            </a:r>
+          </a:p>
+        </p:txBody>
+      </p:sp>
+    </p:spTree>
+    <p:extLst>
+      <p:ext uri="{BB962C8B-B14F-4D97-AF65-F5344CB8AC3E}">
+        <p14:creationId xmlns:p14="http://schemas.microsoft.com/office/powerpoint/2010/main" val="1472471268"/>
       </p:ext>
     </p:extLst>
   </p:cSld>

</xml_diff>